<commit_message>
feat: new template + slide layout by photo count
- Replace Termplate.pptx with Termplate Sell-Out REV.pptx (8-slide structure)
- Slide 0: title, Slide 1: chain intro, Slides 2-7: 1-6 photo layouts
- New generate_pptx: copies title, then per chain adds intro + store slides
  using the correct layout for each store's photo count (1–6 photos)
- New update_store_slide: handles groups (slides 4-6), collects absolute
  picture slot positions via group transform, removes groups/pics, inserts
  real photos at correct absolute positions
- New make_chain_divider: copies chain-intro slide (idx 1) and fills NOMBRE CADENA
- New helpers: _collect_pic_slots (incl. group coordinate math), _remove_all_pics
</commit_message>
<xml_diff>
--- a/Termplate.pptx
+++ b/Termplate.pptx
@@ -5,30 +5,32 @@
     <p:sldMasterId id="2147483657" r:id="rId1"/>
   </p:sldMasterIdLst>
   <p:notesMasterIdLst>
-    <p:notesMasterId r:id="rId8"/>
+    <p:notesMasterId r:id="rId10"/>
   </p:notesMasterIdLst>
   <p:sldIdLst>
     <p:sldId id="377" r:id="rId2"/>
-    <p:sldId id="391" r:id="rId3"/>
-    <p:sldId id="392" r:id="rId4"/>
+    <p:sldId id="400" r:id="rId3"/>
+    <p:sldId id="391" r:id="rId4"/>
     <p:sldId id="395" r:id="rId5"/>
-    <p:sldId id="398" r:id="rId6"/>
-    <p:sldId id="399" r:id="rId7"/>
+    <p:sldId id="402" r:id="rId6"/>
+    <p:sldId id="403" r:id="rId7"/>
+    <p:sldId id="404" r:id="rId8"/>
+    <p:sldId id="405" r:id="rId9"/>
   </p:sldIdLst>
   <p:sldSz cx="12192000" cy="6858000"/>
   <p:notesSz cx="6858000" cy="9144000"/>
   <p:embeddedFontLst>
     <p:embeddedFont>
       <p:font typeface="Arial Black" panose="020B0604020202020204" pitchFamily="34" charset="0"/>
-      <p:regular r:id="rId9"/>
-      <p:bold r:id="rId10"/>
+      <p:regular r:id="rId11"/>
+      <p:bold r:id="rId12"/>
     </p:embeddedFont>
     <p:embeddedFont>
       <p:font typeface="Montserrat SemiBold" panose="00000700000000000000" pitchFamily="2" charset="77"/>
-      <p:regular r:id="rId11"/>
-      <p:bold r:id="rId12"/>
-      <p:italic r:id="rId13"/>
-      <p:boldItalic r:id="rId14"/>
+      <p:regular r:id="rId13"/>
+      <p:bold r:id="rId14"/>
+      <p:italic r:id="rId15"/>
+      <p:boldItalic r:id="rId16"/>
     </p:embeddedFont>
   </p:embeddedFontLst>
   <p:defaultTextStyle>
@@ -974,128 +976,6 @@
   <p:cSld>
     <p:spTree>
       <p:nvGrpSpPr>
-        <p:cNvPr id="1" name="Shape 36"/>
-        <p:cNvGrpSpPr/>
-        <p:nvPr/>
-      </p:nvGrpSpPr>
-      <p:grpSpPr>
-        <a:xfrm>
-          <a:off x="0" y="0"/>
-          <a:ext cx="0" cy="0"/>
-          <a:chOff x="0" y="0"/>
-          <a:chExt cx="0" cy="0"/>
-        </a:xfrm>
-      </p:grpSpPr>
-      <p:sp>
-        <p:nvSpPr>
-          <p:cNvPr id="37" name="Google Shape;37;g3d777708fde_0_57:notes"/>
-          <p:cNvSpPr txBox="1">
-            <a:spLocks noGrp="1"/>
-          </p:cNvSpPr>
-          <p:nvPr>
-            <p:ph type="body" idx="1"/>
-          </p:nvPr>
-        </p:nvSpPr>
-        <p:spPr>
-          <a:xfrm>
-            <a:off x="685800" y="4343400"/>
-            <a:ext cx="5486400" cy="4114800"/>
-          </a:xfrm>
-          <a:prstGeom prst="rect">
-            <a:avLst/>
-          </a:prstGeom>
-          <a:noFill/>
-          <a:ln>
-            <a:noFill/>
-          </a:ln>
-        </p:spPr>
-        <p:txBody>
-          <a:bodyPr spcFirstLastPara="1" wrap="square" lIns="91425" tIns="91425" rIns="91425" bIns="91425" anchor="t" anchorCtr="0">
-            <a:noAutofit/>
-          </a:bodyPr>
-          <a:lstStyle/>
-          <a:p>
-            <a:pPr marL="0" lvl="0" indent="0" algn="l" rtl="0">
-              <a:lnSpc>
-                <a:spcPct val="100000"/>
-              </a:lnSpc>
-              <a:spcBef>
-                <a:spcPts val="0"/>
-              </a:spcBef>
-              <a:spcAft>
-                <a:spcPts val="0"/>
-              </a:spcAft>
-              <a:buSzPts val="1100"/>
-              <a:buNone/>
-            </a:pPr>
-            <a:endParaRPr/>
-          </a:p>
-        </p:txBody>
-      </p:sp>
-      <p:sp>
-        <p:nvSpPr>
-          <p:cNvPr id="38" name="Google Shape;38;g3d777708fde_0_57:notes"/>
-          <p:cNvSpPr>
-            <a:spLocks noGrp="1" noRot="1" noChangeAspect="1"/>
-          </p:cNvSpPr>
-          <p:nvPr>
-            <p:ph type="sldImg" idx="2"/>
-          </p:nvPr>
-        </p:nvSpPr>
-        <p:spPr>
-          <a:xfrm>
-            <a:off x="381000" y="685800"/>
-            <a:ext cx="6096000" cy="3429000"/>
-          </a:xfrm>
-          <a:custGeom>
-            <a:avLst/>
-            <a:gdLst/>
-            <a:ahLst/>
-            <a:cxnLst/>
-            <a:rect l="l" t="t" r="r" b="b"/>
-            <a:pathLst>
-              <a:path w="120000" h="120000" extrusionOk="0">
-                <a:moveTo>
-                  <a:pt x="0" y="0"/>
-                </a:moveTo>
-                <a:lnTo>
-                  <a:pt x="120000" y="0"/>
-                </a:lnTo>
-                <a:lnTo>
-                  <a:pt x="120000" y="120000"/>
-                </a:lnTo>
-                <a:lnTo>
-                  <a:pt x="0" y="120000"/>
-                </a:lnTo>
-                <a:close/>
-              </a:path>
-            </a:pathLst>
-          </a:custGeom>
-          <a:noFill/>
-          <a:ln w="9525" cap="flat" cmpd="sng">
-            <a:solidFill>
-              <a:srgbClr val="000000"/>
-            </a:solidFill>
-            <a:prstDash val="solid"/>
-            <a:round/>
-            <a:headEnd type="none" w="sm" len="sm"/>
-            <a:tailEnd type="none" w="sm" len="sm"/>
-          </a:ln>
-        </p:spPr>
-      </p:sp>
-    </p:spTree>
-  </p:cSld>
-  <p:clrMapOvr>
-    <a:masterClrMapping/>
-  </p:clrMapOvr>
-</p:notes>
-</file>
-
-<file path=ppt/notesSlides/notesSlide3.xml><?xml version="1.0" encoding="utf-8"?>
-<p:notes xmlns:a="http://schemas.openxmlformats.org/drawingml/2006/main" xmlns:r="http://schemas.openxmlformats.org/officeDocument/2006/relationships" xmlns:p="http://schemas.openxmlformats.org/presentationml/2006/main" showMasterSp="0" showMasterPhAnim="0">
-  <p:cSld>
-    <p:spTree>
-      <p:nvGrpSpPr>
         <p:cNvPr id="1" name="Shape 135"/>
         <p:cNvGrpSpPr/>
         <p:nvPr/>
@@ -1213,12 +1093,18 @@
 </p:notes>
 </file>
 
-<file path=ppt/notesSlides/notesSlide4.xml><?xml version="1.0" encoding="utf-8"?>
+<file path=ppt/notesSlides/notesSlide3.xml><?xml version="1.0" encoding="utf-8"?>
 <p:notes xmlns:a="http://schemas.openxmlformats.org/drawingml/2006/main" xmlns:r="http://schemas.openxmlformats.org/officeDocument/2006/relationships" xmlns:p="http://schemas.openxmlformats.org/presentationml/2006/main" showMasterSp="0" showMasterPhAnim="0">
   <p:cSld>
     <p:spTree>
       <p:nvGrpSpPr>
-        <p:cNvPr id="1" name="Shape 295"/>
+        <p:cNvPr id="1" name="Shape 25">
+          <a:extLst>
+            <a:ext uri="{FF2B5EF4-FFF2-40B4-BE49-F238E27FC236}">
+              <a16:creationId xmlns:a16="http://schemas.microsoft.com/office/drawing/2014/main" id="{642B6F40-F0AD-BA10-5C37-09B35FBD69C3}"/>
+            </a:ext>
+          </a:extLst>
+        </p:cNvPr>
         <p:cNvGrpSpPr/>
         <p:nvPr/>
       </p:nvGrpSpPr>
@@ -1232,7 +1118,13 @@
       </p:grpSpPr>
       <p:sp>
         <p:nvSpPr>
-          <p:cNvPr id="296" name="Google Shape;296;g395f9ca54f4_0_65:notes"/>
+          <p:cNvPr id="26" name="Google Shape;26;g3ceeff82bb2_0_39:notes">
+            <a:extLst>
+              <a:ext uri="{FF2B5EF4-FFF2-40B4-BE49-F238E27FC236}">
+                <a16:creationId xmlns:a16="http://schemas.microsoft.com/office/drawing/2014/main" id="{D2533165-E7DB-224E-BA93-12B4A3705748}"/>
+              </a:ext>
+            </a:extLst>
+          </p:cNvPr>
           <p:cNvSpPr txBox="1">
             <a:spLocks noGrp="1"/>
           </p:cNvSpPr>
@@ -1278,7 +1170,13 @@
       </p:sp>
       <p:sp>
         <p:nvSpPr>
-          <p:cNvPr id="297" name="Google Shape;297;g395f9ca54f4_0_65:notes"/>
+          <p:cNvPr id="27" name="Google Shape;27;g3ceeff82bb2_0_39:notes">
+            <a:extLst>
+              <a:ext uri="{FF2B5EF4-FFF2-40B4-BE49-F238E27FC236}">
+                <a16:creationId xmlns:a16="http://schemas.microsoft.com/office/drawing/2014/main" id="{CF312A0B-E2CD-B0F0-53F3-2BB396805690}"/>
+              </a:ext>
+            </a:extLst>
+          </p:cNvPr>
           <p:cNvSpPr>
             <a:spLocks noGrp="1" noRot="1" noChangeAspect="1"/>
           </p:cNvSpPr>
@@ -1328,6 +1226,11 @@
         </p:spPr>
       </p:sp>
     </p:spTree>
+    <p:extLst>
+      <p:ext uri="{BB962C8B-B14F-4D97-AF65-F5344CB8AC3E}">
+        <p14:creationId xmlns:p14="http://schemas.microsoft.com/office/powerpoint/2010/main" val="3288849059"/>
+      </p:ext>
+    </p:extLst>
   </p:cSld>
   <p:clrMapOvr>
     <a:masterClrMapping/>
@@ -1335,12 +1238,18 @@
 </p:notes>
 </file>
 
-<file path=ppt/notesSlides/notesSlide5.xml><?xml version="1.0" encoding="utf-8"?>
+<file path=ppt/notesSlides/notesSlide4.xml><?xml version="1.0" encoding="utf-8"?>
 <p:notes xmlns:a="http://schemas.openxmlformats.org/drawingml/2006/main" xmlns:r="http://schemas.openxmlformats.org/officeDocument/2006/relationships" xmlns:p="http://schemas.openxmlformats.org/presentationml/2006/main" showMasterSp="0" showMasterPhAnim="0">
   <p:cSld>
     <p:spTree>
       <p:nvGrpSpPr>
-        <p:cNvPr id="1" name="Shape 306"/>
+        <p:cNvPr id="1" name="Shape 25">
+          <a:extLst>
+            <a:ext uri="{FF2B5EF4-FFF2-40B4-BE49-F238E27FC236}">
+              <a16:creationId xmlns:a16="http://schemas.microsoft.com/office/drawing/2014/main" id="{D6270554-290F-A063-C7C3-DEE875707BA8}"/>
+            </a:ext>
+          </a:extLst>
+        </p:cNvPr>
         <p:cNvGrpSpPr/>
         <p:nvPr/>
       </p:nvGrpSpPr>
@@ -1354,7 +1263,13 @@
       </p:grpSpPr>
       <p:sp>
         <p:nvSpPr>
-          <p:cNvPr id="307" name="Google Shape;307;g3ceeff82bb2_0_1:notes"/>
+          <p:cNvPr id="26" name="Google Shape;26;g3ceeff82bb2_0_39:notes">
+            <a:extLst>
+              <a:ext uri="{FF2B5EF4-FFF2-40B4-BE49-F238E27FC236}">
+                <a16:creationId xmlns:a16="http://schemas.microsoft.com/office/drawing/2014/main" id="{50D6B706-28A5-8A8C-A0C3-CBEBA2523F7A}"/>
+              </a:ext>
+            </a:extLst>
+          </p:cNvPr>
           <p:cNvSpPr txBox="1">
             <a:spLocks noGrp="1"/>
           </p:cNvSpPr>
@@ -1400,7 +1315,13 @@
       </p:sp>
       <p:sp>
         <p:nvSpPr>
-          <p:cNvPr id="308" name="Google Shape;308;g3ceeff82bb2_0_1:notes"/>
+          <p:cNvPr id="27" name="Google Shape;27;g3ceeff82bb2_0_39:notes">
+            <a:extLst>
+              <a:ext uri="{FF2B5EF4-FFF2-40B4-BE49-F238E27FC236}">
+                <a16:creationId xmlns:a16="http://schemas.microsoft.com/office/drawing/2014/main" id="{04F7649B-60AC-F401-D646-5604EBF3588A}"/>
+              </a:ext>
+            </a:extLst>
+          </p:cNvPr>
           <p:cNvSpPr>
             <a:spLocks noGrp="1" noRot="1" noChangeAspect="1"/>
           </p:cNvSpPr>
@@ -1450,6 +1371,301 @@
         </p:spPr>
       </p:sp>
     </p:spTree>
+    <p:extLst>
+      <p:ext uri="{BB962C8B-B14F-4D97-AF65-F5344CB8AC3E}">
+        <p14:creationId xmlns:p14="http://schemas.microsoft.com/office/powerpoint/2010/main" val="1376557913"/>
+      </p:ext>
+    </p:extLst>
+  </p:cSld>
+  <p:clrMapOvr>
+    <a:masterClrMapping/>
+  </p:clrMapOvr>
+</p:notes>
+</file>
+
+<file path=ppt/notesSlides/notesSlide5.xml><?xml version="1.0" encoding="utf-8"?>
+<p:notes xmlns:a="http://schemas.openxmlformats.org/drawingml/2006/main" xmlns:r="http://schemas.openxmlformats.org/officeDocument/2006/relationships" xmlns:p="http://schemas.openxmlformats.org/presentationml/2006/main" showMasterSp="0" showMasterPhAnim="0">
+  <p:cSld>
+    <p:spTree>
+      <p:nvGrpSpPr>
+        <p:cNvPr id="1" name="Shape 25">
+          <a:extLst>
+            <a:ext uri="{FF2B5EF4-FFF2-40B4-BE49-F238E27FC236}">
+              <a16:creationId xmlns:a16="http://schemas.microsoft.com/office/drawing/2014/main" id="{E4F6E50B-0BFF-208B-6A71-6B559A9D83BA}"/>
+            </a:ext>
+          </a:extLst>
+        </p:cNvPr>
+        <p:cNvGrpSpPr/>
+        <p:nvPr/>
+      </p:nvGrpSpPr>
+      <p:grpSpPr>
+        <a:xfrm>
+          <a:off x="0" y="0"/>
+          <a:ext cx="0" cy="0"/>
+          <a:chOff x="0" y="0"/>
+          <a:chExt cx="0" cy="0"/>
+        </a:xfrm>
+      </p:grpSpPr>
+      <p:sp>
+        <p:nvSpPr>
+          <p:cNvPr id="26" name="Google Shape;26;g3ceeff82bb2_0_39:notes">
+            <a:extLst>
+              <a:ext uri="{FF2B5EF4-FFF2-40B4-BE49-F238E27FC236}">
+                <a16:creationId xmlns:a16="http://schemas.microsoft.com/office/drawing/2014/main" id="{E485E877-6ABA-588C-C951-1CA2FFDBD0F1}"/>
+              </a:ext>
+            </a:extLst>
+          </p:cNvPr>
+          <p:cNvSpPr txBox="1">
+            <a:spLocks noGrp="1"/>
+          </p:cNvSpPr>
+          <p:nvPr>
+            <p:ph type="body" idx="1"/>
+          </p:nvPr>
+        </p:nvSpPr>
+        <p:spPr>
+          <a:xfrm>
+            <a:off x="685800" y="4343400"/>
+            <a:ext cx="5486400" cy="4114800"/>
+          </a:xfrm>
+          <a:prstGeom prst="rect">
+            <a:avLst/>
+          </a:prstGeom>
+          <a:noFill/>
+          <a:ln>
+            <a:noFill/>
+          </a:ln>
+        </p:spPr>
+        <p:txBody>
+          <a:bodyPr spcFirstLastPara="1" wrap="square" lIns="91425" tIns="91425" rIns="91425" bIns="91425" anchor="t" anchorCtr="0">
+            <a:noAutofit/>
+          </a:bodyPr>
+          <a:lstStyle/>
+          <a:p>
+            <a:pPr marL="0" lvl="0" indent="0" algn="l" rtl="0">
+              <a:lnSpc>
+                <a:spcPct val="100000"/>
+              </a:lnSpc>
+              <a:spcBef>
+                <a:spcPts val="0"/>
+              </a:spcBef>
+              <a:spcAft>
+                <a:spcPts val="0"/>
+              </a:spcAft>
+              <a:buSzPts val="1100"/>
+              <a:buNone/>
+            </a:pPr>
+            <a:endParaRPr/>
+          </a:p>
+        </p:txBody>
+      </p:sp>
+      <p:sp>
+        <p:nvSpPr>
+          <p:cNvPr id="27" name="Google Shape;27;g3ceeff82bb2_0_39:notes">
+            <a:extLst>
+              <a:ext uri="{FF2B5EF4-FFF2-40B4-BE49-F238E27FC236}">
+                <a16:creationId xmlns:a16="http://schemas.microsoft.com/office/drawing/2014/main" id="{E841703B-1E55-44D7-EA9B-6DF31F06AC11}"/>
+              </a:ext>
+            </a:extLst>
+          </p:cNvPr>
+          <p:cNvSpPr>
+            <a:spLocks noGrp="1" noRot="1" noChangeAspect="1"/>
+          </p:cNvSpPr>
+          <p:nvPr>
+            <p:ph type="sldImg" idx="2"/>
+          </p:nvPr>
+        </p:nvSpPr>
+        <p:spPr>
+          <a:xfrm>
+            <a:off x="381000" y="685800"/>
+            <a:ext cx="6096000" cy="3429000"/>
+          </a:xfrm>
+          <a:custGeom>
+            <a:avLst/>
+            <a:gdLst/>
+            <a:ahLst/>
+            <a:cxnLst/>
+            <a:rect l="l" t="t" r="r" b="b"/>
+            <a:pathLst>
+              <a:path w="120000" h="120000" extrusionOk="0">
+                <a:moveTo>
+                  <a:pt x="0" y="0"/>
+                </a:moveTo>
+                <a:lnTo>
+                  <a:pt x="120000" y="0"/>
+                </a:lnTo>
+                <a:lnTo>
+                  <a:pt x="120000" y="120000"/>
+                </a:lnTo>
+                <a:lnTo>
+                  <a:pt x="0" y="120000"/>
+                </a:lnTo>
+                <a:close/>
+              </a:path>
+            </a:pathLst>
+          </a:custGeom>
+          <a:noFill/>
+          <a:ln w="9525" cap="flat" cmpd="sng">
+            <a:solidFill>
+              <a:srgbClr val="000000"/>
+            </a:solidFill>
+            <a:prstDash val="solid"/>
+            <a:round/>
+            <a:headEnd type="none" w="sm" len="sm"/>
+            <a:tailEnd type="none" w="sm" len="sm"/>
+          </a:ln>
+        </p:spPr>
+      </p:sp>
+    </p:spTree>
+    <p:extLst>
+      <p:ext uri="{BB962C8B-B14F-4D97-AF65-F5344CB8AC3E}">
+        <p14:creationId xmlns:p14="http://schemas.microsoft.com/office/powerpoint/2010/main" val="4127889005"/>
+      </p:ext>
+    </p:extLst>
+  </p:cSld>
+  <p:clrMapOvr>
+    <a:masterClrMapping/>
+  </p:clrMapOvr>
+</p:notes>
+</file>
+
+<file path=ppt/notesSlides/notesSlide6.xml><?xml version="1.0" encoding="utf-8"?>
+<p:notes xmlns:a="http://schemas.openxmlformats.org/drawingml/2006/main" xmlns:r="http://schemas.openxmlformats.org/officeDocument/2006/relationships" xmlns:p="http://schemas.openxmlformats.org/presentationml/2006/main" showMasterSp="0" showMasterPhAnim="0">
+  <p:cSld>
+    <p:spTree>
+      <p:nvGrpSpPr>
+        <p:cNvPr id="1" name="Shape 25">
+          <a:extLst>
+            <a:ext uri="{FF2B5EF4-FFF2-40B4-BE49-F238E27FC236}">
+              <a16:creationId xmlns:a16="http://schemas.microsoft.com/office/drawing/2014/main" id="{A03FF3B3-FF87-5874-FD2D-332E33469E29}"/>
+            </a:ext>
+          </a:extLst>
+        </p:cNvPr>
+        <p:cNvGrpSpPr/>
+        <p:nvPr/>
+      </p:nvGrpSpPr>
+      <p:grpSpPr>
+        <a:xfrm>
+          <a:off x="0" y="0"/>
+          <a:ext cx="0" cy="0"/>
+          <a:chOff x="0" y="0"/>
+          <a:chExt cx="0" cy="0"/>
+        </a:xfrm>
+      </p:grpSpPr>
+      <p:sp>
+        <p:nvSpPr>
+          <p:cNvPr id="26" name="Google Shape;26;g3ceeff82bb2_0_39:notes">
+            <a:extLst>
+              <a:ext uri="{FF2B5EF4-FFF2-40B4-BE49-F238E27FC236}">
+                <a16:creationId xmlns:a16="http://schemas.microsoft.com/office/drawing/2014/main" id="{A6A5AEE3-1CF1-E7D4-A3ED-917A05937AAA}"/>
+              </a:ext>
+            </a:extLst>
+          </p:cNvPr>
+          <p:cNvSpPr txBox="1">
+            <a:spLocks noGrp="1"/>
+          </p:cNvSpPr>
+          <p:nvPr>
+            <p:ph type="body" idx="1"/>
+          </p:nvPr>
+        </p:nvSpPr>
+        <p:spPr>
+          <a:xfrm>
+            <a:off x="685800" y="4343400"/>
+            <a:ext cx="5486400" cy="4114800"/>
+          </a:xfrm>
+          <a:prstGeom prst="rect">
+            <a:avLst/>
+          </a:prstGeom>
+          <a:noFill/>
+          <a:ln>
+            <a:noFill/>
+          </a:ln>
+        </p:spPr>
+        <p:txBody>
+          <a:bodyPr spcFirstLastPara="1" wrap="square" lIns="91425" tIns="91425" rIns="91425" bIns="91425" anchor="t" anchorCtr="0">
+            <a:noAutofit/>
+          </a:bodyPr>
+          <a:lstStyle/>
+          <a:p>
+            <a:pPr marL="0" lvl="0" indent="0" algn="l" rtl="0">
+              <a:lnSpc>
+                <a:spcPct val="100000"/>
+              </a:lnSpc>
+              <a:spcBef>
+                <a:spcPts val="0"/>
+              </a:spcBef>
+              <a:spcAft>
+                <a:spcPts val="0"/>
+              </a:spcAft>
+              <a:buSzPts val="1100"/>
+              <a:buNone/>
+            </a:pPr>
+            <a:endParaRPr/>
+          </a:p>
+        </p:txBody>
+      </p:sp>
+      <p:sp>
+        <p:nvSpPr>
+          <p:cNvPr id="27" name="Google Shape;27;g3ceeff82bb2_0_39:notes">
+            <a:extLst>
+              <a:ext uri="{FF2B5EF4-FFF2-40B4-BE49-F238E27FC236}">
+                <a16:creationId xmlns:a16="http://schemas.microsoft.com/office/drawing/2014/main" id="{1A635978-23E4-AE4B-0C63-B9DBC24418D5}"/>
+              </a:ext>
+            </a:extLst>
+          </p:cNvPr>
+          <p:cNvSpPr>
+            <a:spLocks noGrp="1" noRot="1" noChangeAspect="1"/>
+          </p:cNvSpPr>
+          <p:nvPr>
+            <p:ph type="sldImg" idx="2"/>
+          </p:nvPr>
+        </p:nvSpPr>
+        <p:spPr>
+          <a:xfrm>
+            <a:off x="381000" y="685800"/>
+            <a:ext cx="6096000" cy="3429000"/>
+          </a:xfrm>
+          <a:custGeom>
+            <a:avLst/>
+            <a:gdLst/>
+            <a:ahLst/>
+            <a:cxnLst/>
+            <a:rect l="l" t="t" r="r" b="b"/>
+            <a:pathLst>
+              <a:path w="120000" h="120000" extrusionOk="0">
+                <a:moveTo>
+                  <a:pt x="0" y="0"/>
+                </a:moveTo>
+                <a:lnTo>
+                  <a:pt x="120000" y="0"/>
+                </a:lnTo>
+                <a:lnTo>
+                  <a:pt x="120000" y="120000"/>
+                </a:lnTo>
+                <a:lnTo>
+                  <a:pt x="0" y="120000"/>
+                </a:lnTo>
+                <a:close/>
+              </a:path>
+            </a:pathLst>
+          </a:custGeom>
+          <a:noFill/>
+          <a:ln w="9525" cap="flat" cmpd="sng">
+            <a:solidFill>
+              <a:srgbClr val="000000"/>
+            </a:solidFill>
+            <a:prstDash val="solid"/>
+            <a:round/>
+            <a:headEnd type="none" w="sm" len="sm"/>
+            <a:tailEnd type="none" w="sm" len="sm"/>
+          </a:ln>
+        </p:spPr>
+      </p:sp>
+    </p:spTree>
+    <p:extLst>
+      <p:ext uri="{BB962C8B-B14F-4D97-AF65-F5344CB8AC3E}">
+        <p14:creationId xmlns:p14="http://schemas.microsoft.com/office/powerpoint/2010/main" val="43816130"/>
+      </p:ext>
+    </p:extLst>
   </p:cSld>
   <p:clrMapOvr>
     <a:masterClrMapping/>
@@ -1499,42 +1715,6 @@
           <a:chExt cx="0" cy="0"/>
         </a:xfrm>
       </p:grpSpPr>
-      <p:pic>
-        <p:nvPicPr>
-          <p:cNvPr id="6" name="Gráfico 5">
-            <a:extLst>
-              <a:ext uri="{FF2B5EF4-FFF2-40B4-BE49-F238E27FC236}">
-                <a16:creationId xmlns:a16="http://schemas.microsoft.com/office/drawing/2014/main" id="{B917E286-44D4-A4A0-00A4-2C4A146F5D79}"/>
-              </a:ext>
-            </a:extLst>
-          </p:cNvPr>
-          <p:cNvPicPr>
-            <a:picLocks noChangeAspect="1"/>
-          </p:cNvPicPr>
-          <p:nvPr userDrawn="1"/>
-        </p:nvPicPr>
-        <p:blipFill>
-          <a:blip>
-            <a:extLst>
-              <a:ext uri="{96DAC541-7B7A-43D3-8B79-37D633B846F1}">
-                <asvg:svgBlip xmlns:asvg="http://schemas.microsoft.com/office/drawing/2016/SVG/main" r:embed="rId2"/>
-              </a:ext>
-            </a:extLst>
-          </a:blip>
-          <a:stretch>
-            <a:fillRect/>
-          </a:stretch>
-        </p:blipFill>
-        <p:spPr>
-          <a:xfrm>
-            <a:off x="9833956" y="6130290"/>
-            <a:ext cx="2069176" cy="557086"/>
-          </a:xfrm>
-          <a:prstGeom prst="rect">
-            <a:avLst/>
-          </a:prstGeom>
-        </p:spPr>
-      </p:pic>
     </p:spTree>
     <p:extLst>
       <p:ext uri="{BB962C8B-B14F-4D97-AF65-F5344CB8AC3E}">
@@ -2393,6 +2573,119 @@
   <p:cSld>
     <p:spTree>
       <p:nvGrpSpPr>
+        <p:cNvPr id="1" name="">
+          <a:extLst>
+            <a:ext uri="{FF2B5EF4-FFF2-40B4-BE49-F238E27FC236}">
+              <a16:creationId xmlns:a16="http://schemas.microsoft.com/office/drawing/2014/main" id="{34E01EB0-1B4E-64C6-ABAC-EDC7DE56F354}"/>
+            </a:ext>
+          </a:extLst>
+        </p:cNvPr>
+        <p:cNvGrpSpPr/>
+        <p:nvPr/>
+      </p:nvGrpSpPr>
+      <p:grpSpPr>
+        <a:xfrm>
+          <a:off x="0" y="0"/>
+          <a:ext cx="0" cy="0"/>
+          <a:chOff x="0" y="0"/>
+          <a:chExt cx="0" cy="0"/>
+        </a:xfrm>
+      </p:grpSpPr>
+      <p:sp>
+        <p:nvSpPr>
+          <p:cNvPr id="12" name="CuadroTexto 11">
+            <a:extLst>
+              <a:ext uri="{FF2B5EF4-FFF2-40B4-BE49-F238E27FC236}">
+                <a16:creationId xmlns:a16="http://schemas.microsoft.com/office/drawing/2014/main" id="{0E8AF996-2459-7EA7-5CEE-0AE00BE80269}"/>
+              </a:ext>
+            </a:extLst>
+          </p:cNvPr>
+          <p:cNvSpPr txBox="1"/>
+          <p:nvPr/>
+        </p:nvSpPr>
+        <p:spPr>
+          <a:xfrm>
+            <a:off x="1817958" y="4214015"/>
+            <a:ext cx="8556084" cy="646331"/>
+          </a:xfrm>
+          <a:prstGeom prst="rect">
+            <a:avLst/>
+          </a:prstGeom>
+          <a:noFill/>
+        </p:spPr>
+        <p:txBody>
+          <a:bodyPr wrap="square" rtlCol="0">
+            <a:spAutoFit/>
+          </a:bodyPr>
+          <a:lstStyle/>
+          <a:p>
+            <a:pPr algn="ctr"/>
+            <a:r>
+              <a:rPr lang="es-MX" sz="3600" dirty="0">
+                <a:solidFill>
+                  <a:schemeClr val="bg1"/>
+                </a:solidFill>
+                <a:latin typeface="Montserrat SemiBold" pitchFamily="2" charset="0"/>
+              </a:rPr>
+              <a:t>NOMBRE CADENA</a:t>
+            </a:r>
+          </a:p>
+        </p:txBody>
+      </p:sp>
+      <p:pic>
+        <p:nvPicPr>
+          <p:cNvPr id="4" name="Imagen 3" descr="Logotipo&#10;&#10;Descripción generada automáticamente">
+            <a:extLst>
+              <a:ext uri="{FF2B5EF4-FFF2-40B4-BE49-F238E27FC236}">
+                <a16:creationId xmlns:a16="http://schemas.microsoft.com/office/drawing/2014/main" id="{179D87B2-BAA1-555C-F4BD-01FF4621B4E0}"/>
+              </a:ext>
+            </a:extLst>
+          </p:cNvPr>
+          <p:cNvPicPr>
+            <a:picLocks noChangeAspect="1"/>
+          </p:cNvPicPr>
+          <p:nvPr/>
+        </p:nvPicPr>
+        <p:blipFill>
+          <a:blip r:embed="rId2" cstate="screen">
+            <a:extLst>
+              <a:ext uri="{28A0092B-C50C-407E-A947-70E740481C1C}">
+                <a14:useLocalDpi xmlns:a14="http://schemas.microsoft.com/office/drawing/2010/main"/>
+              </a:ext>
+            </a:extLst>
+          </a:blip>
+          <a:stretch>
+            <a:fillRect/>
+          </a:stretch>
+        </p:blipFill>
+        <p:spPr>
+          <a:xfrm>
+            <a:off x="2731300" y="2117797"/>
+            <a:ext cx="6729399" cy="1311203"/>
+          </a:xfrm>
+          <a:prstGeom prst="rect">
+            <a:avLst/>
+          </a:prstGeom>
+        </p:spPr>
+      </p:pic>
+    </p:spTree>
+    <p:extLst>
+      <p:ext uri="{BB962C8B-B14F-4D97-AF65-F5344CB8AC3E}">
+        <p14:creationId xmlns:p14="http://schemas.microsoft.com/office/powerpoint/2010/main" val="2809198233"/>
+      </p:ext>
+    </p:extLst>
+  </p:cSld>
+  <p:clrMapOvr>
+    <a:masterClrMapping/>
+  </p:clrMapOvr>
+</p:sld>
+</file>
+
+<file path=ppt/slides/slide3.xml><?xml version="1.0" encoding="utf-8"?>
+<p:sld xmlns:a="http://schemas.openxmlformats.org/drawingml/2006/main" xmlns:r="http://schemas.openxmlformats.org/officeDocument/2006/relationships" xmlns:p="http://schemas.openxmlformats.org/presentationml/2006/main">
+  <p:cSld>
+    <p:spTree>
+      <p:nvGrpSpPr>
         <p:cNvPr id="1" name="Shape 28"/>
         <p:cNvGrpSpPr/>
         <p:nvPr/>
@@ -2457,55 +2750,7 @@
                 <a:cs typeface="Arial Black"/>
                 <a:sym typeface="Arial Black"/>
               </a:rPr>
-              <a:t>N361</a:t>
-            </a:r>
-            <a:r>
-              <a:rPr lang="es-ES" sz="2200" b="1" i="0" u="none" strike="noStrike" cap="none" dirty="0">
-                <a:solidFill>
-                  <a:schemeClr val="bg1"/>
-                </a:solidFill>
-                <a:latin typeface="Arial Black"/>
-                <a:ea typeface="Arial Black"/>
-                <a:cs typeface="Arial Black"/>
-                <a:sym typeface="Arial Black"/>
-              </a:rPr>
-              <a:t> </a:t>
-            </a:r>
-            <a:r>
-              <a:rPr lang="es-ES" sz="2200" b="1" dirty="0">
-                <a:solidFill>
-                  <a:schemeClr val="bg1"/>
-                </a:solidFill>
-                <a:latin typeface="Arial Black"/>
-                <a:ea typeface="Arial Black"/>
-                <a:cs typeface="Arial Black"/>
-                <a:sym typeface="Arial Black"/>
-              </a:rPr>
-              <a:t>SISA</a:t>
-            </a:r>
-            <a:r>
-              <a:rPr lang="es-ES" sz="2200" b="1" i="0" u="none" strike="noStrike" cap="none" dirty="0">
-                <a:solidFill>
-                  <a:schemeClr val="bg1"/>
-                </a:solidFill>
-                <a:latin typeface="Arial Black"/>
-                <a:ea typeface="Arial Black"/>
-                <a:cs typeface="Arial Black"/>
-                <a:sym typeface="Arial Black"/>
-              </a:rPr>
-              <a:t> - </a:t>
-            </a:r>
-            <a:r>
-              <a:rPr lang="es-ES" sz="2200" b="1" dirty="0">
-                <a:solidFill>
-                  <a:schemeClr val="bg1"/>
-                </a:solidFill>
-                <a:latin typeface="Arial Black"/>
-                <a:ea typeface="Arial Black"/>
-                <a:cs typeface="Arial Black"/>
-                <a:sym typeface="Arial Black"/>
-              </a:rPr>
-              <a:t>AV. LO MARCOLETA N361, QUILICURA</a:t>
+              <a:t>NOMBRE TIENDA</a:t>
             </a:r>
             <a:endParaRPr sz="2200" b="1" dirty="0">
               <a:solidFill>
@@ -2527,8 +2772,8 @@
         </p:nvSpPr>
         <p:spPr>
           <a:xfrm>
-            <a:off x="812586" y="1758678"/>
-            <a:ext cx="3022500" cy="288803"/>
+            <a:off x="2883735" y="1365799"/>
+            <a:ext cx="5543467" cy="288803"/>
           </a:xfrm>
           <a:prstGeom prst="rect">
             <a:avLst/>
@@ -2571,7 +2816,7 @@
                 <a:cs typeface="Arial"/>
                 <a:sym typeface="Arial"/>
               </a:rPr>
-              <a:t>FECHA: 11/03/2026</a:t>
+              <a:t>FECHA:</a:t>
             </a:r>
           </a:p>
         </p:txBody>
@@ -2591,176 +2836,8 @@
         </p:blipFill>
         <p:spPr>
           <a:xfrm>
-            <a:off x="634050" y="2177403"/>
-            <a:ext cx="3379376" cy="2589173"/>
-          </a:xfrm>
-          <a:prstGeom prst="rect">
-            <a:avLst/>
-          </a:prstGeom>
-          <a:noFill/>
-          <a:ln>
-            <a:noFill/>
-          </a:ln>
-        </p:spPr>
-      </p:pic>
-      <p:sp>
-        <p:nvSpPr>
-          <p:cNvPr id="32" name="Google Shape;32;g3ceeff82bb2_0_39"/>
-          <p:cNvSpPr txBox="1"/>
-          <p:nvPr/>
-        </p:nvSpPr>
-        <p:spPr>
-          <a:xfrm>
-            <a:off x="4506135" y="1758950"/>
-            <a:ext cx="3022500" cy="288803"/>
-          </a:xfrm>
-          <a:prstGeom prst="rect">
-            <a:avLst/>
-          </a:prstGeom>
-          <a:noFill/>
-          <a:ln>
-            <a:noFill/>
-          </a:ln>
-        </p:spPr>
-        <p:txBody>
-          <a:bodyPr spcFirstLastPara="1" wrap="square" lIns="36325" tIns="36325" rIns="36325" bIns="36325" anchor="t" anchorCtr="0">
-            <a:spAutoFit/>
-          </a:bodyPr>
-          <a:lstStyle/>
-          <a:p>
-            <a:pPr marL="0" marR="0" lvl="0" indent="0" algn="ctr" rtl="0">
-              <a:lnSpc>
-                <a:spcPct val="100000"/>
-              </a:lnSpc>
-              <a:spcBef>
-                <a:spcPts val="0"/>
-              </a:spcBef>
-              <a:spcAft>
-                <a:spcPts val="0"/>
-              </a:spcAft>
-              <a:buClr>
-                <a:srgbClr val="000000"/>
-              </a:buClr>
-              <a:buSzPts val="1000"/>
-              <a:buFont typeface="Arial"/>
-              <a:buNone/>
-            </a:pPr>
-            <a:r>
-              <a:rPr lang="es-ES" b="1" i="0" u="none" strike="noStrike" cap="none" dirty="0">
-                <a:solidFill>
-                  <a:srgbClr val="FFFFFF"/>
-                </a:solidFill>
-                <a:latin typeface="Arial"/>
-                <a:ea typeface="Arial"/>
-                <a:cs typeface="Arial"/>
-                <a:sym typeface="Arial"/>
-              </a:rPr>
-              <a:t>FECHA: 11/03/2026</a:t>
-            </a:r>
-          </a:p>
-        </p:txBody>
-      </p:sp>
-      <p:pic>
-        <p:nvPicPr>
-          <p:cNvPr id="33" name="Google Shape;33;g3ceeff82bb2_0_39" title="41fe07a4-69a5-43f8-b998-ea75b2249615.jpg"/>
-          <p:cNvPicPr preferRelativeResize="0"/>
-          <p:nvPr/>
-        </p:nvPicPr>
-        <p:blipFill rotWithShape="1">
-          <a:blip r:embed="rId4">
-            <a:alphaModFix/>
-          </a:blip>
-          <a:srcRect l="1057" r="1057"/>
-          <a:stretch/>
-        </p:blipFill>
-        <p:spPr>
-          <a:xfrm>
-            <a:off x="4327600" y="2177403"/>
-            <a:ext cx="3379376" cy="2589170"/>
-          </a:xfrm>
-          <a:prstGeom prst="rect">
-            <a:avLst/>
-          </a:prstGeom>
-          <a:noFill/>
-          <a:ln>
-            <a:noFill/>
-          </a:ln>
-        </p:spPr>
-      </p:pic>
-      <p:sp>
-        <p:nvSpPr>
-          <p:cNvPr id="34" name="Google Shape;34;g3ceeff82bb2_0_39"/>
-          <p:cNvSpPr txBox="1"/>
-          <p:nvPr/>
-        </p:nvSpPr>
-        <p:spPr>
-          <a:xfrm>
-            <a:off x="8199684" y="1758950"/>
-            <a:ext cx="3022500" cy="288803"/>
-          </a:xfrm>
-          <a:prstGeom prst="rect">
-            <a:avLst/>
-          </a:prstGeom>
-          <a:noFill/>
-          <a:ln>
-            <a:noFill/>
-          </a:ln>
-        </p:spPr>
-        <p:txBody>
-          <a:bodyPr spcFirstLastPara="1" wrap="square" lIns="36325" tIns="36325" rIns="36325" bIns="36325" anchor="t" anchorCtr="0">
-            <a:spAutoFit/>
-          </a:bodyPr>
-          <a:lstStyle/>
-          <a:p>
-            <a:pPr marL="0" marR="0" lvl="0" indent="0" algn="ctr" rtl="0">
-              <a:lnSpc>
-                <a:spcPct val="100000"/>
-              </a:lnSpc>
-              <a:spcBef>
-                <a:spcPts val="0"/>
-              </a:spcBef>
-              <a:spcAft>
-                <a:spcPts val="0"/>
-              </a:spcAft>
-              <a:buClr>
-                <a:srgbClr val="000000"/>
-              </a:buClr>
-              <a:buSzPts val="1000"/>
-              <a:buFont typeface="Arial"/>
-              <a:buNone/>
-            </a:pPr>
-            <a:r>
-              <a:rPr lang="es-ES" b="1" i="0" u="none" strike="noStrike" cap="none" dirty="0">
-                <a:solidFill>
-                  <a:srgbClr val="FFFFFF"/>
-                </a:solidFill>
-                <a:latin typeface="Arial"/>
-                <a:ea typeface="Arial"/>
-                <a:cs typeface="Arial"/>
-                <a:sym typeface="Arial"/>
-              </a:rPr>
-              <a:t>FECHA: 11/03/2026</a:t>
-            </a:r>
-          </a:p>
-        </p:txBody>
-      </p:sp>
-      <p:pic>
-        <p:nvPicPr>
-          <p:cNvPr id="35" name="Google Shape;35;g3ceeff82bb2_0_39" title="66b07255-4409-4a2d-bcec-05262e91b0ae.jpg"/>
-          <p:cNvPicPr preferRelativeResize="0"/>
-          <p:nvPr/>
-        </p:nvPicPr>
-        <p:blipFill rotWithShape="1">
-          <a:blip r:embed="rId5">
-            <a:alphaModFix/>
-          </a:blip>
-          <a:srcRect l="1057" r="1057"/>
-          <a:stretch/>
-        </p:blipFill>
-        <p:spPr>
-          <a:xfrm>
-            <a:off x="8021149" y="2177403"/>
-            <a:ext cx="3379376" cy="2589173"/>
+            <a:off x="2883736" y="1772907"/>
+            <a:ext cx="5543468" cy="4247233"/>
           </a:xfrm>
           <a:prstGeom prst="rect">
             <a:avLst/>
@@ -2775,234 +2852,6 @@
     <p:extLst>
       <p:ext uri="{BB962C8B-B14F-4D97-AF65-F5344CB8AC3E}">
         <p14:creationId xmlns:p14="http://schemas.microsoft.com/office/powerpoint/2010/main" val="2789082858"/>
-      </p:ext>
-    </p:extLst>
-  </p:cSld>
-  <p:clrMapOvr>
-    <a:masterClrMapping/>
-  </p:clrMapOvr>
-</p:sld>
-</file>
-
-<file path=ppt/slides/slide3.xml><?xml version="1.0" encoding="utf-8"?>
-<p:sld xmlns:a="http://schemas.openxmlformats.org/drawingml/2006/main" xmlns:r="http://schemas.openxmlformats.org/officeDocument/2006/relationships" xmlns:p="http://schemas.openxmlformats.org/presentationml/2006/main">
-  <p:cSld>
-    <p:spTree>
-      <p:nvGrpSpPr>
-        <p:cNvPr id="1" name="Shape 39"/>
-        <p:cNvGrpSpPr/>
-        <p:nvPr/>
-      </p:nvGrpSpPr>
-      <p:grpSpPr>
-        <a:xfrm>
-          <a:off x="0" y="0"/>
-          <a:ext cx="0" cy="0"/>
-          <a:chOff x="0" y="0"/>
-          <a:chExt cx="0" cy="0"/>
-        </a:xfrm>
-      </p:grpSpPr>
-      <p:sp>
-        <p:nvSpPr>
-          <p:cNvPr id="40" name="Google Shape;40;g3d777708fde_0_57"/>
-          <p:cNvSpPr txBox="1"/>
-          <p:nvPr/>
-        </p:nvSpPr>
-        <p:spPr>
-          <a:xfrm>
-            <a:off x="499380" y="263800"/>
-            <a:ext cx="10972800" cy="430800"/>
-          </a:xfrm>
-          <a:prstGeom prst="rect">
-            <a:avLst/>
-          </a:prstGeom>
-          <a:noFill/>
-          <a:ln>
-            <a:noFill/>
-          </a:ln>
-        </p:spPr>
-        <p:txBody>
-          <a:bodyPr spcFirstLastPara="1" wrap="square" lIns="91425" tIns="45700" rIns="91425" bIns="45700" anchor="t" anchorCtr="0">
-            <a:spAutoFit/>
-          </a:bodyPr>
-          <a:lstStyle/>
-          <a:p>
-            <a:pPr marL="0" marR="0" lvl="0" indent="0" algn="l" rtl="0">
-              <a:lnSpc>
-                <a:spcPct val="100000"/>
-              </a:lnSpc>
-              <a:spcBef>
-                <a:spcPts val="0"/>
-              </a:spcBef>
-              <a:spcAft>
-                <a:spcPts val="0"/>
-              </a:spcAft>
-              <a:buClr>
-                <a:srgbClr val="000000"/>
-              </a:buClr>
-              <a:buSzPts val="2400"/>
-              <a:buFont typeface="Arial"/>
-              <a:buNone/>
-            </a:pPr>
-            <a:r>
-              <a:rPr lang="es-ES" sz="2200" b="1">
-                <a:solidFill>
-                  <a:srgbClr val="FFFFFF"/>
-                </a:solidFill>
-                <a:latin typeface="Arial Black"/>
-                <a:ea typeface="Arial Black"/>
-                <a:cs typeface="Arial Black"/>
-                <a:sym typeface="Arial Black"/>
-              </a:rPr>
-              <a:t>N561</a:t>
-            </a:r>
-            <a:r>
-              <a:rPr lang="es-ES" sz="2200" b="1" i="0" u="none" strike="noStrike" cap="none">
-                <a:solidFill>
-                  <a:srgbClr val="FFFFFF"/>
-                </a:solidFill>
-                <a:latin typeface="Arial Black"/>
-                <a:ea typeface="Arial Black"/>
-                <a:cs typeface="Arial Black"/>
-                <a:sym typeface="Arial Black"/>
-              </a:rPr>
-              <a:t> S</a:t>
-            </a:r>
-            <a:r>
-              <a:rPr lang="es-ES" sz="2200" b="1">
-                <a:solidFill>
-                  <a:srgbClr val="FFFFFF"/>
-                </a:solidFill>
-                <a:latin typeface="Arial Black"/>
-                <a:ea typeface="Arial Black"/>
-                <a:cs typeface="Arial Black"/>
-                <a:sym typeface="Arial Black"/>
-              </a:rPr>
-              <a:t>ISA</a:t>
-            </a:r>
-            <a:r>
-              <a:rPr lang="es-ES" sz="2200" b="1" i="0" u="none" strike="noStrike" cap="none">
-                <a:solidFill>
-                  <a:srgbClr val="FFFFFF"/>
-                </a:solidFill>
-                <a:latin typeface="Arial Black"/>
-                <a:ea typeface="Arial Black"/>
-                <a:cs typeface="Arial Black"/>
-                <a:sym typeface="Arial Black"/>
-              </a:rPr>
-              <a:t> - </a:t>
-            </a:r>
-            <a:r>
-              <a:rPr lang="es-ES" sz="2200" b="1">
-                <a:solidFill>
-                  <a:srgbClr val="FFFFFF"/>
-                </a:solidFill>
-                <a:latin typeface="Arial Black"/>
-                <a:ea typeface="Arial Black"/>
-                <a:cs typeface="Arial Black"/>
-                <a:sym typeface="Arial Black"/>
-              </a:rPr>
-              <a:t>AV. CARDENAL SAMORÉ 2335, VALPARAÍSO</a:t>
-            </a:r>
-            <a:endParaRPr sz="2200" b="1" i="0" u="none" strike="noStrike" cap="none">
-              <a:solidFill>
-                <a:srgbClr val="FFFFFF"/>
-              </a:solidFill>
-              <a:latin typeface="Arial Black"/>
-              <a:ea typeface="Arial Black"/>
-              <a:cs typeface="Arial Black"/>
-              <a:sym typeface="Arial Black"/>
-            </a:endParaRPr>
-          </a:p>
-        </p:txBody>
-      </p:sp>
-      <p:sp>
-        <p:nvSpPr>
-          <p:cNvPr id="41" name="Google Shape;41;g3d777708fde_0_57"/>
-          <p:cNvSpPr txBox="1"/>
-          <p:nvPr/>
-        </p:nvSpPr>
-        <p:spPr>
-          <a:xfrm>
-            <a:off x="4149210" y="1524000"/>
-            <a:ext cx="3893700" cy="318036"/>
-          </a:xfrm>
-          <a:prstGeom prst="rect">
-            <a:avLst/>
-          </a:prstGeom>
-          <a:noFill/>
-          <a:ln>
-            <a:noFill/>
-          </a:ln>
-        </p:spPr>
-        <p:txBody>
-          <a:bodyPr spcFirstLastPara="1" wrap="square" lIns="50800" tIns="50800" rIns="50800" bIns="50800" anchor="t" anchorCtr="0">
-            <a:spAutoFit/>
-          </a:bodyPr>
-          <a:lstStyle/>
-          <a:p>
-            <a:pPr marL="0" marR="0" lvl="0" indent="0" algn="ctr" rtl="0">
-              <a:lnSpc>
-                <a:spcPct val="100000"/>
-              </a:lnSpc>
-              <a:spcBef>
-                <a:spcPts val="0"/>
-              </a:spcBef>
-              <a:spcAft>
-                <a:spcPts val="0"/>
-              </a:spcAft>
-              <a:buClr>
-                <a:srgbClr val="000000"/>
-              </a:buClr>
-              <a:buSzPts val="1400"/>
-              <a:buFont typeface="Arial"/>
-              <a:buNone/>
-            </a:pPr>
-            <a:r>
-              <a:rPr lang="es-ES" b="1" i="0" u="none" strike="noStrike" cap="none" dirty="0">
-                <a:solidFill>
-                  <a:srgbClr val="FFFFFF"/>
-                </a:solidFill>
-                <a:latin typeface="Arial"/>
-                <a:ea typeface="Arial"/>
-                <a:cs typeface="Arial"/>
-                <a:sym typeface="Arial"/>
-              </a:rPr>
-              <a:t>FECHA: 13/03/2026</a:t>
-            </a:r>
-          </a:p>
-        </p:txBody>
-      </p:sp>
-      <p:pic>
-        <p:nvPicPr>
-          <p:cNvPr id="42" name="Google Shape;42;g3d777708fde_0_57" title="13e6092e-a846-4def-8390-030e601e2da8.jpg"/>
-          <p:cNvPicPr preferRelativeResize="0"/>
-          <p:nvPr/>
-        </p:nvPicPr>
-        <p:blipFill rotWithShape="1">
-          <a:blip r:embed="rId3">
-            <a:alphaModFix/>
-          </a:blip>
-          <a:srcRect l="661" r="661"/>
-          <a:stretch/>
-        </p:blipFill>
-        <p:spPr>
-          <a:xfrm>
-            <a:off x="3602400" y="1887075"/>
-            <a:ext cx="5174900" cy="3933000"/>
-          </a:xfrm>
-          <a:prstGeom prst="rect">
-            <a:avLst/>
-          </a:prstGeom>
-          <a:noFill/>
-          <a:ln>
-            <a:noFill/>
-          </a:ln>
-        </p:spPr>
-      </p:pic>
-    </p:spTree>
-    <p:extLst>
-      <p:ext uri="{BB962C8B-B14F-4D97-AF65-F5344CB8AC3E}">
-        <p14:creationId xmlns:p14="http://schemas.microsoft.com/office/powerpoint/2010/main" val="4046438805"/>
       </p:ext>
     </p:extLst>
   </p:cSld>
@@ -3031,7 +2880,145 @@
       </p:grpSpPr>
       <p:sp>
         <p:nvSpPr>
-          <p:cNvPr id="139" name="Google Shape;139;g3d777708fde_0_459"/>
+          <p:cNvPr id="140" name="Google Shape;140;g3d777708fde_0_459"/>
+          <p:cNvSpPr txBox="1"/>
+          <p:nvPr/>
+        </p:nvSpPr>
+        <p:spPr>
+          <a:xfrm>
+            <a:off x="1361589" y="1716419"/>
+            <a:ext cx="4624191" cy="288803"/>
+          </a:xfrm>
+          <a:prstGeom prst="rect">
+            <a:avLst/>
+          </a:prstGeom>
+          <a:noFill/>
+          <a:ln>
+            <a:noFill/>
+          </a:ln>
+        </p:spPr>
+        <p:txBody>
+          <a:bodyPr spcFirstLastPara="1" wrap="square" lIns="36325" tIns="36325" rIns="36325" bIns="36325" anchor="t" anchorCtr="0">
+            <a:spAutoFit/>
+          </a:bodyPr>
+          <a:lstStyle/>
+          <a:p>
+            <a:pPr marL="0" marR="0" lvl="0" indent="0" algn="ctr" rtl="0">
+              <a:lnSpc>
+                <a:spcPct val="100000"/>
+              </a:lnSpc>
+              <a:spcBef>
+                <a:spcPts val="0"/>
+              </a:spcBef>
+              <a:spcAft>
+                <a:spcPts val="0"/>
+              </a:spcAft>
+              <a:buClr>
+                <a:srgbClr val="000000"/>
+              </a:buClr>
+              <a:buSzPts val="1000"/>
+              <a:buFont typeface="Arial"/>
+              <a:buNone/>
+            </a:pPr>
+            <a:r>
+              <a:rPr lang="es-ES" b="1" i="0" u="none" strike="noStrike" cap="none" dirty="0">
+                <a:solidFill>
+                  <a:srgbClr val="FFFFFF"/>
+                </a:solidFill>
+                <a:latin typeface="Arial"/>
+                <a:ea typeface="Arial"/>
+                <a:cs typeface="Arial"/>
+                <a:sym typeface="Arial"/>
+              </a:rPr>
+              <a:t>FECHA:</a:t>
+            </a:r>
+          </a:p>
+        </p:txBody>
+      </p:sp>
+      <p:grpSp>
+        <p:nvGrpSpPr>
+          <p:cNvPr id="3" name="Group 2">
+            <a:extLst>
+              <a:ext uri="{FF2B5EF4-FFF2-40B4-BE49-F238E27FC236}">
+                <a16:creationId xmlns:a16="http://schemas.microsoft.com/office/drawing/2014/main" id="{99A25A76-CBAD-2AD3-77BD-B95654C3DA69}"/>
+              </a:ext>
+            </a:extLst>
+          </p:cNvPr>
+          <p:cNvGrpSpPr/>
+          <p:nvPr/>
+        </p:nvGrpSpPr>
+        <p:grpSpPr>
+          <a:xfrm>
+            <a:off x="1361590" y="2124239"/>
+            <a:ext cx="9594447" cy="3542914"/>
+            <a:chOff x="634050" y="2177402"/>
+            <a:chExt cx="7129930" cy="2632849"/>
+          </a:xfrm>
+        </p:grpSpPr>
+        <p:pic>
+          <p:nvPicPr>
+            <p:cNvPr id="141" name="Google Shape;141;g3d777708fde_0_459" title="2bfc51a8-3849-4a63-ba20-37e70847f06e.jpg"/>
+            <p:cNvPicPr preferRelativeResize="0"/>
+            <p:nvPr/>
+          </p:nvPicPr>
+          <p:blipFill rotWithShape="1">
+            <a:blip r:embed="rId3">
+              <a:alphaModFix/>
+            </a:blip>
+            <a:srcRect l="1057" r="1057"/>
+            <a:stretch/>
+          </p:blipFill>
+          <p:spPr>
+            <a:xfrm>
+              <a:off x="634050" y="2177403"/>
+              <a:ext cx="3436380" cy="2632848"/>
+            </a:xfrm>
+            <a:prstGeom prst="rect">
+              <a:avLst/>
+            </a:prstGeom>
+            <a:noFill/>
+            <a:ln>
+              <a:noFill/>
+            </a:ln>
+          </p:spPr>
+        </p:pic>
+        <p:pic>
+          <p:nvPicPr>
+            <p:cNvPr id="143" name="Google Shape;143;g3d777708fde_0_459" title="66770c6b-40c6-48ad-9738-1b082640cd2c.jpg"/>
+            <p:cNvPicPr preferRelativeResize="0"/>
+            <p:nvPr/>
+          </p:nvPicPr>
+          <p:blipFill rotWithShape="1">
+            <a:blip r:embed="rId4">
+              <a:alphaModFix/>
+            </a:blip>
+            <a:srcRect l="1057" r="1057"/>
+            <a:stretch/>
+          </p:blipFill>
+          <p:spPr>
+            <a:xfrm>
+              <a:off x="4327600" y="2177402"/>
+              <a:ext cx="3436380" cy="2632845"/>
+            </a:xfrm>
+            <a:prstGeom prst="rect">
+              <a:avLst/>
+            </a:prstGeom>
+            <a:noFill/>
+            <a:ln>
+              <a:noFill/>
+            </a:ln>
+          </p:spPr>
+        </p:pic>
+      </p:grpSp>
+      <p:sp>
+        <p:nvSpPr>
+          <p:cNvPr id="2" name="Google Shape;29;g3ceeff82bb2_0_39">
+            <a:extLst>
+              <a:ext uri="{FF2B5EF4-FFF2-40B4-BE49-F238E27FC236}">
+                <a16:creationId xmlns:a16="http://schemas.microsoft.com/office/drawing/2014/main" id="{6CAB27A4-0AF2-BEE6-D05C-DB41A92C8087}"/>
+              </a:ext>
+            </a:extLst>
+          </p:cNvPr>
           <p:cNvSpPr txBox="1"/>
           <p:nvPr/>
         </p:nvSpPr>
@@ -3072,68 +3059,20 @@
               <a:buNone/>
             </a:pPr>
             <a:r>
-              <a:rPr lang="es-ES" sz="2200" b="1">
+              <a:rPr lang="es-ES" sz="2200" b="1" dirty="0">
                 <a:solidFill>
-                  <a:srgbClr val="FFFFFF"/>
+                  <a:schemeClr val="bg1"/>
                 </a:solidFill>
                 <a:latin typeface="Arial Black"/>
                 <a:ea typeface="Arial Black"/>
                 <a:cs typeface="Arial Black"/>
                 <a:sym typeface="Arial Black"/>
               </a:rPr>
-              <a:t>N634</a:t>
+              <a:t>NOMBRE TIENDA</a:t>
             </a:r>
-            <a:r>
-              <a:rPr lang="es-ES" sz="2200" b="1" i="0" u="none" strike="noStrike" cap="none">
-                <a:solidFill>
-                  <a:srgbClr val="FFFFFF"/>
-                </a:solidFill>
-                <a:latin typeface="Arial Black"/>
-                <a:ea typeface="Arial Black"/>
-                <a:cs typeface="Arial Black"/>
-                <a:sym typeface="Arial Black"/>
-              </a:rPr>
-              <a:t> </a:t>
-            </a:r>
-            <a:r>
-              <a:rPr lang="es-ES" sz="2200" b="1">
-                <a:solidFill>
-                  <a:srgbClr val="FFFFFF"/>
-                </a:solidFill>
-                <a:latin typeface="Arial Black"/>
-                <a:ea typeface="Arial Black"/>
-                <a:cs typeface="Arial Black"/>
-                <a:sym typeface="Arial Black"/>
-              </a:rPr>
-              <a:t>SISA</a:t>
-            </a:r>
-            <a:r>
-              <a:rPr lang="es-ES" sz="2200" b="1" i="0" u="none" strike="noStrike" cap="none">
-                <a:solidFill>
-                  <a:srgbClr val="FFFFFF"/>
-                </a:solidFill>
-                <a:latin typeface="Arial Black"/>
-                <a:ea typeface="Arial Black"/>
-                <a:cs typeface="Arial Black"/>
-                <a:sym typeface="Arial Black"/>
-              </a:rPr>
-              <a:t> - </a:t>
-            </a:r>
-            <a:r>
-              <a:rPr lang="es-ES" sz="2200" b="1">
-                <a:solidFill>
-                  <a:srgbClr val="FFFFFF"/>
-                </a:solidFill>
-                <a:latin typeface="Arial Black"/>
-                <a:ea typeface="Arial Black"/>
-                <a:cs typeface="Arial Black"/>
-                <a:sym typeface="Arial Black"/>
-              </a:rPr>
-              <a:t>AV. LO MARCOLETA N361, QUILICURA</a:t>
-            </a:r>
-            <a:endParaRPr sz="2200" b="1">
+            <a:endParaRPr sz="2200" b="1" dirty="0">
               <a:solidFill>
-                <a:srgbClr val="FFFFFF"/>
+                <a:schemeClr val="bg1"/>
               </a:solidFill>
               <a:latin typeface="Arial Black"/>
               <a:ea typeface="Arial Black"/>
@@ -3145,14 +3084,20 @@
       </p:sp>
       <p:sp>
         <p:nvSpPr>
-          <p:cNvPr id="140" name="Google Shape;140;g3d777708fde_0_459"/>
+          <p:cNvPr id="4" name="Google Shape;140;g3d777708fde_0_459">
+            <a:extLst>
+              <a:ext uri="{FF2B5EF4-FFF2-40B4-BE49-F238E27FC236}">
+                <a16:creationId xmlns:a16="http://schemas.microsoft.com/office/drawing/2014/main" id="{6AEF1FB8-F94B-1363-A527-C85A09BEBE39}"/>
+              </a:ext>
+            </a:extLst>
+          </p:cNvPr>
           <p:cNvSpPr txBox="1"/>
           <p:nvPr/>
         </p:nvSpPr>
         <p:spPr>
           <a:xfrm>
-            <a:off x="812585" y="1758950"/>
-            <a:ext cx="3022500" cy="288803"/>
+            <a:off x="6331845" y="1716418"/>
+            <a:ext cx="4624191" cy="288803"/>
           </a:xfrm>
           <a:prstGeom prst="rect">
             <a:avLst/>
@@ -3195,206 +3140,11 @@
                 <a:cs typeface="Arial"/>
                 <a:sym typeface="Arial"/>
               </a:rPr>
-              <a:t>FECHA: 11/03/2026</a:t>
+              <a:t>FECHA:</a:t>
             </a:r>
           </a:p>
         </p:txBody>
       </p:sp>
-      <p:pic>
-        <p:nvPicPr>
-          <p:cNvPr id="141" name="Google Shape;141;g3d777708fde_0_459" title="2bfc51a8-3849-4a63-ba20-37e70847f06e.jpg"/>
-          <p:cNvPicPr preferRelativeResize="0"/>
-          <p:nvPr/>
-        </p:nvPicPr>
-        <p:blipFill rotWithShape="1">
-          <a:blip r:embed="rId3">
-            <a:alphaModFix/>
-          </a:blip>
-          <a:srcRect l="1057" r="1057"/>
-          <a:stretch/>
-        </p:blipFill>
-        <p:spPr>
-          <a:xfrm>
-            <a:off x="634050" y="2177403"/>
-            <a:ext cx="3379376" cy="2589173"/>
-          </a:xfrm>
-          <a:prstGeom prst="rect">
-            <a:avLst/>
-          </a:prstGeom>
-          <a:noFill/>
-          <a:ln>
-            <a:noFill/>
-          </a:ln>
-        </p:spPr>
-      </p:pic>
-      <p:sp>
-        <p:nvSpPr>
-          <p:cNvPr id="142" name="Google Shape;142;g3d777708fde_0_459"/>
-          <p:cNvSpPr txBox="1"/>
-          <p:nvPr/>
-        </p:nvSpPr>
-        <p:spPr>
-          <a:xfrm>
-            <a:off x="4506135" y="1758950"/>
-            <a:ext cx="3022500" cy="288803"/>
-          </a:xfrm>
-          <a:prstGeom prst="rect">
-            <a:avLst/>
-          </a:prstGeom>
-          <a:noFill/>
-          <a:ln>
-            <a:noFill/>
-          </a:ln>
-        </p:spPr>
-        <p:txBody>
-          <a:bodyPr spcFirstLastPara="1" wrap="square" lIns="36325" tIns="36325" rIns="36325" bIns="36325" anchor="t" anchorCtr="0">
-            <a:spAutoFit/>
-          </a:bodyPr>
-          <a:lstStyle/>
-          <a:p>
-            <a:pPr marL="0" marR="0" lvl="0" indent="0" algn="ctr" rtl="0">
-              <a:lnSpc>
-                <a:spcPct val="100000"/>
-              </a:lnSpc>
-              <a:spcBef>
-                <a:spcPts val="0"/>
-              </a:spcBef>
-              <a:spcAft>
-                <a:spcPts val="0"/>
-              </a:spcAft>
-              <a:buClr>
-                <a:srgbClr val="000000"/>
-              </a:buClr>
-              <a:buSzPts val="1000"/>
-              <a:buFont typeface="Arial"/>
-              <a:buNone/>
-            </a:pPr>
-            <a:r>
-              <a:rPr lang="es-ES" b="1" i="0" u="none" strike="noStrike" cap="none" dirty="0">
-                <a:solidFill>
-                  <a:srgbClr val="FFFFFF"/>
-                </a:solidFill>
-                <a:latin typeface="Arial"/>
-                <a:ea typeface="Arial"/>
-                <a:cs typeface="Arial"/>
-                <a:sym typeface="Arial"/>
-              </a:rPr>
-              <a:t>FECHA: 11/02/2026</a:t>
-            </a:r>
-          </a:p>
-        </p:txBody>
-      </p:sp>
-      <p:pic>
-        <p:nvPicPr>
-          <p:cNvPr id="143" name="Google Shape;143;g3d777708fde_0_459" title="66770c6b-40c6-48ad-9738-1b082640cd2c.jpg"/>
-          <p:cNvPicPr preferRelativeResize="0"/>
-          <p:nvPr/>
-        </p:nvPicPr>
-        <p:blipFill rotWithShape="1">
-          <a:blip r:embed="rId4">
-            <a:alphaModFix/>
-          </a:blip>
-          <a:srcRect l="1057" r="1057"/>
-          <a:stretch/>
-        </p:blipFill>
-        <p:spPr>
-          <a:xfrm>
-            <a:off x="4327600" y="2177403"/>
-            <a:ext cx="3379376" cy="2589170"/>
-          </a:xfrm>
-          <a:prstGeom prst="rect">
-            <a:avLst/>
-          </a:prstGeom>
-          <a:noFill/>
-          <a:ln>
-            <a:noFill/>
-          </a:ln>
-        </p:spPr>
-      </p:pic>
-      <p:sp>
-        <p:nvSpPr>
-          <p:cNvPr id="144" name="Google Shape;144;g3d777708fde_0_459"/>
-          <p:cNvSpPr txBox="1"/>
-          <p:nvPr/>
-        </p:nvSpPr>
-        <p:spPr>
-          <a:xfrm>
-            <a:off x="8199684" y="1758950"/>
-            <a:ext cx="3022500" cy="288803"/>
-          </a:xfrm>
-          <a:prstGeom prst="rect">
-            <a:avLst/>
-          </a:prstGeom>
-          <a:noFill/>
-          <a:ln>
-            <a:noFill/>
-          </a:ln>
-        </p:spPr>
-        <p:txBody>
-          <a:bodyPr spcFirstLastPara="1" wrap="square" lIns="36325" tIns="36325" rIns="36325" bIns="36325" anchor="t" anchorCtr="0">
-            <a:spAutoFit/>
-          </a:bodyPr>
-          <a:lstStyle/>
-          <a:p>
-            <a:pPr marL="0" marR="0" lvl="0" indent="0" algn="ctr" rtl="0">
-              <a:lnSpc>
-                <a:spcPct val="100000"/>
-              </a:lnSpc>
-              <a:spcBef>
-                <a:spcPts val="0"/>
-              </a:spcBef>
-              <a:spcAft>
-                <a:spcPts val="0"/>
-              </a:spcAft>
-              <a:buClr>
-                <a:srgbClr val="000000"/>
-              </a:buClr>
-              <a:buSzPts val="1000"/>
-              <a:buFont typeface="Arial"/>
-              <a:buNone/>
-            </a:pPr>
-            <a:r>
-              <a:rPr lang="es-ES" b="1" i="0" u="none" strike="noStrike" cap="none" dirty="0">
-                <a:solidFill>
-                  <a:srgbClr val="FFFFFF"/>
-                </a:solidFill>
-                <a:latin typeface="Arial"/>
-                <a:ea typeface="Arial"/>
-                <a:cs typeface="Arial"/>
-                <a:sym typeface="Arial"/>
-              </a:rPr>
-              <a:t>FECHA: 12/03/2026</a:t>
-            </a:r>
-          </a:p>
-        </p:txBody>
-      </p:sp>
-      <p:pic>
-        <p:nvPicPr>
-          <p:cNvPr id="145" name="Google Shape;145;g3d777708fde_0_459" title="cfc4eb2b-7b52-4165-ac46-5d3817d922ec.jpg"/>
-          <p:cNvPicPr preferRelativeResize="0"/>
-          <p:nvPr/>
-        </p:nvPicPr>
-        <p:blipFill rotWithShape="1">
-          <a:blip r:embed="rId5">
-            <a:alphaModFix/>
-          </a:blip>
-          <a:srcRect l="1057" r="1057"/>
-          <a:stretch/>
-        </p:blipFill>
-        <p:spPr>
-          <a:xfrm>
-            <a:off x="8021149" y="2177403"/>
-            <a:ext cx="3379376" cy="2589173"/>
-          </a:xfrm>
-          <a:prstGeom prst="rect">
-            <a:avLst/>
-          </a:prstGeom>
-          <a:noFill/>
-          <a:ln>
-            <a:noFill/>
-          </a:ln>
-        </p:spPr>
-      </p:pic>
     </p:spTree>
     <p:extLst>
       <p:ext uri="{BB962C8B-B14F-4D97-AF65-F5344CB8AC3E}">
@@ -3413,7 +3163,13 @@
   <p:cSld>
     <p:spTree>
       <p:nvGrpSpPr>
-        <p:cNvPr id="1" name="Shape 298"/>
+        <p:cNvPr id="1" name="Shape 28">
+          <a:extLst>
+            <a:ext uri="{FF2B5EF4-FFF2-40B4-BE49-F238E27FC236}">
+              <a16:creationId xmlns:a16="http://schemas.microsoft.com/office/drawing/2014/main" id="{4488B669-DCEB-ABE6-DBA0-4D004E981D2F}"/>
+            </a:ext>
+          </a:extLst>
+        </p:cNvPr>
         <p:cNvGrpSpPr/>
         <p:nvPr/>
       </p:nvGrpSpPr>
@@ -3427,7 +3183,13 @@
       </p:grpSpPr>
       <p:sp>
         <p:nvSpPr>
-          <p:cNvPr id="299" name="Google Shape;299;g395f9ca54f4_0_65"/>
+          <p:cNvPr id="29" name="Google Shape;29;g3ceeff82bb2_0_39">
+            <a:extLst>
+              <a:ext uri="{FF2B5EF4-FFF2-40B4-BE49-F238E27FC236}">
+                <a16:creationId xmlns:a16="http://schemas.microsoft.com/office/drawing/2014/main" id="{21D47742-0D05-732C-B46B-E095129588DF}"/>
+              </a:ext>
+            </a:extLst>
+          </p:cNvPr>
           <p:cNvSpPr txBox="1"/>
           <p:nvPr/>
         </p:nvSpPr>
@@ -3468,68 +3230,20 @@
               <a:buNone/>
             </a:pPr>
             <a:r>
-              <a:rPr lang="es-ES" sz="2200" b="1">
+              <a:rPr lang="es-ES" sz="2200" b="1" dirty="0">
                 <a:solidFill>
-                  <a:srgbClr val="FFFFFF"/>
+                  <a:schemeClr val="bg1"/>
                 </a:solidFill>
                 <a:latin typeface="Arial Black"/>
                 <a:ea typeface="Arial Black"/>
                 <a:cs typeface="Arial Black"/>
                 <a:sym typeface="Arial Black"/>
               </a:rPr>
-              <a:t>N764</a:t>
+              <a:t>NOMBRE TIENDA</a:t>
             </a:r>
-            <a:r>
-              <a:rPr lang="es-ES" sz="2200" b="1" i="0" u="none" strike="noStrike" cap="none">
-                <a:solidFill>
-                  <a:srgbClr val="FFFFFF"/>
-                </a:solidFill>
-                <a:latin typeface="Arial Black"/>
-                <a:ea typeface="Arial Black"/>
-                <a:cs typeface="Arial Black"/>
-                <a:sym typeface="Arial Black"/>
-              </a:rPr>
-              <a:t> </a:t>
-            </a:r>
-            <a:r>
-              <a:rPr lang="es-ES" sz="2200" b="1">
-                <a:solidFill>
-                  <a:srgbClr val="FFFFFF"/>
-                </a:solidFill>
-                <a:latin typeface="Arial Black"/>
-                <a:ea typeface="Arial Black"/>
-                <a:cs typeface="Arial Black"/>
-                <a:sym typeface="Arial Black"/>
-              </a:rPr>
-              <a:t>SISA</a:t>
-            </a:r>
-            <a:r>
-              <a:rPr lang="es-ES" sz="2200" b="1" i="0" u="none" strike="noStrike" cap="none">
-                <a:solidFill>
-                  <a:srgbClr val="FFFFFF"/>
-                </a:solidFill>
-                <a:latin typeface="Arial Black"/>
-                <a:ea typeface="Arial Black"/>
-                <a:cs typeface="Arial Black"/>
-                <a:sym typeface="Arial Black"/>
-              </a:rPr>
-              <a:t> - </a:t>
-            </a:r>
-            <a:r>
-              <a:rPr lang="es-ES" sz="2200" b="1">
-                <a:solidFill>
-                  <a:srgbClr val="FFFFFF"/>
-                </a:solidFill>
-                <a:latin typeface="Arial Black"/>
-                <a:ea typeface="Arial Black"/>
-                <a:cs typeface="Arial Black"/>
-                <a:sym typeface="Arial Black"/>
-              </a:rPr>
-              <a:t>AV. LA FLORIDA 9385, LA FLORIDA</a:t>
-            </a:r>
-            <a:endParaRPr sz="2200" b="1">
+            <a:endParaRPr sz="2200" b="1" dirty="0">
               <a:solidFill>
-                <a:srgbClr val="FFFFFF"/>
+                <a:schemeClr val="bg1"/>
               </a:solidFill>
               <a:latin typeface="Arial Black"/>
               <a:ea typeface="Arial Black"/>
@@ -3541,14 +3255,20 @@
       </p:sp>
       <p:sp>
         <p:nvSpPr>
-          <p:cNvPr id="300" name="Google Shape;300;g395f9ca54f4_0_65"/>
+          <p:cNvPr id="30" name="Google Shape;30;g3ceeff82bb2_0_39">
+            <a:extLst>
+              <a:ext uri="{FF2B5EF4-FFF2-40B4-BE49-F238E27FC236}">
+                <a16:creationId xmlns:a16="http://schemas.microsoft.com/office/drawing/2014/main" id="{6A289230-FEB4-17C3-F031-23DD48C2F70C}"/>
+              </a:ext>
+            </a:extLst>
+          </p:cNvPr>
           <p:cNvSpPr txBox="1"/>
           <p:nvPr/>
         </p:nvSpPr>
         <p:spPr>
           <a:xfrm>
-            <a:off x="812585" y="1758950"/>
-            <a:ext cx="3022500" cy="288803"/>
+            <a:off x="343583" y="1971332"/>
+            <a:ext cx="3611132" cy="288803"/>
           </a:xfrm>
           <a:prstGeom prst="rect">
             <a:avLst/>
@@ -3591,48 +3311,27 @@
                 <a:cs typeface="Arial"/>
                 <a:sym typeface="Arial"/>
               </a:rPr>
-              <a:t>FECHA: 11/03/2026</a:t>
+              <a:t>FECHA:</a:t>
             </a:r>
           </a:p>
         </p:txBody>
       </p:sp>
-      <p:pic>
-        <p:nvPicPr>
-          <p:cNvPr id="301" name="Google Shape;301;g395f9ca54f4_0_65" title="ce333640-24c4-4896-a46e-a5736a144946.jpg"/>
-          <p:cNvPicPr preferRelativeResize="0"/>
-          <p:nvPr/>
-        </p:nvPicPr>
-        <p:blipFill rotWithShape="1">
-          <a:blip r:embed="rId3">
-            <a:alphaModFix/>
-          </a:blip>
-          <a:srcRect l="1057" r="1057"/>
-          <a:stretch/>
-        </p:blipFill>
-        <p:spPr>
-          <a:xfrm>
-            <a:off x="634050" y="2177403"/>
-            <a:ext cx="3379376" cy="2589171"/>
-          </a:xfrm>
-          <a:prstGeom prst="rect">
-            <a:avLst/>
-          </a:prstGeom>
-          <a:noFill/>
-          <a:ln>
-            <a:noFill/>
-          </a:ln>
-        </p:spPr>
-      </p:pic>
       <p:sp>
         <p:nvSpPr>
-          <p:cNvPr id="302" name="Google Shape;302;g395f9ca54f4_0_65"/>
+          <p:cNvPr id="32" name="Google Shape;32;g3ceeff82bb2_0_39">
+            <a:extLst>
+              <a:ext uri="{FF2B5EF4-FFF2-40B4-BE49-F238E27FC236}">
+                <a16:creationId xmlns:a16="http://schemas.microsoft.com/office/drawing/2014/main" id="{C57D19B4-BCF8-AB4E-24DE-C98916EDEF8C}"/>
+              </a:ext>
+            </a:extLst>
+          </p:cNvPr>
           <p:cNvSpPr txBox="1"/>
           <p:nvPr/>
         </p:nvSpPr>
         <p:spPr>
           <a:xfrm>
-            <a:off x="4506135" y="1758950"/>
-            <a:ext cx="3022500" cy="288803"/>
+            <a:off x="4290435" y="1971604"/>
+            <a:ext cx="3611132" cy="288803"/>
           </a:xfrm>
           <a:prstGeom prst="rect">
             <a:avLst/>
@@ -3675,48 +3374,27 @@
                 <a:cs typeface="Arial"/>
                 <a:sym typeface="Arial"/>
               </a:rPr>
-              <a:t>FECHA: 12/03/2026</a:t>
+              <a:t>FECHA:</a:t>
             </a:r>
           </a:p>
         </p:txBody>
       </p:sp>
-      <p:pic>
-        <p:nvPicPr>
-          <p:cNvPr id="303" name="Google Shape;303;g395f9ca54f4_0_65" title="12ac924a-589c-4913-b415-93e9f815e129.jpg"/>
-          <p:cNvPicPr preferRelativeResize="0"/>
-          <p:nvPr/>
-        </p:nvPicPr>
-        <p:blipFill rotWithShape="1">
-          <a:blip r:embed="rId4">
-            <a:alphaModFix/>
-          </a:blip>
-          <a:srcRect l="1057" r="1057"/>
-          <a:stretch/>
-        </p:blipFill>
-        <p:spPr>
-          <a:xfrm>
-            <a:off x="4327600" y="2177403"/>
-            <a:ext cx="3379376" cy="2589171"/>
-          </a:xfrm>
-          <a:prstGeom prst="rect">
-            <a:avLst/>
-          </a:prstGeom>
-          <a:noFill/>
-          <a:ln>
-            <a:noFill/>
-          </a:ln>
-        </p:spPr>
-      </p:pic>
       <p:sp>
         <p:nvSpPr>
-          <p:cNvPr id="304" name="Google Shape;304;g395f9ca54f4_0_65"/>
+          <p:cNvPr id="34" name="Google Shape;34;g3ceeff82bb2_0_39">
+            <a:extLst>
+              <a:ext uri="{FF2B5EF4-FFF2-40B4-BE49-F238E27FC236}">
+                <a16:creationId xmlns:a16="http://schemas.microsoft.com/office/drawing/2014/main" id="{1EDF8CAA-6A60-C19E-19EA-604854629E2D}"/>
+              </a:ext>
+            </a:extLst>
+          </p:cNvPr>
           <p:cNvSpPr txBox="1"/>
           <p:nvPr/>
         </p:nvSpPr>
         <p:spPr>
           <a:xfrm>
-            <a:off x="8199684" y="1758950"/>
-            <a:ext cx="3022500" cy="288803"/>
+            <a:off x="8237284" y="1971604"/>
+            <a:ext cx="3611132" cy="288803"/>
           </a:xfrm>
           <a:prstGeom prst="rect">
             <a:avLst/>
@@ -3759,42 +3437,135 @@
                 <a:cs typeface="Arial"/>
                 <a:sym typeface="Arial"/>
               </a:rPr>
-              <a:t>FECHA: 12/03/2026</a:t>
+              <a:t>FECHA:</a:t>
             </a:r>
           </a:p>
         </p:txBody>
       </p:sp>
-      <p:pic>
-        <p:nvPicPr>
-          <p:cNvPr id="305" name="Google Shape;305;g395f9ca54f4_0_65" title="2156bd9d-182c-49f0-834c-eac5f7186354.jpg"/>
-          <p:cNvPicPr preferRelativeResize="0"/>
+      <p:grpSp>
+        <p:nvGrpSpPr>
+          <p:cNvPr id="2" name="Group 1">
+            <a:extLst>
+              <a:ext uri="{FF2B5EF4-FFF2-40B4-BE49-F238E27FC236}">
+                <a16:creationId xmlns:a16="http://schemas.microsoft.com/office/drawing/2014/main" id="{2050F029-8BA6-8A78-6964-904430E33469}"/>
+              </a:ext>
+            </a:extLst>
+          </p:cNvPr>
+          <p:cNvGrpSpPr/>
           <p:nvPr/>
-        </p:nvPicPr>
-        <p:blipFill rotWithShape="1">
-          <a:blip r:embed="rId5">
-            <a:alphaModFix/>
-          </a:blip>
-          <a:srcRect l="1057" r="1057"/>
-          <a:stretch/>
-        </p:blipFill>
-        <p:spPr>
+        </p:nvGrpSpPr>
+        <p:grpSpPr>
           <a:xfrm>
-            <a:off x="8021149" y="2177403"/>
-            <a:ext cx="3379376" cy="2589171"/>
+            <a:off x="343583" y="2368788"/>
+            <a:ext cx="11504834" cy="2766737"/>
+            <a:chOff x="634050" y="2177403"/>
+            <a:chExt cx="10766475" cy="2589173"/>
           </a:xfrm>
-          <a:prstGeom prst="rect">
-            <a:avLst/>
-          </a:prstGeom>
-          <a:noFill/>
-          <a:ln>
+        </p:grpSpPr>
+        <p:pic>
+          <p:nvPicPr>
+            <p:cNvPr id="31" name="Google Shape;31;g3ceeff82bb2_0_39" title="c8d449f8-5fb3-4bb5-95ec-050b9a34d934.jpg">
+              <a:extLst>
+                <a:ext uri="{FF2B5EF4-FFF2-40B4-BE49-F238E27FC236}">
+                  <a16:creationId xmlns:a16="http://schemas.microsoft.com/office/drawing/2014/main" id="{3C2FC40A-DBFA-BD4D-9856-0C7B04D524E3}"/>
+                </a:ext>
+              </a:extLst>
+            </p:cNvPr>
+            <p:cNvPicPr preferRelativeResize="0"/>
+            <p:nvPr/>
+          </p:nvPicPr>
+          <p:blipFill rotWithShape="1">
+            <a:blip r:embed="rId3">
+              <a:alphaModFix/>
+            </a:blip>
+            <a:srcRect l="1057" r="1057"/>
+            <a:stretch/>
+          </p:blipFill>
+          <p:spPr>
+            <a:xfrm>
+              <a:off x="634050" y="2177403"/>
+              <a:ext cx="3379376" cy="2589173"/>
+            </a:xfrm>
+            <a:prstGeom prst="rect">
+              <a:avLst/>
+            </a:prstGeom>
             <a:noFill/>
-          </a:ln>
-        </p:spPr>
-      </p:pic>
+            <a:ln>
+              <a:noFill/>
+            </a:ln>
+          </p:spPr>
+        </p:pic>
+        <p:pic>
+          <p:nvPicPr>
+            <p:cNvPr id="33" name="Google Shape;33;g3ceeff82bb2_0_39" title="41fe07a4-69a5-43f8-b998-ea75b2249615.jpg">
+              <a:extLst>
+                <a:ext uri="{FF2B5EF4-FFF2-40B4-BE49-F238E27FC236}">
+                  <a16:creationId xmlns:a16="http://schemas.microsoft.com/office/drawing/2014/main" id="{1B44DA41-6D8D-6EBC-61A4-31B4801029E1}"/>
+                </a:ext>
+              </a:extLst>
+            </p:cNvPr>
+            <p:cNvPicPr preferRelativeResize="0"/>
+            <p:nvPr/>
+          </p:nvPicPr>
+          <p:blipFill rotWithShape="1">
+            <a:blip r:embed="rId4">
+              <a:alphaModFix/>
+            </a:blip>
+            <a:srcRect l="1057" r="1057"/>
+            <a:stretch/>
+          </p:blipFill>
+          <p:spPr>
+            <a:xfrm>
+              <a:off x="4327600" y="2177403"/>
+              <a:ext cx="3379376" cy="2589170"/>
+            </a:xfrm>
+            <a:prstGeom prst="rect">
+              <a:avLst/>
+            </a:prstGeom>
+            <a:noFill/>
+            <a:ln>
+              <a:noFill/>
+            </a:ln>
+          </p:spPr>
+        </p:pic>
+        <p:pic>
+          <p:nvPicPr>
+            <p:cNvPr id="35" name="Google Shape;35;g3ceeff82bb2_0_39" title="66b07255-4409-4a2d-bcec-05262e91b0ae.jpg">
+              <a:extLst>
+                <a:ext uri="{FF2B5EF4-FFF2-40B4-BE49-F238E27FC236}">
+                  <a16:creationId xmlns:a16="http://schemas.microsoft.com/office/drawing/2014/main" id="{4CA3A236-45A7-D82A-16A4-0BDDCCCB1E06}"/>
+                </a:ext>
+              </a:extLst>
+            </p:cNvPr>
+            <p:cNvPicPr preferRelativeResize="0"/>
+            <p:nvPr/>
+          </p:nvPicPr>
+          <p:blipFill rotWithShape="1">
+            <a:blip r:embed="rId5">
+              <a:alphaModFix/>
+            </a:blip>
+            <a:srcRect l="1057" r="1057"/>
+            <a:stretch/>
+          </p:blipFill>
+          <p:spPr>
+            <a:xfrm>
+              <a:off x="8021149" y="2177403"/>
+              <a:ext cx="3379376" cy="2589173"/>
+            </a:xfrm>
+            <a:prstGeom prst="rect">
+              <a:avLst/>
+            </a:prstGeom>
+            <a:noFill/>
+            <a:ln>
+              <a:noFill/>
+            </a:ln>
+          </p:spPr>
+        </p:pic>
+      </p:grpSp>
     </p:spTree>
     <p:extLst>
       <p:ext uri="{BB962C8B-B14F-4D97-AF65-F5344CB8AC3E}">
-        <p14:creationId xmlns:p14="http://schemas.microsoft.com/office/powerpoint/2010/main" val="3857638860"/>
+        <p14:creationId xmlns:p14="http://schemas.microsoft.com/office/powerpoint/2010/main" val="3499098738"/>
       </p:ext>
     </p:extLst>
   </p:cSld>
@@ -3809,7 +3580,13 @@
   <p:cSld>
     <p:spTree>
       <p:nvGrpSpPr>
-        <p:cNvPr id="1" name="Shape 309"/>
+        <p:cNvPr id="1" name="Shape 28">
+          <a:extLst>
+            <a:ext uri="{FF2B5EF4-FFF2-40B4-BE49-F238E27FC236}">
+              <a16:creationId xmlns:a16="http://schemas.microsoft.com/office/drawing/2014/main" id="{F03DC983-303A-7DAE-2764-0554BEB4829E}"/>
+            </a:ext>
+          </a:extLst>
+        </p:cNvPr>
         <p:cNvGrpSpPr/>
         <p:nvPr/>
       </p:nvGrpSpPr>
@@ -3823,7 +3600,13 @@
       </p:grpSpPr>
       <p:sp>
         <p:nvSpPr>
-          <p:cNvPr id="310" name="Google Shape;310;g3ceeff82bb2_0_1"/>
+          <p:cNvPr id="29" name="Google Shape;29;g3ceeff82bb2_0_39">
+            <a:extLst>
+              <a:ext uri="{FF2B5EF4-FFF2-40B4-BE49-F238E27FC236}">
+                <a16:creationId xmlns:a16="http://schemas.microsoft.com/office/drawing/2014/main" id="{8350F6D5-D46E-F66C-3146-00634993BB51}"/>
+              </a:ext>
+            </a:extLst>
+          </p:cNvPr>
           <p:cNvSpPr txBox="1"/>
           <p:nvPr/>
         </p:nvSpPr>
@@ -3864,68 +3647,20 @@
               <a:buNone/>
             </a:pPr>
             <a:r>
-              <a:rPr lang="es-ES" sz="2200" b="1">
+              <a:rPr lang="es-ES" sz="2200" b="1" dirty="0">
                 <a:solidFill>
-                  <a:srgbClr val="FFFFFF"/>
+                  <a:schemeClr val="bg1"/>
                 </a:solidFill>
                 <a:latin typeface="Arial Black"/>
                 <a:ea typeface="Arial Black"/>
                 <a:cs typeface="Arial Black"/>
                 <a:sym typeface="Arial Black"/>
               </a:rPr>
-              <a:t>N765</a:t>
+              <a:t>NOMBRE TIENDA</a:t>
             </a:r>
-            <a:r>
-              <a:rPr lang="es-ES" sz="2200" b="1" i="0" u="none" strike="noStrike" cap="none">
-                <a:solidFill>
-                  <a:srgbClr val="FFFFFF"/>
-                </a:solidFill>
-                <a:latin typeface="Arial Black"/>
-                <a:ea typeface="Arial Black"/>
-                <a:cs typeface="Arial Black"/>
-                <a:sym typeface="Arial Black"/>
-              </a:rPr>
-              <a:t> S</a:t>
-            </a:r>
-            <a:r>
-              <a:rPr lang="es-ES" sz="2200" b="1">
-                <a:solidFill>
-                  <a:srgbClr val="FFFFFF"/>
-                </a:solidFill>
-                <a:latin typeface="Arial Black"/>
-                <a:ea typeface="Arial Black"/>
-                <a:cs typeface="Arial Black"/>
-                <a:sym typeface="Arial Black"/>
-              </a:rPr>
-              <a:t>ISA</a:t>
-            </a:r>
-            <a:r>
-              <a:rPr lang="es-ES" sz="2200" b="1" i="0" u="none" strike="noStrike" cap="none">
-                <a:solidFill>
-                  <a:srgbClr val="FFFFFF"/>
-                </a:solidFill>
-                <a:latin typeface="Arial Black"/>
-                <a:ea typeface="Arial Black"/>
-                <a:cs typeface="Arial Black"/>
-                <a:sym typeface="Arial Black"/>
-              </a:rPr>
-              <a:t> - </a:t>
-            </a:r>
-            <a:r>
-              <a:rPr lang="es-ES" sz="2200" b="1">
-                <a:solidFill>
-                  <a:srgbClr val="FFFFFF"/>
-                </a:solidFill>
-                <a:latin typeface="Arial Black"/>
-                <a:ea typeface="Arial Black"/>
-                <a:cs typeface="Arial Black"/>
-                <a:sym typeface="Arial Black"/>
-              </a:rPr>
-              <a:t>AV. JOSE MIGUEL CARRERA 6610, LA CISTERNA</a:t>
-            </a:r>
-            <a:endParaRPr sz="2200" b="1" i="0" u="none" strike="noStrike" cap="none">
+            <a:endParaRPr sz="2200" b="1" dirty="0">
               <a:solidFill>
-                <a:srgbClr val="FFFFFF"/>
+                <a:schemeClr val="bg1"/>
               </a:solidFill>
               <a:latin typeface="Arial Black"/>
               <a:ea typeface="Arial Black"/>
@@ -3937,14 +3672,20 @@
       </p:sp>
       <p:sp>
         <p:nvSpPr>
-          <p:cNvPr id="311" name="Google Shape;311;g3ceeff82bb2_0_1"/>
+          <p:cNvPr id="30" name="Google Shape;30;g3ceeff82bb2_0_39">
+            <a:extLst>
+              <a:ext uri="{FF2B5EF4-FFF2-40B4-BE49-F238E27FC236}">
+                <a16:creationId xmlns:a16="http://schemas.microsoft.com/office/drawing/2014/main" id="{5D18D63B-B6FC-E531-3F47-717773D4F8AD}"/>
+              </a:ext>
+            </a:extLst>
+          </p:cNvPr>
           <p:cNvSpPr txBox="1"/>
           <p:nvPr/>
         </p:nvSpPr>
         <p:spPr>
           <a:xfrm>
-            <a:off x="4149210" y="1524000"/>
-            <a:ext cx="3893700" cy="318036"/>
+            <a:off x="359412" y="2158656"/>
+            <a:ext cx="2681336" cy="288803"/>
           </a:xfrm>
           <a:prstGeom prst="rect">
             <a:avLst/>
@@ -3955,7 +3696,7 @@
           </a:ln>
         </p:spPr>
         <p:txBody>
-          <a:bodyPr spcFirstLastPara="1" wrap="square" lIns="50800" tIns="50800" rIns="50800" bIns="50800" anchor="t" anchorCtr="0">
+          <a:bodyPr spcFirstLastPara="1" wrap="square" lIns="36325" tIns="36325" rIns="36325" bIns="36325" anchor="t" anchorCtr="0">
             <a:spAutoFit/>
           </a:bodyPr>
           <a:lstStyle/>
@@ -3973,7 +3714,7 @@
               <a:buClr>
                 <a:srgbClr val="000000"/>
               </a:buClr>
-              <a:buSzPts val="1400"/>
+              <a:buSzPts val="1000"/>
               <a:buFont typeface="Arial"/>
               <a:buNone/>
             </a:pPr>
@@ -3987,14 +3728,533 @@
                 <a:cs typeface="Arial"/>
                 <a:sym typeface="Arial"/>
               </a:rPr>
-              <a:t>FECHA: 10/03/2026</a:t>
+              <a:t>FECHA:</a:t>
+            </a:r>
+          </a:p>
+        </p:txBody>
+      </p:sp>
+      <p:grpSp>
+        <p:nvGrpSpPr>
+          <p:cNvPr id="4" name="Group 3">
+            <a:extLst>
+              <a:ext uri="{FF2B5EF4-FFF2-40B4-BE49-F238E27FC236}">
+                <a16:creationId xmlns:a16="http://schemas.microsoft.com/office/drawing/2014/main" id="{FD693E2C-7DC6-C192-7629-CC081D271632}"/>
+              </a:ext>
+            </a:extLst>
+          </p:cNvPr>
+          <p:cNvGrpSpPr/>
+          <p:nvPr/>
+        </p:nvGrpSpPr>
+        <p:grpSpPr>
+          <a:xfrm>
+            <a:off x="359412" y="2570806"/>
+            <a:ext cx="11473176" cy="2054358"/>
+            <a:chOff x="343583" y="2368787"/>
+            <a:chExt cx="11473176" cy="2054358"/>
+          </a:xfrm>
+        </p:grpSpPr>
+        <p:pic>
+          <p:nvPicPr>
+            <p:cNvPr id="31" name="Google Shape;31;g3ceeff82bb2_0_39" title="c8d449f8-5fb3-4bb5-95ec-050b9a34d934.jpg">
+              <a:extLst>
+                <a:ext uri="{FF2B5EF4-FFF2-40B4-BE49-F238E27FC236}">
+                  <a16:creationId xmlns:a16="http://schemas.microsoft.com/office/drawing/2014/main" id="{389936F0-5E9D-9690-88FE-5ECF6564226A}"/>
+                </a:ext>
+              </a:extLst>
+            </p:cNvPr>
+            <p:cNvPicPr preferRelativeResize="0"/>
+            <p:nvPr/>
+          </p:nvPicPr>
+          <p:blipFill rotWithShape="1">
+            <a:blip r:embed="rId3">
+              <a:alphaModFix/>
+            </a:blip>
+            <a:srcRect l="1057" r="1057"/>
+            <a:stretch/>
+          </p:blipFill>
+          <p:spPr>
+            <a:xfrm>
+              <a:off x="343583" y="2368789"/>
+              <a:ext cx="2681336" cy="2054356"/>
+            </a:xfrm>
+            <a:prstGeom prst="rect">
+              <a:avLst/>
+            </a:prstGeom>
+            <a:noFill/>
+            <a:ln>
+              <a:noFill/>
+            </a:ln>
+          </p:spPr>
+        </p:pic>
+        <p:pic>
+          <p:nvPicPr>
+            <p:cNvPr id="33" name="Google Shape;33;g3ceeff82bb2_0_39" title="41fe07a4-69a5-43f8-b998-ea75b2249615.jpg">
+              <a:extLst>
+                <a:ext uri="{FF2B5EF4-FFF2-40B4-BE49-F238E27FC236}">
+                  <a16:creationId xmlns:a16="http://schemas.microsoft.com/office/drawing/2014/main" id="{212FBBE8-3F78-D327-08A6-05DF4264DF92}"/>
+                </a:ext>
+              </a:extLst>
+            </p:cNvPr>
+            <p:cNvPicPr preferRelativeResize="0"/>
+            <p:nvPr/>
+          </p:nvPicPr>
+          <p:blipFill rotWithShape="1">
+            <a:blip r:embed="rId4">
+              <a:alphaModFix/>
+            </a:blip>
+            <a:srcRect l="1057" r="1057"/>
+            <a:stretch/>
+          </p:blipFill>
+          <p:spPr>
+            <a:xfrm>
+              <a:off x="3274197" y="2368789"/>
+              <a:ext cx="2681336" cy="2054354"/>
+            </a:xfrm>
+            <a:prstGeom prst="rect">
+              <a:avLst/>
+            </a:prstGeom>
+            <a:noFill/>
+            <a:ln>
+              <a:noFill/>
+            </a:ln>
+          </p:spPr>
+        </p:pic>
+        <p:pic>
+          <p:nvPicPr>
+            <p:cNvPr id="35" name="Google Shape;35;g3ceeff82bb2_0_39" title="66b07255-4409-4a2d-bcec-05262e91b0ae.jpg">
+              <a:extLst>
+                <a:ext uri="{FF2B5EF4-FFF2-40B4-BE49-F238E27FC236}">
+                  <a16:creationId xmlns:a16="http://schemas.microsoft.com/office/drawing/2014/main" id="{06DD81F6-6AFE-E977-279D-736397202C4E}"/>
+                </a:ext>
+              </a:extLst>
+            </p:cNvPr>
+            <p:cNvPicPr preferRelativeResize="0"/>
+            <p:nvPr/>
+          </p:nvPicPr>
+          <p:blipFill rotWithShape="1">
+            <a:blip r:embed="rId5">
+              <a:alphaModFix/>
+            </a:blip>
+            <a:srcRect l="1057" r="1057"/>
+            <a:stretch/>
+          </p:blipFill>
+          <p:spPr>
+            <a:xfrm>
+              <a:off x="6204810" y="2368789"/>
+              <a:ext cx="2681336" cy="2054356"/>
+            </a:xfrm>
+            <a:prstGeom prst="rect">
+              <a:avLst/>
+            </a:prstGeom>
+            <a:noFill/>
+            <a:ln>
+              <a:noFill/>
+            </a:ln>
+          </p:spPr>
+        </p:pic>
+        <p:pic>
+          <p:nvPicPr>
+            <p:cNvPr id="3" name="Google Shape;35;g3ceeff82bb2_0_39" title="66b07255-4409-4a2d-bcec-05262e91b0ae.jpg">
+              <a:extLst>
+                <a:ext uri="{FF2B5EF4-FFF2-40B4-BE49-F238E27FC236}">
+                  <a16:creationId xmlns:a16="http://schemas.microsoft.com/office/drawing/2014/main" id="{D59C8AAE-7CCF-ABC0-9CAC-8BEE3007C45C}"/>
+                </a:ext>
+              </a:extLst>
+            </p:cNvPr>
+            <p:cNvPicPr preferRelativeResize="0"/>
+            <p:nvPr/>
+          </p:nvPicPr>
+          <p:blipFill rotWithShape="1">
+            <a:blip r:embed="rId5">
+              <a:alphaModFix/>
+            </a:blip>
+            <a:srcRect l="1057" r="1057"/>
+            <a:stretch/>
+          </p:blipFill>
+          <p:spPr>
+            <a:xfrm>
+              <a:off x="9135423" y="2368787"/>
+              <a:ext cx="2681336" cy="2054356"/>
+            </a:xfrm>
+            <a:prstGeom prst="rect">
+              <a:avLst/>
+            </a:prstGeom>
+            <a:noFill/>
+            <a:ln>
+              <a:noFill/>
+            </a:ln>
+          </p:spPr>
+        </p:pic>
+      </p:grpSp>
+      <p:sp>
+        <p:nvSpPr>
+          <p:cNvPr id="5" name="Google Shape;30;g3ceeff82bb2_0_39">
+            <a:extLst>
+              <a:ext uri="{FF2B5EF4-FFF2-40B4-BE49-F238E27FC236}">
+                <a16:creationId xmlns:a16="http://schemas.microsoft.com/office/drawing/2014/main" id="{6ADEA137-71FD-16B0-E6D7-80A64636D90C}"/>
+              </a:ext>
+            </a:extLst>
+          </p:cNvPr>
+          <p:cNvSpPr txBox="1"/>
+          <p:nvPr/>
+        </p:nvSpPr>
+        <p:spPr>
+          <a:xfrm>
+            <a:off x="3290026" y="2158655"/>
+            <a:ext cx="2681336" cy="288803"/>
+          </a:xfrm>
+          <a:prstGeom prst="rect">
+            <a:avLst/>
+          </a:prstGeom>
+          <a:noFill/>
+          <a:ln>
+            <a:noFill/>
+          </a:ln>
+        </p:spPr>
+        <p:txBody>
+          <a:bodyPr spcFirstLastPara="1" wrap="square" lIns="36325" tIns="36325" rIns="36325" bIns="36325" anchor="t" anchorCtr="0">
+            <a:spAutoFit/>
+          </a:bodyPr>
+          <a:lstStyle/>
+          <a:p>
+            <a:pPr marL="0" marR="0" lvl="0" indent="0" algn="ctr" rtl="0">
+              <a:lnSpc>
+                <a:spcPct val="100000"/>
+              </a:lnSpc>
+              <a:spcBef>
+                <a:spcPts val="0"/>
+              </a:spcBef>
+              <a:spcAft>
+                <a:spcPts val="0"/>
+              </a:spcAft>
+              <a:buClr>
+                <a:srgbClr val="000000"/>
+              </a:buClr>
+              <a:buSzPts val="1000"/>
+              <a:buFont typeface="Arial"/>
+              <a:buNone/>
+            </a:pPr>
+            <a:r>
+              <a:rPr lang="es-ES" b="1" i="0" u="none" strike="noStrike" cap="none" dirty="0">
+                <a:solidFill>
+                  <a:srgbClr val="FFFFFF"/>
+                </a:solidFill>
+                <a:latin typeface="Arial"/>
+                <a:ea typeface="Arial"/>
+                <a:cs typeface="Arial"/>
+                <a:sym typeface="Arial"/>
+              </a:rPr>
+              <a:t>FECHA:</a:t>
+            </a:r>
+          </a:p>
+        </p:txBody>
+      </p:sp>
+      <p:sp>
+        <p:nvSpPr>
+          <p:cNvPr id="6" name="Google Shape;30;g3ceeff82bb2_0_39">
+            <a:extLst>
+              <a:ext uri="{FF2B5EF4-FFF2-40B4-BE49-F238E27FC236}">
+                <a16:creationId xmlns:a16="http://schemas.microsoft.com/office/drawing/2014/main" id="{7CF5D54C-4C90-9CC1-55D5-0441293D3C8E}"/>
+              </a:ext>
+            </a:extLst>
+          </p:cNvPr>
+          <p:cNvSpPr txBox="1"/>
+          <p:nvPr/>
+        </p:nvSpPr>
+        <p:spPr>
+          <a:xfrm>
+            <a:off x="6209841" y="2158654"/>
+            <a:ext cx="2681336" cy="288803"/>
+          </a:xfrm>
+          <a:prstGeom prst="rect">
+            <a:avLst/>
+          </a:prstGeom>
+          <a:noFill/>
+          <a:ln>
+            <a:noFill/>
+          </a:ln>
+        </p:spPr>
+        <p:txBody>
+          <a:bodyPr spcFirstLastPara="1" wrap="square" lIns="36325" tIns="36325" rIns="36325" bIns="36325" anchor="t" anchorCtr="0">
+            <a:spAutoFit/>
+          </a:bodyPr>
+          <a:lstStyle/>
+          <a:p>
+            <a:pPr marL="0" marR="0" lvl="0" indent="0" algn="ctr" rtl="0">
+              <a:lnSpc>
+                <a:spcPct val="100000"/>
+              </a:lnSpc>
+              <a:spcBef>
+                <a:spcPts val="0"/>
+              </a:spcBef>
+              <a:spcAft>
+                <a:spcPts val="0"/>
+              </a:spcAft>
+              <a:buClr>
+                <a:srgbClr val="000000"/>
+              </a:buClr>
+              <a:buSzPts val="1000"/>
+              <a:buFont typeface="Arial"/>
+              <a:buNone/>
+            </a:pPr>
+            <a:r>
+              <a:rPr lang="es-ES" b="1" i="0" u="none" strike="noStrike" cap="none" dirty="0">
+                <a:solidFill>
+                  <a:srgbClr val="FFFFFF"/>
+                </a:solidFill>
+                <a:latin typeface="Arial"/>
+                <a:ea typeface="Arial"/>
+                <a:cs typeface="Arial"/>
+                <a:sym typeface="Arial"/>
+              </a:rPr>
+              <a:t>FECHA:</a:t>
+            </a:r>
+          </a:p>
+        </p:txBody>
+      </p:sp>
+      <p:sp>
+        <p:nvSpPr>
+          <p:cNvPr id="7" name="Google Shape;30;g3ceeff82bb2_0_39">
+            <a:extLst>
+              <a:ext uri="{FF2B5EF4-FFF2-40B4-BE49-F238E27FC236}">
+                <a16:creationId xmlns:a16="http://schemas.microsoft.com/office/drawing/2014/main" id="{3BBB08B7-13C5-5D45-6D55-FF4E00AD61D9}"/>
+              </a:ext>
+            </a:extLst>
+          </p:cNvPr>
+          <p:cNvSpPr txBox="1"/>
+          <p:nvPr/>
+        </p:nvSpPr>
+        <p:spPr>
+          <a:xfrm>
+            <a:off x="9129986" y="2158654"/>
+            <a:ext cx="2681336" cy="288803"/>
+          </a:xfrm>
+          <a:prstGeom prst="rect">
+            <a:avLst/>
+          </a:prstGeom>
+          <a:noFill/>
+          <a:ln>
+            <a:noFill/>
+          </a:ln>
+        </p:spPr>
+        <p:txBody>
+          <a:bodyPr spcFirstLastPara="1" wrap="square" lIns="36325" tIns="36325" rIns="36325" bIns="36325" anchor="t" anchorCtr="0">
+            <a:spAutoFit/>
+          </a:bodyPr>
+          <a:lstStyle/>
+          <a:p>
+            <a:pPr marL="0" marR="0" lvl="0" indent="0" algn="ctr" rtl="0">
+              <a:lnSpc>
+                <a:spcPct val="100000"/>
+              </a:lnSpc>
+              <a:spcBef>
+                <a:spcPts val="0"/>
+              </a:spcBef>
+              <a:spcAft>
+                <a:spcPts val="0"/>
+              </a:spcAft>
+              <a:buClr>
+                <a:srgbClr val="000000"/>
+              </a:buClr>
+              <a:buSzPts val="1000"/>
+              <a:buFont typeface="Arial"/>
+              <a:buNone/>
+            </a:pPr>
+            <a:r>
+              <a:rPr lang="es-ES" b="1" i="0" u="none" strike="noStrike" cap="none" dirty="0">
+                <a:solidFill>
+                  <a:srgbClr val="FFFFFF"/>
+                </a:solidFill>
+                <a:latin typeface="Arial"/>
+                <a:ea typeface="Arial"/>
+                <a:cs typeface="Arial"/>
+                <a:sym typeface="Arial"/>
+              </a:rPr>
+              <a:t>FECHA:</a:t>
+            </a:r>
+          </a:p>
+        </p:txBody>
+      </p:sp>
+    </p:spTree>
+    <p:extLst>
+      <p:ext uri="{BB962C8B-B14F-4D97-AF65-F5344CB8AC3E}">
+        <p14:creationId xmlns:p14="http://schemas.microsoft.com/office/powerpoint/2010/main" val="1921996156"/>
+      </p:ext>
+    </p:extLst>
+  </p:cSld>
+  <p:clrMapOvr>
+    <a:masterClrMapping/>
+  </p:clrMapOvr>
+</p:sld>
+</file>
+
+<file path=ppt/slides/slide7.xml><?xml version="1.0" encoding="utf-8"?>
+<p:sld xmlns:a="http://schemas.openxmlformats.org/drawingml/2006/main" xmlns:r="http://schemas.openxmlformats.org/officeDocument/2006/relationships" xmlns:p="http://schemas.openxmlformats.org/presentationml/2006/main">
+  <p:cSld>
+    <p:spTree>
+      <p:nvGrpSpPr>
+        <p:cNvPr id="1" name="Shape 28">
+          <a:extLst>
+            <a:ext uri="{FF2B5EF4-FFF2-40B4-BE49-F238E27FC236}">
+              <a16:creationId xmlns:a16="http://schemas.microsoft.com/office/drawing/2014/main" id="{81B44511-EA63-539C-C9AB-F2DDE0809B0D}"/>
+            </a:ext>
+          </a:extLst>
+        </p:cNvPr>
+        <p:cNvGrpSpPr/>
+        <p:nvPr/>
+      </p:nvGrpSpPr>
+      <p:grpSpPr>
+        <a:xfrm>
+          <a:off x="0" y="0"/>
+          <a:ext cx="0" cy="0"/>
+          <a:chOff x="0" y="0"/>
+          <a:chExt cx="0" cy="0"/>
+        </a:xfrm>
+      </p:grpSpPr>
+      <p:sp>
+        <p:nvSpPr>
+          <p:cNvPr id="29" name="Google Shape;29;g3ceeff82bb2_0_39">
+            <a:extLst>
+              <a:ext uri="{FF2B5EF4-FFF2-40B4-BE49-F238E27FC236}">
+                <a16:creationId xmlns:a16="http://schemas.microsoft.com/office/drawing/2014/main" id="{B16BD5FB-739A-D81C-2B2F-51CD4BC7F652}"/>
+              </a:ext>
+            </a:extLst>
+          </p:cNvPr>
+          <p:cNvSpPr txBox="1"/>
+          <p:nvPr/>
+        </p:nvSpPr>
+        <p:spPr>
+          <a:xfrm>
+            <a:off x="499380" y="263800"/>
+            <a:ext cx="10972800" cy="430800"/>
+          </a:xfrm>
+          <a:prstGeom prst="rect">
+            <a:avLst/>
+          </a:prstGeom>
+          <a:noFill/>
+          <a:ln>
+            <a:noFill/>
+          </a:ln>
+        </p:spPr>
+        <p:txBody>
+          <a:bodyPr spcFirstLastPara="1" wrap="square" lIns="91425" tIns="45700" rIns="91425" bIns="45700" anchor="t" anchorCtr="0">
+            <a:spAutoFit/>
+          </a:bodyPr>
+          <a:lstStyle/>
+          <a:p>
+            <a:pPr marL="0" marR="0" lvl="0" indent="0" algn="l" rtl="0">
+              <a:lnSpc>
+                <a:spcPct val="100000"/>
+              </a:lnSpc>
+              <a:spcBef>
+                <a:spcPts val="0"/>
+              </a:spcBef>
+              <a:spcAft>
+                <a:spcPts val="0"/>
+              </a:spcAft>
+              <a:buClr>
+                <a:srgbClr val="000000"/>
+              </a:buClr>
+              <a:buSzPts val="2400"/>
+              <a:buFont typeface="Arial"/>
+              <a:buNone/>
+            </a:pPr>
+            <a:r>
+              <a:rPr lang="es-ES" sz="2200" b="1" dirty="0">
+                <a:solidFill>
+                  <a:schemeClr val="bg1"/>
+                </a:solidFill>
+                <a:latin typeface="Arial Black"/>
+                <a:ea typeface="Arial Black"/>
+                <a:cs typeface="Arial Black"/>
+                <a:sym typeface="Arial Black"/>
+              </a:rPr>
+              <a:t>NOMBRE TIENDA</a:t>
+            </a:r>
+            <a:endParaRPr sz="2200" b="1" dirty="0">
+              <a:solidFill>
+                <a:schemeClr val="bg1"/>
+              </a:solidFill>
+              <a:latin typeface="Arial Black"/>
+              <a:ea typeface="Arial Black"/>
+              <a:cs typeface="Arial Black"/>
+              <a:sym typeface="Arial Black"/>
+            </a:endParaRPr>
+          </a:p>
+        </p:txBody>
+      </p:sp>
+      <p:sp>
+        <p:nvSpPr>
+          <p:cNvPr id="30" name="Google Shape;30;g3ceeff82bb2_0_39">
+            <a:extLst>
+              <a:ext uri="{FF2B5EF4-FFF2-40B4-BE49-F238E27FC236}">
+                <a16:creationId xmlns:a16="http://schemas.microsoft.com/office/drawing/2014/main" id="{7A8115F2-BEAD-2565-E273-AA37B13296CC}"/>
+              </a:ext>
+            </a:extLst>
+          </p:cNvPr>
+          <p:cNvSpPr txBox="1"/>
+          <p:nvPr/>
+        </p:nvSpPr>
+        <p:spPr>
+          <a:xfrm>
+            <a:off x="1624686" y="1084491"/>
+            <a:ext cx="2681336" cy="288803"/>
+          </a:xfrm>
+          <a:prstGeom prst="rect">
+            <a:avLst/>
+          </a:prstGeom>
+          <a:noFill/>
+          <a:ln>
+            <a:noFill/>
+          </a:ln>
+        </p:spPr>
+        <p:txBody>
+          <a:bodyPr spcFirstLastPara="1" wrap="square" lIns="36325" tIns="36325" rIns="36325" bIns="36325" anchor="t" anchorCtr="0">
+            <a:spAutoFit/>
+          </a:bodyPr>
+          <a:lstStyle/>
+          <a:p>
+            <a:pPr marL="0" marR="0" lvl="0" indent="0" algn="ctr" rtl="0">
+              <a:lnSpc>
+                <a:spcPct val="100000"/>
+              </a:lnSpc>
+              <a:spcBef>
+                <a:spcPts val="0"/>
+              </a:spcBef>
+              <a:spcAft>
+                <a:spcPts val="0"/>
+              </a:spcAft>
+              <a:buClr>
+                <a:srgbClr val="000000"/>
+              </a:buClr>
+              <a:buSzPts val="1000"/>
+              <a:buFont typeface="Arial"/>
+              <a:buNone/>
+            </a:pPr>
+            <a:r>
+              <a:rPr lang="es-ES" b="1" i="0" u="none" strike="noStrike" cap="none" dirty="0">
+                <a:solidFill>
+                  <a:srgbClr val="FFFFFF"/>
+                </a:solidFill>
+                <a:latin typeface="Arial"/>
+                <a:ea typeface="Arial"/>
+                <a:cs typeface="Arial"/>
+                <a:sym typeface="Arial"/>
+              </a:rPr>
+              <a:t>FECHA:</a:t>
             </a:r>
           </a:p>
         </p:txBody>
       </p:sp>
       <p:pic>
         <p:nvPicPr>
-          <p:cNvPr id="312" name="Google Shape;312;g3ceeff82bb2_0_1" title="89b6b83f-fbb4-4828-9c54-24dd3cb59ae3.jpg"/>
+          <p:cNvPr id="31" name="Google Shape;31;g3ceeff82bb2_0_39" title="c8d449f8-5fb3-4bb5-95ec-050b9a34d934.jpg">
+            <a:extLst>
+              <a:ext uri="{FF2B5EF4-FFF2-40B4-BE49-F238E27FC236}">
+                <a16:creationId xmlns:a16="http://schemas.microsoft.com/office/drawing/2014/main" id="{AC4BE59C-3A98-72AE-8B34-467776345EC1}"/>
+              </a:ext>
+            </a:extLst>
+          </p:cNvPr>
           <p:cNvPicPr preferRelativeResize="0"/>
           <p:nvPr/>
         </p:nvPicPr>
@@ -4002,13 +4262,13 @@
           <a:blip r:embed="rId3">
             <a:alphaModFix/>
           </a:blip>
-          <a:srcRect l="12997" r="12989"/>
+          <a:srcRect l="1057" r="1057"/>
           <a:stretch/>
         </p:blipFill>
         <p:spPr>
           <a:xfrm>
-            <a:off x="3602400" y="1887075"/>
-            <a:ext cx="5174900" cy="3933000"/>
+            <a:off x="1624686" y="1496643"/>
+            <a:ext cx="2681336" cy="2054356"/>
           </a:xfrm>
           <a:prstGeom prst="rect">
             <a:avLst/>
@@ -4019,10 +4279,1078 @@
           </a:ln>
         </p:spPr>
       </p:pic>
+      <p:pic>
+        <p:nvPicPr>
+          <p:cNvPr id="33" name="Google Shape;33;g3ceeff82bb2_0_39" title="41fe07a4-69a5-43f8-b998-ea75b2249615.jpg">
+            <a:extLst>
+              <a:ext uri="{FF2B5EF4-FFF2-40B4-BE49-F238E27FC236}">
+                <a16:creationId xmlns:a16="http://schemas.microsoft.com/office/drawing/2014/main" id="{D5226E1B-A15D-5C85-2A11-93ED6A3336DB}"/>
+              </a:ext>
+            </a:extLst>
+          </p:cNvPr>
+          <p:cNvPicPr preferRelativeResize="0"/>
+          <p:nvPr/>
+        </p:nvPicPr>
+        <p:blipFill rotWithShape="1">
+          <a:blip r:embed="rId4">
+            <a:alphaModFix/>
+          </a:blip>
+          <a:srcRect l="1057" r="1057"/>
+          <a:stretch/>
+        </p:blipFill>
+        <p:spPr>
+          <a:xfrm>
+            <a:off x="4555300" y="1496643"/>
+            <a:ext cx="2681336" cy="2054354"/>
+          </a:xfrm>
+          <a:prstGeom prst="rect">
+            <a:avLst/>
+          </a:prstGeom>
+          <a:noFill/>
+          <a:ln>
+            <a:noFill/>
+          </a:ln>
+        </p:spPr>
+      </p:pic>
+      <p:pic>
+        <p:nvPicPr>
+          <p:cNvPr id="35" name="Google Shape;35;g3ceeff82bb2_0_39" title="66b07255-4409-4a2d-bcec-05262e91b0ae.jpg">
+            <a:extLst>
+              <a:ext uri="{FF2B5EF4-FFF2-40B4-BE49-F238E27FC236}">
+                <a16:creationId xmlns:a16="http://schemas.microsoft.com/office/drawing/2014/main" id="{B2BA2009-EF44-8D44-47AF-0EE2737E8DAD}"/>
+              </a:ext>
+            </a:extLst>
+          </p:cNvPr>
+          <p:cNvPicPr preferRelativeResize="0"/>
+          <p:nvPr/>
+        </p:nvPicPr>
+        <p:blipFill rotWithShape="1">
+          <a:blip r:embed="rId5">
+            <a:alphaModFix/>
+          </a:blip>
+          <a:srcRect l="1057" r="1057"/>
+          <a:stretch/>
+        </p:blipFill>
+        <p:spPr>
+          <a:xfrm>
+            <a:off x="7485913" y="1496643"/>
+            <a:ext cx="2681336" cy="2054356"/>
+          </a:xfrm>
+          <a:prstGeom prst="rect">
+            <a:avLst/>
+          </a:prstGeom>
+          <a:noFill/>
+          <a:ln>
+            <a:noFill/>
+          </a:ln>
+        </p:spPr>
+      </p:pic>
+      <p:pic>
+        <p:nvPicPr>
+          <p:cNvPr id="3" name="Google Shape;35;g3ceeff82bb2_0_39" title="66b07255-4409-4a2d-bcec-05262e91b0ae.jpg">
+            <a:extLst>
+              <a:ext uri="{FF2B5EF4-FFF2-40B4-BE49-F238E27FC236}">
+                <a16:creationId xmlns:a16="http://schemas.microsoft.com/office/drawing/2014/main" id="{1F22EF3E-8C02-F624-1D60-EF1D06A73C92}"/>
+              </a:ext>
+            </a:extLst>
+          </p:cNvPr>
+          <p:cNvPicPr preferRelativeResize="0"/>
+          <p:nvPr/>
+        </p:nvPicPr>
+        <p:blipFill rotWithShape="1">
+          <a:blip r:embed="rId5">
+            <a:alphaModFix/>
+          </a:blip>
+          <a:srcRect l="1057" r="1057"/>
+          <a:stretch/>
+        </p:blipFill>
+        <p:spPr>
+          <a:xfrm>
+            <a:off x="3080061" y="4346442"/>
+            <a:ext cx="2681336" cy="2054356"/>
+          </a:xfrm>
+          <a:prstGeom prst="rect">
+            <a:avLst/>
+          </a:prstGeom>
+          <a:noFill/>
+          <a:ln>
+            <a:noFill/>
+          </a:ln>
+        </p:spPr>
+      </p:pic>
+      <p:sp>
+        <p:nvSpPr>
+          <p:cNvPr id="5" name="Google Shape;30;g3ceeff82bb2_0_39">
+            <a:extLst>
+              <a:ext uri="{FF2B5EF4-FFF2-40B4-BE49-F238E27FC236}">
+                <a16:creationId xmlns:a16="http://schemas.microsoft.com/office/drawing/2014/main" id="{D9B1FCB1-5238-F500-36AE-C82E6CF7D5A8}"/>
+              </a:ext>
+            </a:extLst>
+          </p:cNvPr>
+          <p:cNvSpPr txBox="1"/>
+          <p:nvPr/>
+        </p:nvSpPr>
+        <p:spPr>
+          <a:xfrm>
+            <a:off x="4555300" y="1084490"/>
+            <a:ext cx="2681336" cy="288803"/>
+          </a:xfrm>
+          <a:prstGeom prst="rect">
+            <a:avLst/>
+          </a:prstGeom>
+          <a:noFill/>
+          <a:ln>
+            <a:noFill/>
+          </a:ln>
+        </p:spPr>
+        <p:txBody>
+          <a:bodyPr spcFirstLastPara="1" wrap="square" lIns="36325" tIns="36325" rIns="36325" bIns="36325" anchor="t" anchorCtr="0">
+            <a:spAutoFit/>
+          </a:bodyPr>
+          <a:lstStyle/>
+          <a:p>
+            <a:pPr marL="0" marR="0" lvl="0" indent="0" algn="ctr" rtl="0">
+              <a:lnSpc>
+                <a:spcPct val="100000"/>
+              </a:lnSpc>
+              <a:spcBef>
+                <a:spcPts val="0"/>
+              </a:spcBef>
+              <a:spcAft>
+                <a:spcPts val="0"/>
+              </a:spcAft>
+              <a:buClr>
+                <a:srgbClr val="000000"/>
+              </a:buClr>
+              <a:buSzPts val="1000"/>
+              <a:buFont typeface="Arial"/>
+              <a:buNone/>
+            </a:pPr>
+            <a:r>
+              <a:rPr lang="es-ES" b="1" i="0" u="none" strike="noStrike" cap="none" dirty="0">
+                <a:solidFill>
+                  <a:srgbClr val="FFFFFF"/>
+                </a:solidFill>
+                <a:latin typeface="Arial"/>
+                <a:ea typeface="Arial"/>
+                <a:cs typeface="Arial"/>
+                <a:sym typeface="Arial"/>
+              </a:rPr>
+              <a:t>FECHA:</a:t>
+            </a:r>
+          </a:p>
+        </p:txBody>
+      </p:sp>
+      <p:sp>
+        <p:nvSpPr>
+          <p:cNvPr id="6" name="Google Shape;30;g3ceeff82bb2_0_39">
+            <a:extLst>
+              <a:ext uri="{FF2B5EF4-FFF2-40B4-BE49-F238E27FC236}">
+                <a16:creationId xmlns:a16="http://schemas.microsoft.com/office/drawing/2014/main" id="{25E245DA-B75B-3315-2F11-251428B83082}"/>
+              </a:ext>
+            </a:extLst>
+          </p:cNvPr>
+          <p:cNvSpPr txBox="1"/>
+          <p:nvPr/>
+        </p:nvSpPr>
+        <p:spPr>
+          <a:xfrm>
+            <a:off x="7475115" y="1084489"/>
+            <a:ext cx="2681336" cy="288803"/>
+          </a:xfrm>
+          <a:prstGeom prst="rect">
+            <a:avLst/>
+          </a:prstGeom>
+          <a:noFill/>
+          <a:ln>
+            <a:noFill/>
+          </a:ln>
+        </p:spPr>
+        <p:txBody>
+          <a:bodyPr spcFirstLastPara="1" wrap="square" lIns="36325" tIns="36325" rIns="36325" bIns="36325" anchor="t" anchorCtr="0">
+            <a:spAutoFit/>
+          </a:bodyPr>
+          <a:lstStyle/>
+          <a:p>
+            <a:pPr marL="0" marR="0" lvl="0" indent="0" algn="ctr" rtl="0">
+              <a:lnSpc>
+                <a:spcPct val="100000"/>
+              </a:lnSpc>
+              <a:spcBef>
+                <a:spcPts val="0"/>
+              </a:spcBef>
+              <a:spcAft>
+                <a:spcPts val="0"/>
+              </a:spcAft>
+              <a:buClr>
+                <a:srgbClr val="000000"/>
+              </a:buClr>
+              <a:buSzPts val="1000"/>
+              <a:buFont typeface="Arial"/>
+              <a:buNone/>
+            </a:pPr>
+            <a:r>
+              <a:rPr lang="es-ES" b="1" i="0" u="none" strike="noStrike" cap="none" dirty="0">
+                <a:solidFill>
+                  <a:srgbClr val="FFFFFF"/>
+                </a:solidFill>
+                <a:latin typeface="Arial"/>
+                <a:ea typeface="Arial"/>
+                <a:cs typeface="Arial"/>
+                <a:sym typeface="Arial"/>
+              </a:rPr>
+              <a:t>FECHA:</a:t>
+            </a:r>
+          </a:p>
+        </p:txBody>
+      </p:sp>
+      <p:sp>
+        <p:nvSpPr>
+          <p:cNvPr id="7" name="Google Shape;30;g3ceeff82bb2_0_39">
+            <a:extLst>
+              <a:ext uri="{FF2B5EF4-FFF2-40B4-BE49-F238E27FC236}">
+                <a16:creationId xmlns:a16="http://schemas.microsoft.com/office/drawing/2014/main" id="{0E3087A1-016C-D98F-FF95-F58B1EB3094A}"/>
+              </a:ext>
+            </a:extLst>
+          </p:cNvPr>
+          <p:cNvSpPr txBox="1"/>
+          <p:nvPr/>
+        </p:nvSpPr>
+        <p:spPr>
+          <a:xfrm>
+            <a:off x="3058795" y="3934290"/>
+            <a:ext cx="2681336" cy="288803"/>
+          </a:xfrm>
+          <a:prstGeom prst="rect">
+            <a:avLst/>
+          </a:prstGeom>
+          <a:noFill/>
+          <a:ln>
+            <a:noFill/>
+          </a:ln>
+        </p:spPr>
+        <p:txBody>
+          <a:bodyPr spcFirstLastPara="1" wrap="square" lIns="36325" tIns="36325" rIns="36325" bIns="36325" anchor="t" anchorCtr="0">
+            <a:spAutoFit/>
+          </a:bodyPr>
+          <a:lstStyle/>
+          <a:p>
+            <a:pPr marL="0" marR="0" lvl="0" indent="0" algn="ctr" rtl="0">
+              <a:lnSpc>
+                <a:spcPct val="100000"/>
+              </a:lnSpc>
+              <a:spcBef>
+                <a:spcPts val="0"/>
+              </a:spcBef>
+              <a:spcAft>
+                <a:spcPts val="0"/>
+              </a:spcAft>
+              <a:buClr>
+                <a:srgbClr val="000000"/>
+              </a:buClr>
+              <a:buSzPts val="1000"/>
+              <a:buFont typeface="Arial"/>
+              <a:buNone/>
+            </a:pPr>
+            <a:r>
+              <a:rPr lang="es-ES" b="1" i="0" u="none" strike="noStrike" cap="none" dirty="0">
+                <a:solidFill>
+                  <a:srgbClr val="FFFFFF"/>
+                </a:solidFill>
+                <a:latin typeface="Arial"/>
+                <a:ea typeface="Arial"/>
+                <a:cs typeface="Arial"/>
+                <a:sym typeface="Arial"/>
+              </a:rPr>
+              <a:t>FECHA:</a:t>
+            </a:r>
+          </a:p>
+        </p:txBody>
+      </p:sp>
+      <p:pic>
+        <p:nvPicPr>
+          <p:cNvPr id="2" name="Google Shape;35;g3ceeff82bb2_0_39" title="66b07255-4409-4a2d-bcec-05262e91b0ae.jpg">
+            <a:extLst>
+              <a:ext uri="{FF2B5EF4-FFF2-40B4-BE49-F238E27FC236}">
+                <a16:creationId xmlns:a16="http://schemas.microsoft.com/office/drawing/2014/main" id="{A9E89C26-7176-79BE-BEBE-095D3F37ABB1}"/>
+              </a:ext>
+            </a:extLst>
+          </p:cNvPr>
+          <p:cNvPicPr preferRelativeResize="0"/>
+          <p:nvPr/>
+        </p:nvPicPr>
+        <p:blipFill rotWithShape="1">
+          <a:blip r:embed="rId5">
+            <a:alphaModFix/>
+          </a:blip>
+          <a:srcRect l="1057" r="1057"/>
+          <a:stretch/>
+        </p:blipFill>
+        <p:spPr>
+          <a:xfrm>
+            <a:off x="6018192" y="4346442"/>
+            <a:ext cx="2681336" cy="2054356"/>
+          </a:xfrm>
+          <a:prstGeom prst="rect">
+            <a:avLst/>
+          </a:prstGeom>
+          <a:noFill/>
+          <a:ln>
+            <a:noFill/>
+          </a:ln>
+        </p:spPr>
+      </p:pic>
+      <p:sp>
+        <p:nvSpPr>
+          <p:cNvPr id="8" name="Google Shape;30;g3ceeff82bb2_0_39">
+            <a:extLst>
+              <a:ext uri="{FF2B5EF4-FFF2-40B4-BE49-F238E27FC236}">
+                <a16:creationId xmlns:a16="http://schemas.microsoft.com/office/drawing/2014/main" id="{E9C4CF50-633C-E1E7-CE74-D984847B9EAF}"/>
+              </a:ext>
+            </a:extLst>
+          </p:cNvPr>
+          <p:cNvSpPr txBox="1"/>
+          <p:nvPr/>
+        </p:nvSpPr>
+        <p:spPr>
+          <a:xfrm>
+            <a:off x="5996926" y="3934290"/>
+            <a:ext cx="2681336" cy="288803"/>
+          </a:xfrm>
+          <a:prstGeom prst="rect">
+            <a:avLst/>
+          </a:prstGeom>
+          <a:noFill/>
+          <a:ln>
+            <a:noFill/>
+          </a:ln>
+        </p:spPr>
+        <p:txBody>
+          <a:bodyPr spcFirstLastPara="1" wrap="square" lIns="36325" tIns="36325" rIns="36325" bIns="36325" anchor="t" anchorCtr="0">
+            <a:spAutoFit/>
+          </a:bodyPr>
+          <a:lstStyle/>
+          <a:p>
+            <a:pPr marL="0" marR="0" lvl="0" indent="0" algn="ctr" rtl="0">
+              <a:lnSpc>
+                <a:spcPct val="100000"/>
+              </a:lnSpc>
+              <a:spcBef>
+                <a:spcPts val="0"/>
+              </a:spcBef>
+              <a:spcAft>
+                <a:spcPts val="0"/>
+              </a:spcAft>
+              <a:buClr>
+                <a:srgbClr val="000000"/>
+              </a:buClr>
+              <a:buSzPts val="1000"/>
+              <a:buFont typeface="Arial"/>
+              <a:buNone/>
+            </a:pPr>
+            <a:r>
+              <a:rPr lang="es-ES" b="1" i="0" u="none" strike="noStrike" cap="none" dirty="0">
+                <a:solidFill>
+                  <a:srgbClr val="FFFFFF"/>
+                </a:solidFill>
+                <a:latin typeface="Arial"/>
+                <a:ea typeface="Arial"/>
+                <a:cs typeface="Arial"/>
+                <a:sym typeface="Arial"/>
+              </a:rPr>
+              <a:t>FECHA:</a:t>
+            </a:r>
+          </a:p>
+        </p:txBody>
+      </p:sp>
     </p:spTree>
     <p:extLst>
       <p:ext uri="{BB962C8B-B14F-4D97-AF65-F5344CB8AC3E}">
-        <p14:creationId xmlns:p14="http://schemas.microsoft.com/office/powerpoint/2010/main" val="214102958"/>
+        <p14:creationId xmlns:p14="http://schemas.microsoft.com/office/powerpoint/2010/main" val="2548902095"/>
+      </p:ext>
+    </p:extLst>
+  </p:cSld>
+  <p:clrMapOvr>
+    <a:masterClrMapping/>
+  </p:clrMapOvr>
+</p:sld>
+</file>
+
+<file path=ppt/slides/slide8.xml><?xml version="1.0" encoding="utf-8"?>
+<p:sld xmlns:a="http://schemas.openxmlformats.org/drawingml/2006/main" xmlns:r="http://schemas.openxmlformats.org/officeDocument/2006/relationships" xmlns:p="http://schemas.openxmlformats.org/presentationml/2006/main">
+  <p:cSld>
+    <p:spTree>
+      <p:nvGrpSpPr>
+        <p:cNvPr id="1" name="Shape 28">
+          <a:extLst>
+            <a:ext uri="{FF2B5EF4-FFF2-40B4-BE49-F238E27FC236}">
+              <a16:creationId xmlns:a16="http://schemas.microsoft.com/office/drawing/2014/main" id="{1FF8E3B3-D1F2-3D09-B5B2-7EE99CA88370}"/>
+            </a:ext>
+          </a:extLst>
+        </p:cNvPr>
+        <p:cNvGrpSpPr/>
+        <p:nvPr/>
+      </p:nvGrpSpPr>
+      <p:grpSpPr>
+        <a:xfrm>
+          <a:off x="0" y="0"/>
+          <a:ext cx="0" cy="0"/>
+          <a:chOff x="0" y="0"/>
+          <a:chExt cx="0" cy="0"/>
+        </a:xfrm>
+      </p:grpSpPr>
+      <p:sp>
+        <p:nvSpPr>
+          <p:cNvPr id="29" name="Google Shape;29;g3ceeff82bb2_0_39">
+            <a:extLst>
+              <a:ext uri="{FF2B5EF4-FFF2-40B4-BE49-F238E27FC236}">
+                <a16:creationId xmlns:a16="http://schemas.microsoft.com/office/drawing/2014/main" id="{773AA8E5-0287-8F87-078E-9A27C6FC303A}"/>
+              </a:ext>
+            </a:extLst>
+          </p:cNvPr>
+          <p:cNvSpPr txBox="1"/>
+          <p:nvPr/>
+        </p:nvSpPr>
+        <p:spPr>
+          <a:xfrm>
+            <a:off x="499380" y="263800"/>
+            <a:ext cx="10972800" cy="430800"/>
+          </a:xfrm>
+          <a:prstGeom prst="rect">
+            <a:avLst/>
+          </a:prstGeom>
+          <a:noFill/>
+          <a:ln>
+            <a:noFill/>
+          </a:ln>
+        </p:spPr>
+        <p:txBody>
+          <a:bodyPr spcFirstLastPara="1" wrap="square" lIns="91425" tIns="45700" rIns="91425" bIns="45700" anchor="t" anchorCtr="0">
+            <a:spAutoFit/>
+          </a:bodyPr>
+          <a:lstStyle/>
+          <a:p>
+            <a:pPr marL="0" marR="0" lvl="0" indent="0" algn="l" rtl="0">
+              <a:lnSpc>
+                <a:spcPct val="100000"/>
+              </a:lnSpc>
+              <a:spcBef>
+                <a:spcPts val="0"/>
+              </a:spcBef>
+              <a:spcAft>
+                <a:spcPts val="0"/>
+              </a:spcAft>
+              <a:buClr>
+                <a:srgbClr val="000000"/>
+              </a:buClr>
+              <a:buSzPts val="2400"/>
+              <a:buFont typeface="Arial"/>
+              <a:buNone/>
+            </a:pPr>
+            <a:r>
+              <a:rPr lang="es-ES" sz="2200" b="1" dirty="0">
+                <a:solidFill>
+                  <a:schemeClr val="bg1"/>
+                </a:solidFill>
+                <a:latin typeface="Arial Black"/>
+                <a:ea typeface="Arial Black"/>
+                <a:cs typeface="Arial Black"/>
+                <a:sym typeface="Arial Black"/>
+              </a:rPr>
+              <a:t>NOMBRE TIENDA</a:t>
+            </a:r>
+            <a:endParaRPr sz="2200" b="1" dirty="0">
+              <a:solidFill>
+                <a:schemeClr val="bg1"/>
+              </a:solidFill>
+              <a:latin typeface="Arial Black"/>
+              <a:ea typeface="Arial Black"/>
+              <a:cs typeface="Arial Black"/>
+              <a:sym typeface="Arial Black"/>
+            </a:endParaRPr>
+          </a:p>
+        </p:txBody>
+      </p:sp>
+      <p:sp>
+        <p:nvSpPr>
+          <p:cNvPr id="30" name="Google Shape;30;g3ceeff82bb2_0_39">
+            <a:extLst>
+              <a:ext uri="{FF2B5EF4-FFF2-40B4-BE49-F238E27FC236}">
+                <a16:creationId xmlns:a16="http://schemas.microsoft.com/office/drawing/2014/main" id="{01B686E0-B98B-4441-C11B-39245DC7E14A}"/>
+              </a:ext>
+            </a:extLst>
+          </p:cNvPr>
+          <p:cNvSpPr txBox="1"/>
+          <p:nvPr/>
+        </p:nvSpPr>
+        <p:spPr>
+          <a:xfrm>
+            <a:off x="1624686" y="1084491"/>
+            <a:ext cx="2681336" cy="288803"/>
+          </a:xfrm>
+          <a:prstGeom prst="rect">
+            <a:avLst/>
+          </a:prstGeom>
+          <a:noFill/>
+          <a:ln>
+            <a:noFill/>
+          </a:ln>
+        </p:spPr>
+        <p:txBody>
+          <a:bodyPr spcFirstLastPara="1" wrap="square" lIns="36325" tIns="36325" rIns="36325" bIns="36325" anchor="t" anchorCtr="0">
+            <a:spAutoFit/>
+          </a:bodyPr>
+          <a:lstStyle/>
+          <a:p>
+            <a:pPr marL="0" marR="0" lvl="0" indent="0" algn="ctr" rtl="0">
+              <a:lnSpc>
+                <a:spcPct val="100000"/>
+              </a:lnSpc>
+              <a:spcBef>
+                <a:spcPts val="0"/>
+              </a:spcBef>
+              <a:spcAft>
+                <a:spcPts val="0"/>
+              </a:spcAft>
+              <a:buClr>
+                <a:srgbClr val="000000"/>
+              </a:buClr>
+              <a:buSzPts val="1000"/>
+              <a:buFont typeface="Arial"/>
+              <a:buNone/>
+            </a:pPr>
+            <a:r>
+              <a:rPr lang="es-ES" b="1" i="0" u="none" strike="noStrike" cap="none" dirty="0">
+                <a:solidFill>
+                  <a:srgbClr val="FFFFFF"/>
+                </a:solidFill>
+                <a:latin typeface="Arial"/>
+                <a:ea typeface="Arial"/>
+                <a:cs typeface="Arial"/>
+                <a:sym typeface="Arial"/>
+              </a:rPr>
+              <a:t>FECHA:</a:t>
+            </a:r>
+          </a:p>
+        </p:txBody>
+      </p:sp>
+      <p:pic>
+        <p:nvPicPr>
+          <p:cNvPr id="31" name="Google Shape;31;g3ceeff82bb2_0_39" title="c8d449f8-5fb3-4bb5-95ec-050b9a34d934.jpg">
+            <a:extLst>
+              <a:ext uri="{FF2B5EF4-FFF2-40B4-BE49-F238E27FC236}">
+                <a16:creationId xmlns:a16="http://schemas.microsoft.com/office/drawing/2014/main" id="{E78A91A6-2B7E-0D91-2E6F-9488B26AF54E}"/>
+              </a:ext>
+            </a:extLst>
+          </p:cNvPr>
+          <p:cNvPicPr preferRelativeResize="0"/>
+          <p:nvPr/>
+        </p:nvPicPr>
+        <p:blipFill rotWithShape="1">
+          <a:blip r:embed="rId3">
+            <a:alphaModFix/>
+          </a:blip>
+          <a:srcRect l="1057" r="1057"/>
+          <a:stretch/>
+        </p:blipFill>
+        <p:spPr>
+          <a:xfrm>
+            <a:off x="1624686" y="1496643"/>
+            <a:ext cx="2681336" cy="2054356"/>
+          </a:xfrm>
+          <a:prstGeom prst="rect">
+            <a:avLst/>
+          </a:prstGeom>
+          <a:noFill/>
+          <a:ln>
+            <a:noFill/>
+          </a:ln>
+        </p:spPr>
+      </p:pic>
+      <p:pic>
+        <p:nvPicPr>
+          <p:cNvPr id="33" name="Google Shape;33;g3ceeff82bb2_0_39" title="41fe07a4-69a5-43f8-b998-ea75b2249615.jpg">
+            <a:extLst>
+              <a:ext uri="{FF2B5EF4-FFF2-40B4-BE49-F238E27FC236}">
+                <a16:creationId xmlns:a16="http://schemas.microsoft.com/office/drawing/2014/main" id="{C4F2EC3A-074A-0D12-136C-AD78D0C5C332}"/>
+              </a:ext>
+            </a:extLst>
+          </p:cNvPr>
+          <p:cNvPicPr preferRelativeResize="0"/>
+          <p:nvPr/>
+        </p:nvPicPr>
+        <p:blipFill rotWithShape="1">
+          <a:blip r:embed="rId4">
+            <a:alphaModFix/>
+          </a:blip>
+          <a:srcRect l="1057" r="1057"/>
+          <a:stretch/>
+        </p:blipFill>
+        <p:spPr>
+          <a:xfrm>
+            <a:off x="4555300" y="1496643"/>
+            <a:ext cx="2681336" cy="2054354"/>
+          </a:xfrm>
+          <a:prstGeom prst="rect">
+            <a:avLst/>
+          </a:prstGeom>
+          <a:noFill/>
+          <a:ln>
+            <a:noFill/>
+          </a:ln>
+        </p:spPr>
+      </p:pic>
+      <p:pic>
+        <p:nvPicPr>
+          <p:cNvPr id="35" name="Google Shape;35;g3ceeff82bb2_0_39" title="66b07255-4409-4a2d-bcec-05262e91b0ae.jpg">
+            <a:extLst>
+              <a:ext uri="{FF2B5EF4-FFF2-40B4-BE49-F238E27FC236}">
+                <a16:creationId xmlns:a16="http://schemas.microsoft.com/office/drawing/2014/main" id="{373926E3-D425-09FC-9D5F-1D8A53810BE7}"/>
+              </a:ext>
+            </a:extLst>
+          </p:cNvPr>
+          <p:cNvPicPr preferRelativeResize="0"/>
+          <p:nvPr/>
+        </p:nvPicPr>
+        <p:blipFill rotWithShape="1">
+          <a:blip r:embed="rId5">
+            <a:alphaModFix/>
+          </a:blip>
+          <a:srcRect l="1057" r="1057"/>
+          <a:stretch/>
+        </p:blipFill>
+        <p:spPr>
+          <a:xfrm>
+            <a:off x="7485913" y="1496643"/>
+            <a:ext cx="2681336" cy="2054356"/>
+          </a:xfrm>
+          <a:prstGeom prst="rect">
+            <a:avLst/>
+          </a:prstGeom>
+          <a:noFill/>
+          <a:ln>
+            <a:noFill/>
+          </a:ln>
+        </p:spPr>
+      </p:pic>
+      <p:sp>
+        <p:nvSpPr>
+          <p:cNvPr id="5" name="Google Shape;30;g3ceeff82bb2_0_39">
+            <a:extLst>
+              <a:ext uri="{FF2B5EF4-FFF2-40B4-BE49-F238E27FC236}">
+                <a16:creationId xmlns:a16="http://schemas.microsoft.com/office/drawing/2014/main" id="{637CA0C7-7351-D78E-9618-0A35F2451254}"/>
+              </a:ext>
+            </a:extLst>
+          </p:cNvPr>
+          <p:cNvSpPr txBox="1"/>
+          <p:nvPr/>
+        </p:nvSpPr>
+        <p:spPr>
+          <a:xfrm>
+            <a:off x="4555300" y="1084490"/>
+            <a:ext cx="2681336" cy="288803"/>
+          </a:xfrm>
+          <a:prstGeom prst="rect">
+            <a:avLst/>
+          </a:prstGeom>
+          <a:noFill/>
+          <a:ln>
+            <a:noFill/>
+          </a:ln>
+        </p:spPr>
+        <p:txBody>
+          <a:bodyPr spcFirstLastPara="1" wrap="square" lIns="36325" tIns="36325" rIns="36325" bIns="36325" anchor="t" anchorCtr="0">
+            <a:spAutoFit/>
+          </a:bodyPr>
+          <a:lstStyle/>
+          <a:p>
+            <a:pPr marL="0" marR="0" lvl="0" indent="0" algn="ctr" rtl="0">
+              <a:lnSpc>
+                <a:spcPct val="100000"/>
+              </a:lnSpc>
+              <a:spcBef>
+                <a:spcPts val="0"/>
+              </a:spcBef>
+              <a:spcAft>
+                <a:spcPts val="0"/>
+              </a:spcAft>
+              <a:buClr>
+                <a:srgbClr val="000000"/>
+              </a:buClr>
+              <a:buSzPts val="1000"/>
+              <a:buFont typeface="Arial"/>
+              <a:buNone/>
+            </a:pPr>
+            <a:r>
+              <a:rPr lang="es-ES" b="1" i="0" u="none" strike="noStrike" cap="none" dirty="0">
+                <a:solidFill>
+                  <a:srgbClr val="FFFFFF"/>
+                </a:solidFill>
+                <a:latin typeface="Arial"/>
+                <a:ea typeface="Arial"/>
+                <a:cs typeface="Arial"/>
+                <a:sym typeface="Arial"/>
+              </a:rPr>
+              <a:t>FECHA:</a:t>
+            </a:r>
+          </a:p>
+        </p:txBody>
+      </p:sp>
+      <p:sp>
+        <p:nvSpPr>
+          <p:cNvPr id="6" name="Google Shape;30;g3ceeff82bb2_0_39">
+            <a:extLst>
+              <a:ext uri="{FF2B5EF4-FFF2-40B4-BE49-F238E27FC236}">
+                <a16:creationId xmlns:a16="http://schemas.microsoft.com/office/drawing/2014/main" id="{AE002662-0C42-16D4-6A27-A73C361C91F6}"/>
+              </a:ext>
+            </a:extLst>
+          </p:cNvPr>
+          <p:cNvSpPr txBox="1"/>
+          <p:nvPr/>
+        </p:nvSpPr>
+        <p:spPr>
+          <a:xfrm>
+            <a:off x="7475115" y="1084489"/>
+            <a:ext cx="2681336" cy="288803"/>
+          </a:xfrm>
+          <a:prstGeom prst="rect">
+            <a:avLst/>
+          </a:prstGeom>
+          <a:noFill/>
+          <a:ln>
+            <a:noFill/>
+          </a:ln>
+        </p:spPr>
+        <p:txBody>
+          <a:bodyPr spcFirstLastPara="1" wrap="square" lIns="36325" tIns="36325" rIns="36325" bIns="36325" anchor="t" anchorCtr="0">
+            <a:spAutoFit/>
+          </a:bodyPr>
+          <a:lstStyle/>
+          <a:p>
+            <a:pPr marL="0" marR="0" lvl="0" indent="0" algn="ctr" rtl="0">
+              <a:lnSpc>
+                <a:spcPct val="100000"/>
+              </a:lnSpc>
+              <a:spcBef>
+                <a:spcPts val="0"/>
+              </a:spcBef>
+              <a:spcAft>
+                <a:spcPts val="0"/>
+              </a:spcAft>
+              <a:buClr>
+                <a:srgbClr val="000000"/>
+              </a:buClr>
+              <a:buSzPts val="1000"/>
+              <a:buFont typeface="Arial"/>
+              <a:buNone/>
+            </a:pPr>
+            <a:r>
+              <a:rPr lang="es-ES" b="1" i="0" u="none" strike="noStrike" cap="none" dirty="0">
+                <a:solidFill>
+                  <a:srgbClr val="FFFFFF"/>
+                </a:solidFill>
+                <a:latin typeface="Arial"/>
+                <a:ea typeface="Arial"/>
+                <a:cs typeface="Arial"/>
+                <a:sym typeface="Arial"/>
+              </a:rPr>
+              <a:t>FECHA:</a:t>
+            </a:r>
+          </a:p>
+        </p:txBody>
+      </p:sp>
+      <p:sp>
+        <p:nvSpPr>
+          <p:cNvPr id="4" name="Google Shape;30;g3ceeff82bb2_0_39">
+            <a:extLst>
+              <a:ext uri="{FF2B5EF4-FFF2-40B4-BE49-F238E27FC236}">
+                <a16:creationId xmlns:a16="http://schemas.microsoft.com/office/drawing/2014/main" id="{945E2092-7796-2F80-E3FC-962ADC59E9A0}"/>
+              </a:ext>
+            </a:extLst>
+          </p:cNvPr>
+          <p:cNvSpPr txBox="1"/>
+          <p:nvPr/>
+        </p:nvSpPr>
+        <p:spPr>
+          <a:xfrm>
+            <a:off x="1613888" y="3831235"/>
+            <a:ext cx="2681336" cy="288803"/>
+          </a:xfrm>
+          <a:prstGeom prst="rect">
+            <a:avLst/>
+          </a:prstGeom>
+          <a:noFill/>
+          <a:ln>
+            <a:noFill/>
+          </a:ln>
+        </p:spPr>
+        <p:txBody>
+          <a:bodyPr spcFirstLastPara="1" wrap="square" lIns="36325" tIns="36325" rIns="36325" bIns="36325" anchor="t" anchorCtr="0">
+            <a:spAutoFit/>
+          </a:bodyPr>
+          <a:lstStyle/>
+          <a:p>
+            <a:pPr marL="0" marR="0" lvl="0" indent="0" algn="ctr" rtl="0">
+              <a:lnSpc>
+                <a:spcPct val="100000"/>
+              </a:lnSpc>
+              <a:spcBef>
+                <a:spcPts val="0"/>
+              </a:spcBef>
+              <a:spcAft>
+                <a:spcPts val="0"/>
+              </a:spcAft>
+              <a:buClr>
+                <a:srgbClr val="000000"/>
+              </a:buClr>
+              <a:buSzPts val="1000"/>
+              <a:buFont typeface="Arial"/>
+              <a:buNone/>
+            </a:pPr>
+            <a:r>
+              <a:rPr lang="es-ES" b="1" i="0" u="none" strike="noStrike" cap="none" dirty="0">
+                <a:solidFill>
+                  <a:srgbClr val="FFFFFF"/>
+                </a:solidFill>
+                <a:latin typeface="Arial"/>
+                <a:ea typeface="Arial"/>
+                <a:cs typeface="Arial"/>
+                <a:sym typeface="Arial"/>
+              </a:rPr>
+              <a:t>FECHA:</a:t>
+            </a:r>
+          </a:p>
+        </p:txBody>
+      </p:sp>
+      <p:pic>
+        <p:nvPicPr>
+          <p:cNvPr id="9" name="Google Shape;31;g3ceeff82bb2_0_39" title="c8d449f8-5fb3-4bb5-95ec-050b9a34d934.jpg">
+            <a:extLst>
+              <a:ext uri="{FF2B5EF4-FFF2-40B4-BE49-F238E27FC236}">
+                <a16:creationId xmlns:a16="http://schemas.microsoft.com/office/drawing/2014/main" id="{9C453C0D-8C93-230B-4AED-F339645B88C4}"/>
+              </a:ext>
+            </a:extLst>
+          </p:cNvPr>
+          <p:cNvPicPr preferRelativeResize="0"/>
+          <p:nvPr/>
+        </p:nvPicPr>
+        <p:blipFill rotWithShape="1">
+          <a:blip r:embed="rId3">
+            <a:alphaModFix/>
+          </a:blip>
+          <a:srcRect l="1057" r="1057"/>
+          <a:stretch/>
+        </p:blipFill>
+        <p:spPr>
+          <a:xfrm>
+            <a:off x="1613888" y="4243387"/>
+            <a:ext cx="2681336" cy="2054356"/>
+          </a:xfrm>
+          <a:prstGeom prst="rect">
+            <a:avLst/>
+          </a:prstGeom>
+          <a:noFill/>
+          <a:ln>
+            <a:noFill/>
+          </a:ln>
+        </p:spPr>
+      </p:pic>
+      <p:pic>
+        <p:nvPicPr>
+          <p:cNvPr id="10" name="Google Shape;33;g3ceeff82bb2_0_39" title="41fe07a4-69a5-43f8-b998-ea75b2249615.jpg">
+            <a:extLst>
+              <a:ext uri="{FF2B5EF4-FFF2-40B4-BE49-F238E27FC236}">
+                <a16:creationId xmlns:a16="http://schemas.microsoft.com/office/drawing/2014/main" id="{563E2538-3CC3-E552-B382-7EBBF7429ACA}"/>
+              </a:ext>
+            </a:extLst>
+          </p:cNvPr>
+          <p:cNvPicPr preferRelativeResize="0"/>
+          <p:nvPr/>
+        </p:nvPicPr>
+        <p:blipFill rotWithShape="1">
+          <a:blip r:embed="rId4">
+            <a:alphaModFix/>
+          </a:blip>
+          <a:srcRect l="1057" r="1057"/>
+          <a:stretch/>
+        </p:blipFill>
+        <p:spPr>
+          <a:xfrm>
+            <a:off x="4544502" y="4243387"/>
+            <a:ext cx="2681336" cy="2054354"/>
+          </a:xfrm>
+          <a:prstGeom prst="rect">
+            <a:avLst/>
+          </a:prstGeom>
+          <a:noFill/>
+          <a:ln>
+            <a:noFill/>
+          </a:ln>
+        </p:spPr>
+      </p:pic>
+      <p:pic>
+        <p:nvPicPr>
+          <p:cNvPr id="11" name="Google Shape;35;g3ceeff82bb2_0_39" title="66b07255-4409-4a2d-bcec-05262e91b0ae.jpg">
+            <a:extLst>
+              <a:ext uri="{FF2B5EF4-FFF2-40B4-BE49-F238E27FC236}">
+                <a16:creationId xmlns:a16="http://schemas.microsoft.com/office/drawing/2014/main" id="{7B624DFA-F74E-CA6D-0390-979BF1C5C133}"/>
+              </a:ext>
+            </a:extLst>
+          </p:cNvPr>
+          <p:cNvPicPr preferRelativeResize="0"/>
+          <p:nvPr/>
+        </p:nvPicPr>
+        <p:blipFill rotWithShape="1">
+          <a:blip r:embed="rId5">
+            <a:alphaModFix/>
+          </a:blip>
+          <a:srcRect l="1057" r="1057"/>
+          <a:stretch/>
+        </p:blipFill>
+        <p:spPr>
+          <a:xfrm>
+            <a:off x="7475115" y="4243387"/>
+            <a:ext cx="2681336" cy="2054356"/>
+          </a:xfrm>
+          <a:prstGeom prst="rect">
+            <a:avLst/>
+          </a:prstGeom>
+          <a:noFill/>
+          <a:ln>
+            <a:noFill/>
+          </a:ln>
+        </p:spPr>
+      </p:pic>
+      <p:sp>
+        <p:nvSpPr>
+          <p:cNvPr id="12" name="Google Shape;30;g3ceeff82bb2_0_39">
+            <a:extLst>
+              <a:ext uri="{FF2B5EF4-FFF2-40B4-BE49-F238E27FC236}">
+                <a16:creationId xmlns:a16="http://schemas.microsoft.com/office/drawing/2014/main" id="{4A77C14F-A97B-CF62-E131-B76043AF8FAA}"/>
+              </a:ext>
+            </a:extLst>
+          </p:cNvPr>
+          <p:cNvSpPr txBox="1"/>
+          <p:nvPr/>
+        </p:nvSpPr>
+        <p:spPr>
+          <a:xfrm>
+            <a:off x="4544502" y="3831234"/>
+            <a:ext cx="2681336" cy="288803"/>
+          </a:xfrm>
+          <a:prstGeom prst="rect">
+            <a:avLst/>
+          </a:prstGeom>
+          <a:noFill/>
+          <a:ln>
+            <a:noFill/>
+          </a:ln>
+        </p:spPr>
+        <p:txBody>
+          <a:bodyPr spcFirstLastPara="1" wrap="square" lIns="36325" tIns="36325" rIns="36325" bIns="36325" anchor="t" anchorCtr="0">
+            <a:spAutoFit/>
+          </a:bodyPr>
+          <a:lstStyle/>
+          <a:p>
+            <a:pPr marL="0" marR="0" lvl="0" indent="0" algn="ctr" rtl="0">
+              <a:lnSpc>
+                <a:spcPct val="100000"/>
+              </a:lnSpc>
+              <a:spcBef>
+                <a:spcPts val="0"/>
+              </a:spcBef>
+              <a:spcAft>
+                <a:spcPts val="0"/>
+              </a:spcAft>
+              <a:buClr>
+                <a:srgbClr val="000000"/>
+              </a:buClr>
+              <a:buSzPts val="1000"/>
+              <a:buFont typeface="Arial"/>
+              <a:buNone/>
+            </a:pPr>
+            <a:r>
+              <a:rPr lang="es-ES" b="1" i="0" u="none" strike="noStrike" cap="none" dirty="0">
+                <a:solidFill>
+                  <a:srgbClr val="FFFFFF"/>
+                </a:solidFill>
+                <a:latin typeface="Arial"/>
+                <a:ea typeface="Arial"/>
+                <a:cs typeface="Arial"/>
+                <a:sym typeface="Arial"/>
+              </a:rPr>
+              <a:t>FECHA:</a:t>
+            </a:r>
+          </a:p>
+        </p:txBody>
+      </p:sp>
+      <p:sp>
+        <p:nvSpPr>
+          <p:cNvPr id="13" name="Google Shape;30;g3ceeff82bb2_0_39">
+            <a:extLst>
+              <a:ext uri="{FF2B5EF4-FFF2-40B4-BE49-F238E27FC236}">
+                <a16:creationId xmlns:a16="http://schemas.microsoft.com/office/drawing/2014/main" id="{F073BB2A-D902-DE61-D915-165EA04D3793}"/>
+              </a:ext>
+            </a:extLst>
+          </p:cNvPr>
+          <p:cNvSpPr txBox="1"/>
+          <p:nvPr/>
+        </p:nvSpPr>
+        <p:spPr>
+          <a:xfrm>
+            <a:off x="7464317" y="3831233"/>
+            <a:ext cx="2681336" cy="288803"/>
+          </a:xfrm>
+          <a:prstGeom prst="rect">
+            <a:avLst/>
+          </a:prstGeom>
+          <a:noFill/>
+          <a:ln>
+            <a:noFill/>
+          </a:ln>
+        </p:spPr>
+        <p:txBody>
+          <a:bodyPr spcFirstLastPara="1" wrap="square" lIns="36325" tIns="36325" rIns="36325" bIns="36325" anchor="t" anchorCtr="0">
+            <a:spAutoFit/>
+          </a:bodyPr>
+          <a:lstStyle/>
+          <a:p>
+            <a:pPr marL="0" marR="0" lvl="0" indent="0" algn="ctr" rtl="0">
+              <a:lnSpc>
+                <a:spcPct val="100000"/>
+              </a:lnSpc>
+              <a:spcBef>
+                <a:spcPts val="0"/>
+              </a:spcBef>
+              <a:spcAft>
+                <a:spcPts val="0"/>
+              </a:spcAft>
+              <a:buClr>
+                <a:srgbClr val="000000"/>
+              </a:buClr>
+              <a:buSzPts val="1000"/>
+              <a:buFont typeface="Arial"/>
+              <a:buNone/>
+            </a:pPr>
+            <a:r>
+              <a:rPr lang="es-ES" b="1" i="0" u="none" strike="noStrike" cap="none" dirty="0">
+                <a:solidFill>
+                  <a:srgbClr val="FFFFFF"/>
+                </a:solidFill>
+                <a:latin typeface="Arial"/>
+                <a:ea typeface="Arial"/>
+                <a:cs typeface="Arial"/>
+                <a:sym typeface="Arial"/>
+              </a:rPr>
+              <a:t>FECHA:</a:t>
+            </a:r>
+          </a:p>
+        </p:txBody>
+      </p:sp>
+    </p:spTree>
+    <p:extLst>
+      <p:ext uri="{BB962C8B-B14F-4D97-AF65-F5344CB8AC3E}">
+        <p14:creationId xmlns:p14="http://schemas.microsoft.com/office/powerpoint/2010/main" val="1936137184"/>
       </p:ext>
     </p:extLst>
   </p:cSld>

</xml_diff>

<commit_message>
feat: new template Template Sell-Out.pptx + output filename from template
- Replace Termplate.pptx with Template Sell-Out.pptx (9-slide structure)
  Slides: title, chain-intro, 1p, 2p, 3p, 5p, 4p, 6p, closing
- Auto-detect template layout (8-slide or 9-slide) in _detect_template_layout()
- Copy closing slide at end of output PPTX when template has 9 slides
- app.py: TEMPLATE_PPTX now points to "Template Sell-Out.pptx"
- app.py: output filename = template filename (default or uploaded)
  e.g. default output = "Template Sell-Out.pptx"; custom upload keeps its name
- /download endpoint uses stored output_name from job dict
</commit_message>
<xml_diff>
--- a/Termplate.pptx
+++ b/Termplate.pptx
@@ -5,32 +5,30 @@
     <p:sldMasterId id="2147483657" r:id="rId1"/>
   </p:sldMasterIdLst>
   <p:notesMasterIdLst>
-    <p:notesMasterId r:id="rId10"/>
+    <p:notesMasterId r:id="rId8"/>
   </p:notesMasterIdLst>
   <p:sldIdLst>
     <p:sldId id="377" r:id="rId2"/>
-    <p:sldId id="400" r:id="rId3"/>
-    <p:sldId id="391" r:id="rId4"/>
+    <p:sldId id="391" r:id="rId3"/>
+    <p:sldId id="392" r:id="rId4"/>
     <p:sldId id="395" r:id="rId5"/>
-    <p:sldId id="402" r:id="rId6"/>
-    <p:sldId id="403" r:id="rId7"/>
-    <p:sldId id="404" r:id="rId8"/>
-    <p:sldId id="405" r:id="rId9"/>
+    <p:sldId id="398" r:id="rId6"/>
+    <p:sldId id="399" r:id="rId7"/>
   </p:sldIdLst>
   <p:sldSz cx="12192000" cy="6858000"/>
   <p:notesSz cx="6858000" cy="9144000"/>
   <p:embeddedFontLst>
     <p:embeddedFont>
       <p:font typeface="Arial Black" panose="020B0604020202020204" pitchFamily="34" charset="0"/>
-      <p:regular r:id="rId11"/>
-      <p:bold r:id="rId12"/>
+      <p:regular r:id="rId9"/>
+      <p:bold r:id="rId10"/>
     </p:embeddedFont>
     <p:embeddedFont>
       <p:font typeface="Montserrat SemiBold" panose="00000700000000000000" pitchFamily="2" charset="77"/>
-      <p:regular r:id="rId13"/>
-      <p:bold r:id="rId14"/>
-      <p:italic r:id="rId15"/>
-      <p:boldItalic r:id="rId16"/>
+      <p:regular r:id="rId11"/>
+      <p:bold r:id="rId12"/>
+      <p:italic r:id="rId13"/>
+      <p:boldItalic r:id="rId14"/>
     </p:embeddedFont>
   </p:embeddedFontLst>
   <p:defaultTextStyle>
@@ -976,6 +974,128 @@
   <p:cSld>
     <p:spTree>
       <p:nvGrpSpPr>
+        <p:cNvPr id="1" name="Shape 36"/>
+        <p:cNvGrpSpPr/>
+        <p:nvPr/>
+      </p:nvGrpSpPr>
+      <p:grpSpPr>
+        <a:xfrm>
+          <a:off x="0" y="0"/>
+          <a:ext cx="0" cy="0"/>
+          <a:chOff x="0" y="0"/>
+          <a:chExt cx="0" cy="0"/>
+        </a:xfrm>
+      </p:grpSpPr>
+      <p:sp>
+        <p:nvSpPr>
+          <p:cNvPr id="37" name="Google Shape;37;g3d777708fde_0_57:notes"/>
+          <p:cNvSpPr txBox="1">
+            <a:spLocks noGrp="1"/>
+          </p:cNvSpPr>
+          <p:nvPr>
+            <p:ph type="body" idx="1"/>
+          </p:nvPr>
+        </p:nvSpPr>
+        <p:spPr>
+          <a:xfrm>
+            <a:off x="685800" y="4343400"/>
+            <a:ext cx="5486400" cy="4114800"/>
+          </a:xfrm>
+          <a:prstGeom prst="rect">
+            <a:avLst/>
+          </a:prstGeom>
+          <a:noFill/>
+          <a:ln>
+            <a:noFill/>
+          </a:ln>
+        </p:spPr>
+        <p:txBody>
+          <a:bodyPr spcFirstLastPara="1" wrap="square" lIns="91425" tIns="91425" rIns="91425" bIns="91425" anchor="t" anchorCtr="0">
+            <a:noAutofit/>
+          </a:bodyPr>
+          <a:lstStyle/>
+          <a:p>
+            <a:pPr marL="0" lvl="0" indent="0" algn="l" rtl="0">
+              <a:lnSpc>
+                <a:spcPct val="100000"/>
+              </a:lnSpc>
+              <a:spcBef>
+                <a:spcPts val="0"/>
+              </a:spcBef>
+              <a:spcAft>
+                <a:spcPts val="0"/>
+              </a:spcAft>
+              <a:buSzPts val="1100"/>
+              <a:buNone/>
+            </a:pPr>
+            <a:endParaRPr/>
+          </a:p>
+        </p:txBody>
+      </p:sp>
+      <p:sp>
+        <p:nvSpPr>
+          <p:cNvPr id="38" name="Google Shape;38;g3d777708fde_0_57:notes"/>
+          <p:cNvSpPr>
+            <a:spLocks noGrp="1" noRot="1" noChangeAspect="1"/>
+          </p:cNvSpPr>
+          <p:nvPr>
+            <p:ph type="sldImg" idx="2"/>
+          </p:nvPr>
+        </p:nvSpPr>
+        <p:spPr>
+          <a:xfrm>
+            <a:off x="381000" y="685800"/>
+            <a:ext cx="6096000" cy="3429000"/>
+          </a:xfrm>
+          <a:custGeom>
+            <a:avLst/>
+            <a:gdLst/>
+            <a:ahLst/>
+            <a:cxnLst/>
+            <a:rect l="l" t="t" r="r" b="b"/>
+            <a:pathLst>
+              <a:path w="120000" h="120000" extrusionOk="0">
+                <a:moveTo>
+                  <a:pt x="0" y="0"/>
+                </a:moveTo>
+                <a:lnTo>
+                  <a:pt x="120000" y="0"/>
+                </a:lnTo>
+                <a:lnTo>
+                  <a:pt x="120000" y="120000"/>
+                </a:lnTo>
+                <a:lnTo>
+                  <a:pt x="0" y="120000"/>
+                </a:lnTo>
+                <a:close/>
+              </a:path>
+            </a:pathLst>
+          </a:custGeom>
+          <a:noFill/>
+          <a:ln w="9525" cap="flat" cmpd="sng">
+            <a:solidFill>
+              <a:srgbClr val="000000"/>
+            </a:solidFill>
+            <a:prstDash val="solid"/>
+            <a:round/>
+            <a:headEnd type="none" w="sm" len="sm"/>
+            <a:tailEnd type="none" w="sm" len="sm"/>
+          </a:ln>
+        </p:spPr>
+      </p:sp>
+    </p:spTree>
+  </p:cSld>
+  <p:clrMapOvr>
+    <a:masterClrMapping/>
+  </p:clrMapOvr>
+</p:notes>
+</file>
+
+<file path=ppt/notesSlides/notesSlide3.xml><?xml version="1.0" encoding="utf-8"?>
+<p:notes xmlns:a="http://schemas.openxmlformats.org/drawingml/2006/main" xmlns:r="http://schemas.openxmlformats.org/officeDocument/2006/relationships" xmlns:p="http://schemas.openxmlformats.org/presentationml/2006/main" showMasterSp="0" showMasterPhAnim="0">
+  <p:cSld>
+    <p:spTree>
+      <p:nvGrpSpPr>
         <p:cNvPr id="1" name="Shape 135"/>
         <p:cNvGrpSpPr/>
         <p:nvPr/>
@@ -1093,18 +1213,12 @@
 </p:notes>
 </file>
 
-<file path=ppt/notesSlides/notesSlide3.xml><?xml version="1.0" encoding="utf-8"?>
+<file path=ppt/notesSlides/notesSlide4.xml><?xml version="1.0" encoding="utf-8"?>
 <p:notes xmlns:a="http://schemas.openxmlformats.org/drawingml/2006/main" xmlns:r="http://schemas.openxmlformats.org/officeDocument/2006/relationships" xmlns:p="http://schemas.openxmlformats.org/presentationml/2006/main" showMasterSp="0" showMasterPhAnim="0">
   <p:cSld>
     <p:spTree>
       <p:nvGrpSpPr>
-        <p:cNvPr id="1" name="Shape 25">
-          <a:extLst>
-            <a:ext uri="{FF2B5EF4-FFF2-40B4-BE49-F238E27FC236}">
-              <a16:creationId xmlns:a16="http://schemas.microsoft.com/office/drawing/2014/main" id="{642B6F40-F0AD-BA10-5C37-09B35FBD69C3}"/>
-            </a:ext>
-          </a:extLst>
-        </p:cNvPr>
+        <p:cNvPr id="1" name="Shape 295"/>
         <p:cNvGrpSpPr/>
         <p:nvPr/>
       </p:nvGrpSpPr>
@@ -1118,13 +1232,7 @@
       </p:grpSpPr>
       <p:sp>
         <p:nvSpPr>
-          <p:cNvPr id="26" name="Google Shape;26;g3ceeff82bb2_0_39:notes">
-            <a:extLst>
-              <a:ext uri="{FF2B5EF4-FFF2-40B4-BE49-F238E27FC236}">
-                <a16:creationId xmlns:a16="http://schemas.microsoft.com/office/drawing/2014/main" id="{D2533165-E7DB-224E-BA93-12B4A3705748}"/>
-              </a:ext>
-            </a:extLst>
-          </p:cNvPr>
+          <p:cNvPr id="296" name="Google Shape;296;g395f9ca54f4_0_65:notes"/>
           <p:cNvSpPr txBox="1">
             <a:spLocks noGrp="1"/>
           </p:cNvSpPr>
@@ -1170,13 +1278,7 @@
       </p:sp>
       <p:sp>
         <p:nvSpPr>
-          <p:cNvPr id="27" name="Google Shape;27;g3ceeff82bb2_0_39:notes">
-            <a:extLst>
-              <a:ext uri="{FF2B5EF4-FFF2-40B4-BE49-F238E27FC236}">
-                <a16:creationId xmlns:a16="http://schemas.microsoft.com/office/drawing/2014/main" id="{CF312A0B-E2CD-B0F0-53F3-2BB396805690}"/>
-              </a:ext>
-            </a:extLst>
-          </p:cNvPr>
+          <p:cNvPr id="297" name="Google Shape;297;g395f9ca54f4_0_65:notes"/>
           <p:cNvSpPr>
             <a:spLocks noGrp="1" noRot="1" noChangeAspect="1"/>
           </p:cNvSpPr>
@@ -1226,11 +1328,6 @@
         </p:spPr>
       </p:sp>
     </p:spTree>
-    <p:extLst>
-      <p:ext uri="{BB962C8B-B14F-4D97-AF65-F5344CB8AC3E}">
-        <p14:creationId xmlns:p14="http://schemas.microsoft.com/office/powerpoint/2010/main" val="3288849059"/>
-      </p:ext>
-    </p:extLst>
   </p:cSld>
   <p:clrMapOvr>
     <a:masterClrMapping/>
@@ -1238,18 +1335,12 @@
 </p:notes>
 </file>
 
-<file path=ppt/notesSlides/notesSlide4.xml><?xml version="1.0" encoding="utf-8"?>
+<file path=ppt/notesSlides/notesSlide5.xml><?xml version="1.0" encoding="utf-8"?>
 <p:notes xmlns:a="http://schemas.openxmlformats.org/drawingml/2006/main" xmlns:r="http://schemas.openxmlformats.org/officeDocument/2006/relationships" xmlns:p="http://schemas.openxmlformats.org/presentationml/2006/main" showMasterSp="0" showMasterPhAnim="0">
   <p:cSld>
     <p:spTree>
       <p:nvGrpSpPr>
-        <p:cNvPr id="1" name="Shape 25">
-          <a:extLst>
-            <a:ext uri="{FF2B5EF4-FFF2-40B4-BE49-F238E27FC236}">
-              <a16:creationId xmlns:a16="http://schemas.microsoft.com/office/drawing/2014/main" id="{D6270554-290F-A063-C7C3-DEE875707BA8}"/>
-            </a:ext>
-          </a:extLst>
-        </p:cNvPr>
+        <p:cNvPr id="1" name="Shape 306"/>
         <p:cNvGrpSpPr/>
         <p:nvPr/>
       </p:nvGrpSpPr>
@@ -1263,13 +1354,7 @@
       </p:grpSpPr>
       <p:sp>
         <p:nvSpPr>
-          <p:cNvPr id="26" name="Google Shape;26;g3ceeff82bb2_0_39:notes">
-            <a:extLst>
-              <a:ext uri="{FF2B5EF4-FFF2-40B4-BE49-F238E27FC236}">
-                <a16:creationId xmlns:a16="http://schemas.microsoft.com/office/drawing/2014/main" id="{50D6B706-28A5-8A8C-A0C3-CBEBA2523F7A}"/>
-              </a:ext>
-            </a:extLst>
-          </p:cNvPr>
+          <p:cNvPr id="307" name="Google Shape;307;g3ceeff82bb2_0_1:notes"/>
           <p:cNvSpPr txBox="1">
             <a:spLocks noGrp="1"/>
           </p:cNvSpPr>
@@ -1315,13 +1400,7 @@
       </p:sp>
       <p:sp>
         <p:nvSpPr>
-          <p:cNvPr id="27" name="Google Shape;27;g3ceeff82bb2_0_39:notes">
-            <a:extLst>
-              <a:ext uri="{FF2B5EF4-FFF2-40B4-BE49-F238E27FC236}">
-                <a16:creationId xmlns:a16="http://schemas.microsoft.com/office/drawing/2014/main" id="{04F7649B-60AC-F401-D646-5604EBF3588A}"/>
-              </a:ext>
-            </a:extLst>
-          </p:cNvPr>
+          <p:cNvPr id="308" name="Google Shape;308;g3ceeff82bb2_0_1:notes"/>
           <p:cNvSpPr>
             <a:spLocks noGrp="1" noRot="1" noChangeAspect="1"/>
           </p:cNvSpPr>
@@ -1371,301 +1450,6 @@
         </p:spPr>
       </p:sp>
     </p:spTree>
-    <p:extLst>
-      <p:ext uri="{BB962C8B-B14F-4D97-AF65-F5344CB8AC3E}">
-        <p14:creationId xmlns:p14="http://schemas.microsoft.com/office/powerpoint/2010/main" val="1376557913"/>
-      </p:ext>
-    </p:extLst>
-  </p:cSld>
-  <p:clrMapOvr>
-    <a:masterClrMapping/>
-  </p:clrMapOvr>
-</p:notes>
-</file>
-
-<file path=ppt/notesSlides/notesSlide5.xml><?xml version="1.0" encoding="utf-8"?>
-<p:notes xmlns:a="http://schemas.openxmlformats.org/drawingml/2006/main" xmlns:r="http://schemas.openxmlformats.org/officeDocument/2006/relationships" xmlns:p="http://schemas.openxmlformats.org/presentationml/2006/main" showMasterSp="0" showMasterPhAnim="0">
-  <p:cSld>
-    <p:spTree>
-      <p:nvGrpSpPr>
-        <p:cNvPr id="1" name="Shape 25">
-          <a:extLst>
-            <a:ext uri="{FF2B5EF4-FFF2-40B4-BE49-F238E27FC236}">
-              <a16:creationId xmlns:a16="http://schemas.microsoft.com/office/drawing/2014/main" id="{E4F6E50B-0BFF-208B-6A71-6B559A9D83BA}"/>
-            </a:ext>
-          </a:extLst>
-        </p:cNvPr>
-        <p:cNvGrpSpPr/>
-        <p:nvPr/>
-      </p:nvGrpSpPr>
-      <p:grpSpPr>
-        <a:xfrm>
-          <a:off x="0" y="0"/>
-          <a:ext cx="0" cy="0"/>
-          <a:chOff x="0" y="0"/>
-          <a:chExt cx="0" cy="0"/>
-        </a:xfrm>
-      </p:grpSpPr>
-      <p:sp>
-        <p:nvSpPr>
-          <p:cNvPr id="26" name="Google Shape;26;g3ceeff82bb2_0_39:notes">
-            <a:extLst>
-              <a:ext uri="{FF2B5EF4-FFF2-40B4-BE49-F238E27FC236}">
-                <a16:creationId xmlns:a16="http://schemas.microsoft.com/office/drawing/2014/main" id="{E485E877-6ABA-588C-C951-1CA2FFDBD0F1}"/>
-              </a:ext>
-            </a:extLst>
-          </p:cNvPr>
-          <p:cNvSpPr txBox="1">
-            <a:spLocks noGrp="1"/>
-          </p:cNvSpPr>
-          <p:nvPr>
-            <p:ph type="body" idx="1"/>
-          </p:nvPr>
-        </p:nvSpPr>
-        <p:spPr>
-          <a:xfrm>
-            <a:off x="685800" y="4343400"/>
-            <a:ext cx="5486400" cy="4114800"/>
-          </a:xfrm>
-          <a:prstGeom prst="rect">
-            <a:avLst/>
-          </a:prstGeom>
-          <a:noFill/>
-          <a:ln>
-            <a:noFill/>
-          </a:ln>
-        </p:spPr>
-        <p:txBody>
-          <a:bodyPr spcFirstLastPara="1" wrap="square" lIns="91425" tIns="91425" rIns="91425" bIns="91425" anchor="t" anchorCtr="0">
-            <a:noAutofit/>
-          </a:bodyPr>
-          <a:lstStyle/>
-          <a:p>
-            <a:pPr marL="0" lvl="0" indent="0" algn="l" rtl="0">
-              <a:lnSpc>
-                <a:spcPct val="100000"/>
-              </a:lnSpc>
-              <a:spcBef>
-                <a:spcPts val="0"/>
-              </a:spcBef>
-              <a:spcAft>
-                <a:spcPts val="0"/>
-              </a:spcAft>
-              <a:buSzPts val="1100"/>
-              <a:buNone/>
-            </a:pPr>
-            <a:endParaRPr/>
-          </a:p>
-        </p:txBody>
-      </p:sp>
-      <p:sp>
-        <p:nvSpPr>
-          <p:cNvPr id="27" name="Google Shape;27;g3ceeff82bb2_0_39:notes">
-            <a:extLst>
-              <a:ext uri="{FF2B5EF4-FFF2-40B4-BE49-F238E27FC236}">
-                <a16:creationId xmlns:a16="http://schemas.microsoft.com/office/drawing/2014/main" id="{E841703B-1E55-44D7-EA9B-6DF31F06AC11}"/>
-              </a:ext>
-            </a:extLst>
-          </p:cNvPr>
-          <p:cNvSpPr>
-            <a:spLocks noGrp="1" noRot="1" noChangeAspect="1"/>
-          </p:cNvSpPr>
-          <p:nvPr>
-            <p:ph type="sldImg" idx="2"/>
-          </p:nvPr>
-        </p:nvSpPr>
-        <p:spPr>
-          <a:xfrm>
-            <a:off x="381000" y="685800"/>
-            <a:ext cx="6096000" cy="3429000"/>
-          </a:xfrm>
-          <a:custGeom>
-            <a:avLst/>
-            <a:gdLst/>
-            <a:ahLst/>
-            <a:cxnLst/>
-            <a:rect l="l" t="t" r="r" b="b"/>
-            <a:pathLst>
-              <a:path w="120000" h="120000" extrusionOk="0">
-                <a:moveTo>
-                  <a:pt x="0" y="0"/>
-                </a:moveTo>
-                <a:lnTo>
-                  <a:pt x="120000" y="0"/>
-                </a:lnTo>
-                <a:lnTo>
-                  <a:pt x="120000" y="120000"/>
-                </a:lnTo>
-                <a:lnTo>
-                  <a:pt x="0" y="120000"/>
-                </a:lnTo>
-                <a:close/>
-              </a:path>
-            </a:pathLst>
-          </a:custGeom>
-          <a:noFill/>
-          <a:ln w="9525" cap="flat" cmpd="sng">
-            <a:solidFill>
-              <a:srgbClr val="000000"/>
-            </a:solidFill>
-            <a:prstDash val="solid"/>
-            <a:round/>
-            <a:headEnd type="none" w="sm" len="sm"/>
-            <a:tailEnd type="none" w="sm" len="sm"/>
-          </a:ln>
-        </p:spPr>
-      </p:sp>
-    </p:spTree>
-    <p:extLst>
-      <p:ext uri="{BB962C8B-B14F-4D97-AF65-F5344CB8AC3E}">
-        <p14:creationId xmlns:p14="http://schemas.microsoft.com/office/powerpoint/2010/main" val="4127889005"/>
-      </p:ext>
-    </p:extLst>
-  </p:cSld>
-  <p:clrMapOvr>
-    <a:masterClrMapping/>
-  </p:clrMapOvr>
-</p:notes>
-</file>
-
-<file path=ppt/notesSlides/notesSlide6.xml><?xml version="1.0" encoding="utf-8"?>
-<p:notes xmlns:a="http://schemas.openxmlformats.org/drawingml/2006/main" xmlns:r="http://schemas.openxmlformats.org/officeDocument/2006/relationships" xmlns:p="http://schemas.openxmlformats.org/presentationml/2006/main" showMasterSp="0" showMasterPhAnim="0">
-  <p:cSld>
-    <p:spTree>
-      <p:nvGrpSpPr>
-        <p:cNvPr id="1" name="Shape 25">
-          <a:extLst>
-            <a:ext uri="{FF2B5EF4-FFF2-40B4-BE49-F238E27FC236}">
-              <a16:creationId xmlns:a16="http://schemas.microsoft.com/office/drawing/2014/main" id="{A03FF3B3-FF87-5874-FD2D-332E33469E29}"/>
-            </a:ext>
-          </a:extLst>
-        </p:cNvPr>
-        <p:cNvGrpSpPr/>
-        <p:nvPr/>
-      </p:nvGrpSpPr>
-      <p:grpSpPr>
-        <a:xfrm>
-          <a:off x="0" y="0"/>
-          <a:ext cx="0" cy="0"/>
-          <a:chOff x="0" y="0"/>
-          <a:chExt cx="0" cy="0"/>
-        </a:xfrm>
-      </p:grpSpPr>
-      <p:sp>
-        <p:nvSpPr>
-          <p:cNvPr id="26" name="Google Shape;26;g3ceeff82bb2_0_39:notes">
-            <a:extLst>
-              <a:ext uri="{FF2B5EF4-FFF2-40B4-BE49-F238E27FC236}">
-                <a16:creationId xmlns:a16="http://schemas.microsoft.com/office/drawing/2014/main" id="{A6A5AEE3-1CF1-E7D4-A3ED-917A05937AAA}"/>
-              </a:ext>
-            </a:extLst>
-          </p:cNvPr>
-          <p:cNvSpPr txBox="1">
-            <a:spLocks noGrp="1"/>
-          </p:cNvSpPr>
-          <p:nvPr>
-            <p:ph type="body" idx="1"/>
-          </p:nvPr>
-        </p:nvSpPr>
-        <p:spPr>
-          <a:xfrm>
-            <a:off x="685800" y="4343400"/>
-            <a:ext cx="5486400" cy="4114800"/>
-          </a:xfrm>
-          <a:prstGeom prst="rect">
-            <a:avLst/>
-          </a:prstGeom>
-          <a:noFill/>
-          <a:ln>
-            <a:noFill/>
-          </a:ln>
-        </p:spPr>
-        <p:txBody>
-          <a:bodyPr spcFirstLastPara="1" wrap="square" lIns="91425" tIns="91425" rIns="91425" bIns="91425" anchor="t" anchorCtr="0">
-            <a:noAutofit/>
-          </a:bodyPr>
-          <a:lstStyle/>
-          <a:p>
-            <a:pPr marL="0" lvl="0" indent="0" algn="l" rtl="0">
-              <a:lnSpc>
-                <a:spcPct val="100000"/>
-              </a:lnSpc>
-              <a:spcBef>
-                <a:spcPts val="0"/>
-              </a:spcBef>
-              <a:spcAft>
-                <a:spcPts val="0"/>
-              </a:spcAft>
-              <a:buSzPts val="1100"/>
-              <a:buNone/>
-            </a:pPr>
-            <a:endParaRPr/>
-          </a:p>
-        </p:txBody>
-      </p:sp>
-      <p:sp>
-        <p:nvSpPr>
-          <p:cNvPr id="27" name="Google Shape;27;g3ceeff82bb2_0_39:notes">
-            <a:extLst>
-              <a:ext uri="{FF2B5EF4-FFF2-40B4-BE49-F238E27FC236}">
-                <a16:creationId xmlns:a16="http://schemas.microsoft.com/office/drawing/2014/main" id="{1A635978-23E4-AE4B-0C63-B9DBC24418D5}"/>
-              </a:ext>
-            </a:extLst>
-          </p:cNvPr>
-          <p:cNvSpPr>
-            <a:spLocks noGrp="1" noRot="1" noChangeAspect="1"/>
-          </p:cNvSpPr>
-          <p:nvPr>
-            <p:ph type="sldImg" idx="2"/>
-          </p:nvPr>
-        </p:nvSpPr>
-        <p:spPr>
-          <a:xfrm>
-            <a:off x="381000" y="685800"/>
-            <a:ext cx="6096000" cy="3429000"/>
-          </a:xfrm>
-          <a:custGeom>
-            <a:avLst/>
-            <a:gdLst/>
-            <a:ahLst/>
-            <a:cxnLst/>
-            <a:rect l="l" t="t" r="r" b="b"/>
-            <a:pathLst>
-              <a:path w="120000" h="120000" extrusionOk="0">
-                <a:moveTo>
-                  <a:pt x="0" y="0"/>
-                </a:moveTo>
-                <a:lnTo>
-                  <a:pt x="120000" y="0"/>
-                </a:lnTo>
-                <a:lnTo>
-                  <a:pt x="120000" y="120000"/>
-                </a:lnTo>
-                <a:lnTo>
-                  <a:pt x="0" y="120000"/>
-                </a:lnTo>
-                <a:close/>
-              </a:path>
-            </a:pathLst>
-          </a:custGeom>
-          <a:noFill/>
-          <a:ln w="9525" cap="flat" cmpd="sng">
-            <a:solidFill>
-              <a:srgbClr val="000000"/>
-            </a:solidFill>
-            <a:prstDash val="solid"/>
-            <a:round/>
-            <a:headEnd type="none" w="sm" len="sm"/>
-            <a:tailEnd type="none" w="sm" len="sm"/>
-          </a:ln>
-        </p:spPr>
-      </p:sp>
-    </p:spTree>
-    <p:extLst>
-      <p:ext uri="{BB962C8B-B14F-4D97-AF65-F5344CB8AC3E}">
-        <p14:creationId xmlns:p14="http://schemas.microsoft.com/office/powerpoint/2010/main" val="43816130"/>
-      </p:ext>
-    </p:extLst>
   </p:cSld>
   <p:clrMapOvr>
     <a:masterClrMapping/>
@@ -1715,6 +1499,42 @@
           <a:chExt cx="0" cy="0"/>
         </a:xfrm>
       </p:grpSpPr>
+      <p:pic>
+        <p:nvPicPr>
+          <p:cNvPr id="6" name="Gráfico 5">
+            <a:extLst>
+              <a:ext uri="{FF2B5EF4-FFF2-40B4-BE49-F238E27FC236}">
+                <a16:creationId xmlns:a16="http://schemas.microsoft.com/office/drawing/2014/main" id="{B917E286-44D4-A4A0-00A4-2C4A146F5D79}"/>
+              </a:ext>
+            </a:extLst>
+          </p:cNvPr>
+          <p:cNvPicPr>
+            <a:picLocks noChangeAspect="1"/>
+          </p:cNvPicPr>
+          <p:nvPr userDrawn="1"/>
+        </p:nvPicPr>
+        <p:blipFill>
+          <a:blip>
+            <a:extLst>
+              <a:ext uri="{96DAC541-7B7A-43D3-8B79-37D633B846F1}">
+                <asvg:svgBlip xmlns:asvg="http://schemas.microsoft.com/office/drawing/2016/SVG/main" r:embed="rId2"/>
+              </a:ext>
+            </a:extLst>
+          </a:blip>
+          <a:stretch>
+            <a:fillRect/>
+          </a:stretch>
+        </p:blipFill>
+        <p:spPr>
+          <a:xfrm>
+            <a:off x="9833956" y="6130290"/>
+            <a:ext cx="2069176" cy="557086"/>
+          </a:xfrm>
+          <a:prstGeom prst="rect">
+            <a:avLst/>
+          </a:prstGeom>
+        </p:spPr>
+      </p:pic>
     </p:spTree>
     <p:extLst>
       <p:ext uri="{BB962C8B-B14F-4D97-AF65-F5344CB8AC3E}">
@@ -2573,119 +2393,6 @@
   <p:cSld>
     <p:spTree>
       <p:nvGrpSpPr>
-        <p:cNvPr id="1" name="">
-          <a:extLst>
-            <a:ext uri="{FF2B5EF4-FFF2-40B4-BE49-F238E27FC236}">
-              <a16:creationId xmlns:a16="http://schemas.microsoft.com/office/drawing/2014/main" id="{34E01EB0-1B4E-64C6-ABAC-EDC7DE56F354}"/>
-            </a:ext>
-          </a:extLst>
-        </p:cNvPr>
-        <p:cNvGrpSpPr/>
-        <p:nvPr/>
-      </p:nvGrpSpPr>
-      <p:grpSpPr>
-        <a:xfrm>
-          <a:off x="0" y="0"/>
-          <a:ext cx="0" cy="0"/>
-          <a:chOff x="0" y="0"/>
-          <a:chExt cx="0" cy="0"/>
-        </a:xfrm>
-      </p:grpSpPr>
-      <p:sp>
-        <p:nvSpPr>
-          <p:cNvPr id="12" name="CuadroTexto 11">
-            <a:extLst>
-              <a:ext uri="{FF2B5EF4-FFF2-40B4-BE49-F238E27FC236}">
-                <a16:creationId xmlns:a16="http://schemas.microsoft.com/office/drawing/2014/main" id="{0E8AF996-2459-7EA7-5CEE-0AE00BE80269}"/>
-              </a:ext>
-            </a:extLst>
-          </p:cNvPr>
-          <p:cNvSpPr txBox="1"/>
-          <p:nvPr/>
-        </p:nvSpPr>
-        <p:spPr>
-          <a:xfrm>
-            <a:off x="1817958" y="4214015"/>
-            <a:ext cx="8556084" cy="646331"/>
-          </a:xfrm>
-          <a:prstGeom prst="rect">
-            <a:avLst/>
-          </a:prstGeom>
-          <a:noFill/>
-        </p:spPr>
-        <p:txBody>
-          <a:bodyPr wrap="square" rtlCol="0">
-            <a:spAutoFit/>
-          </a:bodyPr>
-          <a:lstStyle/>
-          <a:p>
-            <a:pPr algn="ctr"/>
-            <a:r>
-              <a:rPr lang="es-MX" sz="3600" dirty="0">
-                <a:solidFill>
-                  <a:schemeClr val="bg1"/>
-                </a:solidFill>
-                <a:latin typeface="Montserrat SemiBold" pitchFamily="2" charset="0"/>
-              </a:rPr>
-              <a:t>NOMBRE CADENA</a:t>
-            </a:r>
-          </a:p>
-        </p:txBody>
-      </p:sp>
-      <p:pic>
-        <p:nvPicPr>
-          <p:cNvPr id="4" name="Imagen 3" descr="Logotipo&#10;&#10;Descripción generada automáticamente">
-            <a:extLst>
-              <a:ext uri="{FF2B5EF4-FFF2-40B4-BE49-F238E27FC236}">
-                <a16:creationId xmlns:a16="http://schemas.microsoft.com/office/drawing/2014/main" id="{179D87B2-BAA1-555C-F4BD-01FF4621B4E0}"/>
-              </a:ext>
-            </a:extLst>
-          </p:cNvPr>
-          <p:cNvPicPr>
-            <a:picLocks noChangeAspect="1"/>
-          </p:cNvPicPr>
-          <p:nvPr/>
-        </p:nvPicPr>
-        <p:blipFill>
-          <a:blip r:embed="rId2" cstate="screen">
-            <a:extLst>
-              <a:ext uri="{28A0092B-C50C-407E-A947-70E740481C1C}">
-                <a14:useLocalDpi xmlns:a14="http://schemas.microsoft.com/office/drawing/2010/main"/>
-              </a:ext>
-            </a:extLst>
-          </a:blip>
-          <a:stretch>
-            <a:fillRect/>
-          </a:stretch>
-        </p:blipFill>
-        <p:spPr>
-          <a:xfrm>
-            <a:off x="2731300" y="2117797"/>
-            <a:ext cx="6729399" cy="1311203"/>
-          </a:xfrm>
-          <a:prstGeom prst="rect">
-            <a:avLst/>
-          </a:prstGeom>
-        </p:spPr>
-      </p:pic>
-    </p:spTree>
-    <p:extLst>
-      <p:ext uri="{BB962C8B-B14F-4D97-AF65-F5344CB8AC3E}">
-        <p14:creationId xmlns:p14="http://schemas.microsoft.com/office/powerpoint/2010/main" val="2809198233"/>
-      </p:ext>
-    </p:extLst>
-  </p:cSld>
-  <p:clrMapOvr>
-    <a:masterClrMapping/>
-  </p:clrMapOvr>
-</p:sld>
-</file>
-
-<file path=ppt/slides/slide3.xml><?xml version="1.0" encoding="utf-8"?>
-<p:sld xmlns:a="http://schemas.openxmlformats.org/drawingml/2006/main" xmlns:r="http://schemas.openxmlformats.org/officeDocument/2006/relationships" xmlns:p="http://schemas.openxmlformats.org/presentationml/2006/main">
-  <p:cSld>
-    <p:spTree>
-      <p:nvGrpSpPr>
         <p:cNvPr id="1" name="Shape 28"/>
         <p:cNvGrpSpPr/>
         <p:nvPr/>
@@ -2750,7 +2457,55 @@
                 <a:cs typeface="Arial Black"/>
                 <a:sym typeface="Arial Black"/>
               </a:rPr>
-              <a:t>NOMBRE TIENDA</a:t>
+              <a:t>N361</a:t>
+            </a:r>
+            <a:r>
+              <a:rPr lang="es-ES" sz="2200" b="1" i="0" u="none" strike="noStrike" cap="none" dirty="0">
+                <a:solidFill>
+                  <a:schemeClr val="bg1"/>
+                </a:solidFill>
+                <a:latin typeface="Arial Black"/>
+                <a:ea typeface="Arial Black"/>
+                <a:cs typeface="Arial Black"/>
+                <a:sym typeface="Arial Black"/>
+              </a:rPr>
+              <a:t> </a:t>
+            </a:r>
+            <a:r>
+              <a:rPr lang="es-ES" sz="2200" b="1" dirty="0">
+                <a:solidFill>
+                  <a:schemeClr val="bg1"/>
+                </a:solidFill>
+                <a:latin typeface="Arial Black"/>
+                <a:ea typeface="Arial Black"/>
+                <a:cs typeface="Arial Black"/>
+                <a:sym typeface="Arial Black"/>
+              </a:rPr>
+              <a:t>SISA</a:t>
+            </a:r>
+            <a:r>
+              <a:rPr lang="es-ES" sz="2200" b="1" i="0" u="none" strike="noStrike" cap="none" dirty="0">
+                <a:solidFill>
+                  <a:schemeClr val="bg1"/>
+                </a:solidFill>
+                <a:latin typeface="Arial Black"/>
+                <a:ea typeface="Arial Black"/>
+                <a:cs typeface="Arial Black"/>
+                <a:sym typeface="Arial Black"/>
+              </a:rPr>
+              <a:t> - </a:t>
+            </a:r>
+            <a:r>
+              <a:rPr lang="es-ES" sz="2200" b="1" dirty="0">
+                <a:solidFill>
+                  <a:schemeClr val="bg1"/>
+                </a:solidFill>
+                <a:latin typeface="Arial Black"/>
+                <a:ea typeface="Arial Black"/>
+                <a:cs typeface="Arial Black"/>
+                <a:sym typeface="Arial Black"/>
+              </a:rPr>
+              <a:t>AV. LO MARCOLETA N361, QUILICURA</a:t>
             </a:r>
             <a:endParaRPr sz="2200" b="1" dirty="0">
               <a:solidFill>
@@ -2772,8 +2527,8 @@
         </p:nvSpPr>
         <p:spPr>
           <a:xfrm>
-            <a:off x="2883735" y="1365799"/>
-            <a:ext cx="5543467" cy="288803"/>
+            <a:off x="812586" y="1758678"/>
+            <a:ext cx="3022500" cy="288803"/>
           </a:xfrm>
           <a:prstGeom prst="rect">
             <a:avLst/>
@@ -2816,7 +2571,7 @@
                 <a:cs typeface="Arial"/>
                 <a:sym typeface="Arial"/>
               </a:rPr>
-              <a:t>FECHA:</a:t>
+              <a:t>FECHA: 11/03/2026</a:t>
             </a:r>
           </a:p>
         </p:txBody>
@@ -2836,8 +2591,176 @@
         </p:blipFill>
         <p:spPr>
           <a:xfrm>
-            <a:off x="2883736" y="1772907"/>
-            <a:ext cx="5543468" cy="4247233"/>
+            <a:off x="634050" y="2177403"/>
+            <a:ext cx="3379376" cy="2589173"/>
+          </a:xfrm>
+          <a:prstGeom prst="rect">
+            <a:avLst/>
+          </a:prstGeom>
+          <a:noFill/>
+          <a:ln>
+            <a:noFill/>
+          </a:ln>
+        </p:spPr>
+      </p:pic>
+      <p:sp>
+        <p:nvSpPr>
+          <p:cNvPr id="32" name="Google Shape;32;g3ceeff82bb2_0_39"/>
+          <p:cNvSpPr txBox="1"/>
+          <p:nvPr/>
+        </p:nvSpPr>
+        <p:spPr>
+          <a:xfrm>
+            <a:off x="4506135" y="1758950"/>
+            <a:ext cx="3022500" cy="288803"/>
+          </a:xfrm>
+          <a:prstGeom prst="rect">
+            <a:avLst/>
+          </a:prstGeom>
+          <a:noFill/>
+          <a:ln>
+            <a:noFill/>
+          </a:ln>
+        </p:spPr>
+        <p:txBody>
+          <a:bodyPr spcFirstLastPara="1" wrap="square" lIns="36325" tIns="36325" rIns="36325" bIns="36325" anchor="t" anchorCtr="0">
+            <a:spAutoFit/>
+          </a:bodyPr>
+          <a:lstStyle/>
+          <a:p>
+            <a:pPr marL="0" marR="0" lvl="0" indent="0" algn="ctr" rtl="0">
+              <a:lnSpc>
+                <a:spcPct val="100000"/>
+              </a:lnSpc>
+              <a:spcBef>
+                <a:spcPts val="0"/>
+              </a:spcBef>
+              <a:spcAft>
+                <a:spcPts val="0"/>
+              </a:spcAft>
+              <a:buClr>
+                <a:srgbClr val="000000"/>
+              </a:buClr>
+              <a:buSzPts val="1000"/>
+              <a:buFont typeface="Arial"/>
+              <a:buNone/>
+            </a:pPr>
+            <a:r>
+              <a:rPr lang="es-ES" b="1" i="0" u="none" strike="noStrike" cap="none" dirty="0">
+                <a:solidFill>
+                  <a:srgbClr val="FFFFFF"/>
+                </a:solidFill>
+                <a:latin typeface="Arial"/>
+                <a:ea typeface="Arial"/>
+                <a:cs typeface="Arial"/>
+                <a:sym typeface="Arial"/>
+              </a:rPr>
+              <a:t>FECHA: 11/03/2026</a:t>
+            </a:r>
+          </a:p>
+        </p:txBody>
+      </p:sp>
+      <p:pic>
+        <p:nvPicPr>
+          <p:cNvPr id="33" name="Google Shape;33;g3ceeff82bb2_0_39" title="41fe07a4-69a5-43f8-b998-ea75b2249615.jpg"/>
+          <p:cNvPicPr preferRelativeResize="0"/>
+          <p:nvPr/>
+        </p:nvPicPr>
+        <p:blipFill rotWithShape="1">
+          <a:blip r:embed="rId4">
+            <a:alphaModFix/>
+          </a:blip>
+          <a:srcRect l="1057" r="1057"/>
+          <a:stretch/>
+        </p:blipFill>
+        <p:spPr>
+          <a:xfrm>
+            <a:off x="4327600" y="2177403"/>
+            <a:ext cx="3379376" cy="2589170"/>
+          </a:xfrm>
+          <a:prstGeom prst="rect">
+            <a:avLst/>
+          </a:prstGeom>
+          <a:noFill/>
+          <a:ln>
+            <a:noFill/>
+          </a:ln>
+        </p:spPr>
+      </p:pic>
+      <p:sp>
+        <p:nvSpPr>
+          <p:cNvPr id="34" name="Google Shape;34;g3ceeff82bb2_0_39"/>
+          <p:cNvSpPr txBox="1"/>
+          <p:nvPr/>
+        </p:nvSpPr>
+        <p:spPr>
+          <a:xfrm>
+            <a:off x="8199684" y="1758950"/>
+            <a:ext cx="3022500" cy="288803"/>
+          </a:xfrm>
+          <a:prstGeom prst="rect">
+            <a:avLst/>
+          </a:prstGeom>
+          <a:noFill/>
+          <a:ln>
+            <a:noFill/>
+          </a:ln>
+        </p:spPr>
+        <p:txBody>
+          <a:bodyPr spcFirstLastPara="1" wrap="square" lIns="36325" tIns="36325" rIns="36325" bIns="36325" anchor="t" anchorCtr="0">
+            <a:spAutoFit/>
+          </a:bodyPr>
+          <a:lstStyle/>
+          <a:p>
+            <a:pPr marL="0" marR="0" lvl="0" indent="0" algn="ctr" rtl="0">
+              <a:lnSpc>
+                <a:spcPct val="100000"/>
+              </a:lnSpc>
+              <a:spcBef>
+                <a:spcPts val="0"/>
+              </a:spcBef>
+              <a:spcAft>
+                <a:spcPts val="0"/>
+              </a:spcAft>
+              <a:buClr>
+                <a:srgbClr val="000000"/>
+              </a:buClr>
+              <a:buSzPts val="1000"/>
+              <a:buFont typeface="Arial"/>
+              <a:buNone/>
+            </a:pPr>
+            <a:r>
+              <a:rPr lang="es-ES" b="1" i="0" u="none" strike="noStrike" cap="none" dirty="0">
+                <a:solidFill>
+                  <a:srgbClr val="FFFFFF"/>
+                </a:solidFill>
+                <a:latin typeface="Arial"/>
+                <a:ea typeface="Arial"/>
+                <a:cs typeface="Arial"/>
+                <a:sym typeface="Arial"/>
+              </a:rPr>
+              <a:t>FECHA: 11/03/2026</a:t>
+            </a:r>
+          </a:p>
+        </p:txBody>
+      </p:sp>
+      <p:pic>
+        <p:nvPicPr>
+          <p:cNvPr id="35" name="Google Shape;35;g3ceeff82bb2_0_39" title="66b07255-4409-4a2d-bcec-05262e91b0ae.jpg"/>
+          <p:cNvPicPr preferRelativeResize="0"/>
+          <p:nvPr/>
+        </p:nvPicPr>
+        <p:blipFill rotWithShape="1">
+          <a:blip r:embed="rId5">
+            <a:alphaModFix/>
+          </a:blip>
+          <a:srcRect l="1057" r="1057"/>
+          <a:stretch/>
+        </p:blipFill>
+        <p:spPr>
+          <a:xfrm>
+            <a:off x="8021149" y="2177403"/>
+            <a:ext cx="3379376" cy="2589173"/>
           </a:xfrm>
           <a:prstGeom prst="rect">
             <a:avLst/>
@@ -2852,6 +2775,234 @@
     <p:extLst>
       <p:ext uri="{BB962C8B-B14F-4D97-AF65-F5344CB8AC3E}">
         <p14:creationId xmlns:p14="http://schemas.microsoft.com/office/powerpoint/2010/main" val="2789082858"/>
+      </p:ext>
+    </p:extLst>
+  </p:cSld>
+  <p:clrMapOvr>
+    <a:masterClrMapping/>
+  </p:clrMapOvr>
+</p:sld>
+</file>
+
+<file path=ppt/slides/slide3.xml><?xml version="1.0" encoding="utf-8"?>
+<p:sld xmlns:a="http://schemas.openxmlformats.org/drawingml/2006/main" xmlns:r="http://schemas.openxmlformats.org/officeDocument/2006/relationships" xmlns:p="http://schemas.openxmlformats.org/presentationml/2006/main">
+  <p:cSld>
+    <p:spTree>
+      <p:nvGrpSpPr>
+        <p:cNvPr id="1" name="Shape 39"/>
+        <p:cNvGrpSpPr/>
+        <p:nvPr/>
+      </p:nvGrpSpPr>
+      <p:grpSpPr>
+        <a:xfrm>
+          <a:off x="0" y="0"/>
+          <a:ext cx="0" cy="0"/>
+          <a:chOff x="0" y="0"/>
+          <a:chExt cx="0" cy="0"/>
+        </a:xfrm>
+      </p:grpSpPr>
+      <p:sp>
+        <p:nvSpPr>
+          <p:cNvPr id="40" name="Google Shape;40;g3d777708fde_0_57"/>
+          <p:cNvSpPr txBox="1"/>
+          <p:nvPr/>
+        </p:nvSpPr>
+        <p:spPr>
+          <a:xfrm>
+            <a:off x="499380" y="263800"/>
+            <a:ext cx="10972800" cy="430800"/>
+          </a:xfrm>
+          <a:prstGeom prst="rect">
+            <a:avLst/>
+          </a:prstGeom>
+          <a:noFill/>
+          <a:ln>
+            <a:noFill/>
+          </a:ln>
+        </p:spPr>
+        <p:txBody>
+          <a:bodyPr spcFirstLastPara="1" wrap="square" lIns="91425" tIns="45700" rIns="91425" bIns="45700" anchor="t" anchorCtr="0">
+            <a:spAutoFit/>
+          </a:bodyPr>
+          <a:lstStyle/>
+          <a:p>
+            <a:pPr marL="0" marR="0" lvl="0" indent="0" algn="l" rtl="0">
+              <a:lnSpc>
+                <a:spcPct val="100000"/>
+              </a:lnSpc>
+              <a:spcBef>
+                <a:spcPts val="0"/>
+              </a:spcBef>
+              <a:spcAft>
+                <a:spcPts val="0"/>
+              </a:spcAft>
+              <a:buClr>
+                <a:srgbClr val="000000"/>
+              </a:buClr>
+              <a:buSzPts val="2400"/>
+              <a:buFont typeface="Arial"/>
+              <a:buNone/>
+            </a:pPr>
+            <a:r>
+              <a:rPr lang="es-ES" sz="2200" b="1">
+                <a:solidFill>
+                  <a:srgbClr val="FFFFFF"/>
+                </a:solidFill>
+                <a:latin typeface="Arial Black"/>
+                <a:ea typeface="Arial Black"/>
+                <a:cs typeface="Arial Black"/>
+                <a:sym typeface="Arial Black"/>
+              </a:rPr>
+              <a:t>N561</a:t>
+            </a:r>
+            <a:r>
+              <a:rPr lang="es-ES" sz="2200" b="1" i="0" u="none" strike="noStrike" cap="none">
+                <a:solidFill>
+                  <a:srgbClr val="FFFFFF"/>
+                </a:solidFill>
+                <a:latin typeface="Arial Black"/>
+                <a:ea typeface="Arial Black"/>
+                <a:cs typeface="Arial Black"/>
+                <a:sym typeface="Arial Black"/>
+              </a:rPr>
+              <a:t> S</a:t>
+            </a:r>
+            <a:r>
+              <a:rPr lang="es-ES" sz="2200" b="1">
+                <a:solidFill>
+                  <a:srgbClr val="FFFFFF"/>
+                </a:solidFill>
+                <a:latin typeface="Arial Black"/>
+                <a:ea typeface="Arial Black"/>
+                <a:cs typeface="Arial Black"/>
+                <a:sym typeface="Arial Black"/>
+              </a:rPr>
+              <a:t>ISA</a:t>
+            </a:r>
+            <a:r>
+              <a:rPr lang="es-ES" sz="2200" b="1" i="0" u="none" strike="noStrike" cap="none">
+                <a:solidFill>
+                  <a:srgbClr val="FFFFFF"/>
+                </a:solidFill>
+                <a:latin typeface="Arial Black"/>
+                <a:ea typeface="Arial Black"/>
+                <a:cs typeface="Arial Black"/>
+                <a:sym typeface="Arial Black"/>
+              </a:rPr>
+              <a:t> - </a:t>
+            </a:r>
+            <a:r>
+              <a:rPr lang="es-ES" sz="2200" b="1">
+                <a:solidFill>
+                  <a:srgbClr val="FFFFFF"/>
+                </a:solidFill>
+                <a:latin typeface="Arial Black"/>
+                <a:ea typeface="Arial Black"/>
+                <a:cs typeface="Arial Black"/>
+                <a:sym typeface="Arial Black"/>
+              </a:rPr>
+              <a:t>AV. CARDENAL SAMORÉ 2335, VALPARAÍSO</a:t>
+            </a:r>
+            <a:endParaRPr sz="2200" b="1" i="0" u="none" strike="noStrike" cap="none">
+              <a:solidFill>
+                <a:srgbClr val="FFFFFF"/>
+              </a:solidFill>
+              <a:latin typeface="Arial Black"/>
+              <a:ea typeface="Arial Black"/>
+              <a:cs typeface="Arial Black"/>
+              <a:sym typeface="Arial Black"/>
+            </a:endParaRPr>
+          </a:p>
+        </p:txBody>
+      </p:sp>
+      <p:sp>
+        <p:nvSpPr>
+          <p:cNvPr id="41" name="Google Shape;41;g3d777708fde_0_57"/>
+          <p:cNvSpPr txBox="1"/>
+          <p:nvPr/>
+        </p:nvSpPr>
+        <p:spPr>
+          <a:xfrm>
+            <a:off x="4149210" y="1524000"/>
+            <a:ext cx="3893700" cy="318036"/>
+          </a:xfrm>
+          <a:prstGeom prst="rect">
+            <a:avLst/>
+          </a:prstGeom>
+          <a:noFill/>
+          <a:ln>
+            <a:noFill/>
+          </a:ln>
+        </p:spPr>
+        <p:txBody>
+          <a:bodyPr spcFirstLastPara="1" wrap="square" lIns="50800" tIns="50800" rIns="50800" bIns="50800" anchor="t" anchorCtr="0">
+            <a:spAutoFit/>
+          </a:bodyPr>
+          <a:lstStyle/>
+          <a:p>
+            <a:pPr marL="0" marR="0" lvl="0" indent="0" algn="ctr" rtl="0">
+              <a:lnSpc>
+                <a:spcPct val="100000"/>
+              </a:lnSpc>
+              <a:spcBef>
+                <a:spcPts val="0"/>
+              </a:spcBef>
+              <a:spcAft>
+                <a:spcPts val="0"/>
+              </a:spcAft>
+              <a:buClr>
+                <a:srgbClr val="000000"/>
+              </a:buClr>
+              <a:buSzPts val="1400"/>
+              <a:buFont typeface="Arial"/>
+              <a:buNone/>
+            </a:pPr>
+            <a:r>
+              <a:rPr lang="es-ES" b="1" i="0" u="none" strike="noStrike" cap="none" dirty="0">
+                <a:solidFill>
+                  <a:srgbClr val="FFFFFF"/>
+                </a:solidFill>
+                <a:latin typeface="Arial"/>
+                <a:ea typeface="Arial"/>
+                <a:cs typeface="Arial"/>
+                <a:sym typeface="Arial"/>
+              </a:rPr>
+              <a:t>FECHA: 13/03/2026</a:t>
+            </a:r>
+          </a:p>
+        </p:txBody>
+      </p:sp>
+      <p:pic>
+        <p:nvPicPr>
+          <p:cNvPr id="42" name="Google Shape;42;g3d777708fde_0_57" title="13e6092e-a846-4def-8390-030e601e2da8.jpg"/>
+          <p:cNvPicPr preferRelativeResize="0"/>
+          <p:nvPr/>
+        </p:nvPicPr>
+        <p:blipFill rotWithShape="1">
+          <a:blip r:embed="rId3">
+            <a:alphaModFix/>
+          </a:blip>
+          <a:srcRect l="661" r="661"/>
+          <a:stretch/>
+        </p:blipFill>
+        <p:spPr>
+          <a:xfrm>
+            <a:off x="3602400" y="1887075"/>
+            <a:ext cx="5174900" cy="3933000"/>
+          </a:xfrm>
+          <a:prstGeom prst="rect">
+            <a:avLst/>
+          </a:prstGeom>
+          <a:noFill/>
+          <a:ln>
+            <a:noFill/>
+          </a:ln>
+        </p:spPr>
+      </p:pic>
+    </p:spTree>
+    <p:extLst>
+      <p:ext uri="{BB962C8B-B14F-4D97-AF65-F5344CB8AC3E}">
+        <p14:creationId xmlns:p14="http://schemas.microsoft.com/office/powerpoint/2010/main" val="4046438805"/>
       </p:ext>
     </p:extLst>
   </p:cSld>
@@ -2880,145 +3031,7 @@
       </p:grpSpPr>
       <p:sp>
         <p:nvSpPr>
-          <p:cNvPr id="140" name="Google Shape;140;g3d777708fde_0_459"/>
-          <p:cNvSpPr txBox="1"/>
-          <p:nvPr/>
-        </p:nvSpPr>
-        <p:spPr>
-          <a:xfrm>
-            <a:off x="1361589" y="1716419"/>
-            <a:ext cx="4624191" cy="288803"/>
-          </a:xfrm>
-          <a:prstGeom prst="rect">
-            <a:avLst/>
-          </a:prstGeom>
-          <a:noFill/>
-          <a:ln>
-            <a:noFill/>
-          </a:ln>
-        </p:spPr>
-        <p:txBody>
-          <a:bodyPr spcFirstLastPara="1" wrap="square" lIns="36325" tIns="36325" rIns="36325" bIns="36325" anchor="t" anchorCtr="0">
-            <a:spAutoFit/>
-          </a:bodyPr>
-          <a:lstStyle/>
-          <a:p>
-            <a:pPr marL="0" marR="0" lvl="0" indent="0" algn="ctr" rtl="0">
-              <a:lnSpc>
-                <a:spcPct val="100000"/>
-              </a:lnSpc>
-              <a:spcBef>
-                <a:spcPts val="0"/>
-              </a:spcBef>
-              <a:spcAft>
-                <a:spcPts val="0"/>
-              </a:spcAft>
-              <a:buClr>
-                <a:srgbClr val="000000"/>
-              </a:buClr>
-              <a:buSzPts val="1000"/>
-              <a:buFont typeface="Arial"/>
-              <a:buNone/>
-            </a:pPr>
-            <a:r>
-              <a:rPr lang="es-ES" b="1" i="0" u="none" strike="noStrike" cap="none" dirty="0">
-                <a:solidFill>
-                  <a:srgbClr val="FFFFFF"/>
-                </a:solidFill>
-                <a:latin typeface="Arial"/>
-                <a:ea typeface="Arial"/>
-                <a:cs typeface="Arial"/>
-                <a:sym typeface="Arial"/>
-              </a:rPr>
-              <a:t>FECHA:</a:t>
-            </a:r>
-          </a:p>
-        </p:txBody>
-      </p:sp>
-      <p:grpSp>
-        <p:nvGrpSpPr>
-          <p:cNvPr id="3" name="Group 2">
-            <a:extLst>
-              <a:ext uri="{FF2B5EF4-FFF2-40B4-BE49-F238E27FC236}">
-                <a16:creationId xmlns:a16="http://schemas.microsoft.com/office/drawing/2014/main" id="{99A25A76-CBAD-2AD3-77BD-B95654C3DA69}"/>
-              </a:ext>
-            </a:extLst>
-          </p:cNvPr>
-          <p:cNvGrpSpPr/>
-          <p:nvPr/>
-        </p:nvGrpSpPr>
-        <p:grpSpPr>
-          <a:xfrm>
-            <a:off x="1361590" y="2124239"/>
-            <a:ext cx="9594447" cy="3542914"/>
-            <a:chOff x="634050" y="2177402"/>
-            <a:chExt cx="7129930" cy="2632849"/>
-          </a:xfrm>
-        </p:grpSpPr>
-        <p:pic>
-          <p:nvPicPr>
-            <p:cNvPr id="141" name="Google Shape;141;g3d777708fde_0_459" title="2bfc51a8-3849-4a63-ba20-37e70847f06e.jpg"/>
-            <p:cNvPicPr preferRelativeResize="0"/>
-            <p:nvPr/>
-          </p:nvPicPr>
-          <p:blipFill rotWithShape="1">
-            <a:blip r:embed="rId3">
-              <a:alphaModFix/>
-            </a:blip>
-            <a:srcRect l="1057" r="1057"/>
-            <a:stretch/>
-          </p:blipFill>
-          <p:spPr>
-            <a:xfrm>
-              <a:off x="634050" y="2177403"/>
-              <a:ext cx="3436380" cy="2632848"/>
-            </a:xfrm>
-            <a:prstGeom prst="rect">
-              <a:avLst/>
-            </a:prstGeom>
-            <a:noFill/>
-            <a:ln>
-              <a:noFill/>
-            </a:ln>
-          </p:spPr>
-        </p:pic>
-        <p:pic>
-          <p:nvPicPr>
-            <p:cNvPr id="143" name="Google Shape;143;g3d777708fde_0_459" title="66770c6b-40c6-48ad-9738-1b082640cd2c.jpg"/>
-            <p:cNvPicPr preferRelativeResize="0"/>
-            <p:nvPr/>
-          </p:nvPicPr>
-          <p:blipFill rotWithShape="1">
-            <a:blip r:embed="rId4">
-              <a:alphaModFix/>
-            </a:blip>
-            <a:srcRect l="1057" r="1057"/>
-            <a:stretch/>
-          </p:blipFill>
-          <p:spPr>
-            <a:xfrm>
-              <a:off x="4327600" y="2177402"/>
-              <a:ext cx="3436380" cy="2632845"/>
-            </a:xfrm>
-            <a:prstGeom prst="rect">
-              <a:avLst/>
-            </a:prstGeom>
-            <a:noFill/>
-            <a:ln>
-              <a:noFill/>
-            </a:ln>
-          </p:spPr>
-        </p:pic>
-      </p:grpSp>
-      <p:sp>
-        <p:nvSpPr>
-          <p:cNvPr id="2" name="Google Shape;29;g3ceeff82bb2_0_39">
-            <a:extLst>
-              <a:ext uri="{FF2B5EF4-FFF2-40B4-BE49-F238E27FC236}">
-                <a16:creationId xmlns:a16="http://schemas.microsoft.com/office/drawing/2014/main" id="{6CAB27A4-0AF2-BEE6-D05C-DB41A92C8087}"/>
-              </a:ext>
-            </a:extLst>
-          </p:cNvPr>
+          <p:cNvPr id="139" name="Google Shape;139;g3d777708fde_0_459"/>
           <p:cNvSpPr txBox="1"/>
           <p:nvPr/>
         </p:nvSpPr>
@@ -3059,20 +3072,68 @@
               <a:buNone/>
             </a:pPr>
             <a:r>
-              <a:rPr lang="es-ES" sz="2200" b="1" dirty="0">
+              <a:rPr lang="es-ES" sz="2200" b="1">
                 <a:solidFill>
-                  <a:schemeClr val="bg1"/>
+                  <a:srgbClr val="FFFFFF"/>
                 </a:solidFill>
                 <a:latin typeface="Arial Black"/>
                 <a:ea typeface="Arial Black"/>
                 <a:cs typeface="Arial Black"/>
                 <a:sym typeface="Arial Black"/>
               </a:rPr>
-              <a:t>NOMBRE TIENDA</a:t>
+              <a:t>N634</a:t>
             </a:r>
-            <a:endParaRPr sz="2200" b="1" dirty="0">
+            <a:r>
+              <a:rPr lang="es-ES" sz="2200" b="1" i="0" u="none" strike="noStrike" cap="none">
+                <a:solidFill>
+                  <a:srgbClr val="FFFFFF"/>
+                </a:solidFill>
+                <a:latin typeface="Arial Black"/>
+                <a:ea typeface="Arial Black"/>
+                <a:cs typeface="Arial Black"/>
+                <a:sym typeface="Arial Black"/>
+              </a:rPr>
+              <a:t> </a:t>
+            </a:r>
+            <a:r>
+              <a:rPr lang="es-ES" sz="2200" b="1">
+                <a:solidFill>
+                  <a:srgbClr val="FFFFFF"/>
+                </a:solidFill>
+                <a:latin typeface="Arial Black"/>
+                <a:ea typeface="Arial Black"/>
+                <a:cs typeface="Arial Black"/>
+                <a:sym typeface="Arial Black"/>
+              </a:rPr>
+              <a:t>SISA</a:t>
+            </a:r>
+            <a:r>
+              <a:rPr lang="es-ES" sz="2200" b="1" i="0" u="none" strike="noStrike" cap="none">
+                <a:solidFill>
+                  <a:srgbClr val="FFFFFF"/>
+                </a:solidFill>
+                <a:latin typeface="Arial Black"/>
+                <a:ea typeface="Arial Black"/>
+                <a:cs typeface="Arial Black"/>
+                <a:sym typeface="Arial Black"/>
+              </a:rPr>
+              <a:t> - </a:t>
+            </a:r>
+            <a:r>
+              <a:rPr lang="es-ES" sz="2200" b="1">
+                <a:solidFill>
+                  <a:srgbClr val="FFFFFF"/>
+                </a:solidFill>
+                <a:latin typeface="Arial Black"/>
+                <a:ea typeface="Arial Black"/>
+                <a:cs typeface="Arial Black"/>
+                <a:sym typeface="Arial Black"/>
+              </a:rPr>
+              <a:t>AV. LO MARCOLETA N361, QUILICURA</a:t>
+            </a:r>
+            <a:endParaRPr sz="2200" b="1">
               <a:solidFill>
-                <a:schemeClr val="bg1"/>
+                <a:srgbClr val="FFFFFF"/>
               </a:solidFill>
               <a:latin typeface="Arial Black"/>
               <a:ea typeface="Arial Black"/>
@@ -3084,20 +3145,14 @@
       </p:sp>
       <p:sp>
         <p:nvSpPr>
-          <p:cNvPr id="4" name="Google Shape;140;g3d777708fde_0_459">
-            <a:extLst>
-              <a:ext uri="{FF2B5EF4-FFF2-40B4-BE49-F238E27FC236}">
-                <a16:creationId xmlns:a16="http://schemas.microsoft.com/office/drawing/2014/main" id="{6AEF1FB8-F94B-1363-A527-C85A09BEBE39}"/>
-              </a:ext>
-            </a:extLst>
-          </p:cNvPr>
+          <p:cNvPr id="140" name="Google Shape;140;g3d777708fde_0_459"/>
           <p:cNvSpPr txBox="1"/>
           <p:nvPr/>
         </p:nvSpPr>
         <p:spPr>
           <a:xfrm>
-            <a:off x="6331845" y="1716418"/>
-            <a:ext cx="4624191" cy="288803"/>
+            <a:off x="812585" y="1758950"/>
+            <a:ext cx="3022500" cy="288803"/>
           </a:xfrm>
           <a:prstGeom prst="rect">
             <a:avLst/>
@@ -3140,11 +3195,206 @@
                 <a:cs typeface="Arial"/>
                 <a:sym typeface="Arial"/>
               </a:rPr>
-              <a:t>FECHA:</a:t>
+              <a:t>FECHA: 11/03/2026</a:t>
             </a:r>
           </a:p>
         </p:txBody>
       </p:sp>
+      <p:pic>
+        <p:nvPicPr>
+          <p:cNvPr id="141" name="Google Shape;141;g3d777708fde_0_459" title="2bfc51a8-3849-4a63-ba20-37e70847f06e.jpg"/>
+          <p:cNvPicPr preferRelativeResize="0"/>
+          <p:nvPr/>
+        </p:nvPicPr>
+        <p:blipFill rotWithShape="1">
+          <a:blip r:embed="rId3">
+            <a:alphaModFix/>
+          </a:blip>
+          <a:srcRect l="1057" r="1057"/>
+          <a:stretch/>
+        </p:blipFill>
+        <p:spPr>
+          <a:xfrm>
+            <a:off x="634050" y="2177403"/>
+            <a:ext cx="3379376" cy="2589173"/>
+          </a:xfrm>
+          <a:prstGeom prst="rect">
+            <a:avLst/>
+          </a:prstGeom>
+          <a:noFill/>
+          <a:ln>
+            <a:noFill/>
+          </a:ln>
+        </p:spPr>
+      </p:pic>
+      <p:sp>
+        <p:nvSpPr>
+          <p:cNvPr id="142" name="Google Shape;142;g3d777708fde_0_459"/>
+          <p:cNvSpPr txBox="1"/>
+          <p:nvPr/>
+        </p:nvSpPr>
+        <p:spPr>
+          <a:xfrm>
+            <a:off x="4506135" y="1758950"/>
+            <a:ext cx="3022500" cy="288803"/>
+          </a:xfrm>
+          <a:prstGeom prst="rect">
+            <a:avLst/>
+          </a:prstGeom>
+          <a:noFill/>
+          <a:ln>
+            <a:noFill/>
+          </a:ln>
+        </p:spPr>
+        <p:txBody>
+          <a:bodyPr spcFirstLastPara="1" wrap="square" lIns="36325" tIns="36325" rIns="36325" bIns="36325" anchor="t" anchorCtr="0">
+            <a:spAutoFit/>
+          </a:bodyPr>
+          <a:lstStyle/>
+          <a:p>
+            <a:pPr marL="0" marR="0" lvl="0" indent="0" algn="ctr" rtl="0">
+              <a:lnSpc>
+                <a:spcPct val="100000"/>
+              </a:lnSpc>
+              <a:spcBef>
+                <a:spcPts val="0"/>
+              </a:spcBef>
+              <a:spcAft>
+                <a:spcPts val="0"/>
+              </a:spcAft>
+              <a:buClr>
+                <a:srgbClr val="000000"/>
+              </a:buClr>
+              <a:buSzPts val="1000"/>
+              <a:buFont typeface="Arial"/>
+              <a:buNone/>
+            </a:pPr>
+            <a:r>
+              <a:rPr lang="es-ES" b="1" i="0" u="none" strike="noStrike" cap="none" dirty="0">
+                <a:solidFill>
+                  <a:srgbClr val="FFFFFF"/>
+                </a:solidFill>
+                <a:latin typeface="Arial"/>
+                <a:ea typeface="Arial"/>
+                <a:cs typeface="Arial"/>
+                <a:sym typeface="Arial"/>
+              </a:rPr>
+              <a:t>FECHA: 11/02/2026</a:t>
+            </a:r>
+          </a:p>
+        </p:txBody>
+      </p:sp>
+      <p:pic>
+        <p:nvPicPr>
+          <p:cNvPr id="143" name="Google Shape;143;g3d777708fde_0_459" title="66770c6b-40c6-48ad-9738-1b082640cd2c.jpg"/>
+          <p:cNvPicPr preferRelativeResize="0"/>
+          <p:nvPr/>
+        </p:nvPicPr>
+        <p:blipFill rotWithShape="1">
+          <a:blip r:embed="rId4">
+            <a:alphaModFix/>
+          </a:blip>
+          <a:srcRect l="1057" r="1057"/>
+          <a:stretch/>
+        </p:blipFill>
+        <p:spPr>
+          <a:xfrm>
+            <a:off x="4327600" y="2177403"/>
+            <a:ext cx="3379376" cy="2589170"/>
+          </a:xfrm>
+          <a:prstGeom prst="rect">
+            <a:avLst/>
+          </a:prstGeom>
+          <a:noFill/>
+          <a:ln>
+            <a:noFill/>
+          </a:ln>
+        </p:spPr>
+      </p:pic>
+      <p:sp>
+        <p:nvSpPr>
+          <p:cNvPr id="144" name="Google Shape;144;g3d777708fde_0_459"/>
+          <p:cNvSpPr txBox="1"/>
+          <p:nvPr/>
+        </p:nvSpPr>
+        <p:spPr>
+          <a:xfrm>
+            <a:off x="8199684" y="1758950"/>
+            <a:ext cx="3022500" cy="288803"/>
+          </a:xfrm>
+          <a:prstGeom prst="rect">
+            <a:avLst/>
+          </a:prstGeom>
+          <a:noFill/>
+          <a:ln>
+            <a:noFill/>
+          </a:ln>
+        </p:spPr>
+        <p:txBody>
+          <a:bodyPr spcFirstLastPara="1" wrap="square" lIns="36325" tIns="36325" rIns="36325" bIns="36325" anchor="t" anchorCtr="0">
+            <a:spAutoFit/>
+          </a:bodyPr>
+          <a:lstStyle/>
+          <a:p>
+            <a:pPr marL="0" marR="0" lvl="0" indent="0" algn="ctr" rtl="0">
+              <a:lnSpc>
+                <a:spcPct val="100000"/>
+              </a:lnSpc>
+              <a:spcBef>
+                <a:spcPts val="0"/>
+              </a:spcBef>
+              <a:spcAft>
+                <a:spcPts val="0"/>
+              </a:spcAft>
+              <a:buClr>
+                <a:srgbClr val="000000"/>
+              </a:buClr>
+              <a:buSzPts val="1000"/>
+              <a:buFont typeface="Arial"/>
+              <a:buNone/>
+            </a:pPr>
+            <a:r>
+              <a:rPr lang="es-ES" b="1" i="0" u="none" strike="noStrike" cap="none" dirty="0">
+                <a:solidFill>
+                  <a:srgbClr val="FFFFFF"/>
+                </a:solidFill>
+                <a:latin typeface="Arial"/>
+                <a:ea typeface="Arial"/>
+                <a:cs typeface="Arial"/>
+                <a:sym typeface="Arial"/>
+              </a:rPr>
+              <a:t>FECHA: 12/03/2026</a:t>
+            </a:r>
+          </a:p>
+        </p:txBody>
+      </p:sp>
+      <p:pic>
+        <p:nvPicPr>
+          <p:cNvPr id="145" name="Google Shape;145;g3d777708fde_0_459" title="cfc4eb2b-7b52-4165-ac46-5d3817d922ec.jpg"/>
+          <p:cNvPicPr preferRelativeResize="0"/>
+          <p:nvPr/>
+        </p:nvPicPr>
+        <p:blipFill rotWithShape="1">
+          <a:blip r:embed="rId5">
+            <a:alphaModFix/>
+          </a:blip>
+          <a:srcRect l="1057" r="1057"/>
+          <a:stretch/>
+        </p:blipFill>
+        <p:spPr>
+          <a:xfrm>
+            <a:off x="8021149" y="2177403"/>
+            <a:ext cx="3379376" cy="2589173"/>
+          </a:xfrm>
+          <a:prstGeom prst="rect">
+            <a:avLst/>
+          </a:prstGeom>
+          <a:noFill/>
+          <a:ln>
+            <a:noFill/>
+          </a:ln>
+        </p:spPr>
+      </p:pic>
     </p:spTree>
     <p:extLst>
       <p:ext uri="{BB962C8B-B14F-4D97-AF65-F5344CB8AC3E}">
@@ -3163,13 +3413,7 @@
   <p:cSld>
     <p:spTree>
       <p:nvGrpSpPr>
-        <p:cNvPr id="1" name="Shape 28">
-          <a:extLst>
-            <a:ext uri="{FF2B5EF4-FFF2-40B4-BE49-F238E27FC236}">
-              <a16:creationId xmlns:a16="http://schemas.microsoft.com/office/drawing/2014/main" id="{4488B669-DCEB-ABE6-DBA0-4D004E981D2F}"/>
-            </a:ext>
-          </a:extLst>
-        </p:cNvPr>
+        <p:cNvPr id="1" name="Shape 298"/>
         <p:cNvGrpSpPr/>
         <p:nvPr/>
       </p:nvGrpSpPr>
@@ -3183,13 +3427,7 @@
       </p:grpSpPr>
       <p:sp>
         <p:nvSpPr>
-          <p:cNvPr id="29" name="Google Shape;29;g3ceeff82bb2_0_39">
-            <a:extLst>
-              <a:ext uri="{FF2B5EF4-FFF2-40B4-BE49-F238E27FC236}">
-                <a16:creationId xmlns:a16="http://schemas.microsoft.com/office/drawing/2014/main" id="{21D47742-0D05-732C-B46B-E095129588DF}"/>
-              </a:ext>
-            </a:extLst>
-          </p:cNvPr>
+          <p:cNvPr id="299" name="Google Shape;299;g395f9ca54f4_0_65"/>
           <p:cNvSpPr txBox="1"/>
           <p:nvPr/>
         </p:nvSpPr>
@@ -3230,20 +3468,68 @@
               <a:buNone/>
             </a:pPr>
             <a:r>
-              <a:rPr lang="es-ES" sz="2200" b="1" dirty="0">
+              <a:rPr lang="es-ES" sz="2200" b="1">
                 <a:solidFill>
-                  <a:schemeClr val="bg1"/>
+                  <a:srgbClr val="FFFFFF"/>
                 </a:solidFill>
                 <a:latin typeface="Arial Black"/>
                 <a:ea typeface="Arial Black"/>
                 <a:cs typeface="Arial Black"/>
                 <a:sym typeface="Arial Black"/>
               </a:rPr>
-              <a:t>NOMBRE TIENDA</a:t>
+              <a:t>N764</a:t>
             </a:r>
-            <a:endParaRPr sz="2200" b="1" dirty="0">
+            <a:r>
+              <a:rPr lang="es-ES" sz="2200" b="1" i="0" u="none" strike="noStrike" cap="none">
+                <a:solidFill>
+                  <a:srgbClr val="FFFFFF"/>
+                </a:solidFill>
+                <a:latin typeface="Arial Black"/>
+                <a:ea typeface="Arial Black"/>
+                <a:cs typeface="Arial Black"/>
+                <a:sym typeface="Arial Black"/>
+              </a:rPr>
+              <a:t> </a:t>
+            </a:r>
+            <a:r>
+              <a:rPr lang="es-ES" sz="2200" b="1">
+                <a:solidFill>
+                  <a:srgbClr val="FFFFFF"/>
+                </a:solidFill>
+                <a:latin typeface="Arial Black"/>
+                <a:ea typeface="Arial Black"/>
+                <a:cs typeface="Arial Black"/>
+                <a:sym typeface="Arial Black"/>
+              </a:rPr>
+              <a:t>SISA</a:t>
+            </a:r>
+            <a:r>
+              <a:rPr lang="es-ES" sz="2200" b="1" i="0" u="none" strike="noStrike" cap="none">
+                <a:solidFill>
+                  <a:srgbClr val="FFFFFF"/>
+                </a:solidFill>
+                <a:latin typeface="Arial Black"/>
+                <a:ea typeface="Arial Black"/>
+                <a:cs typeface="Arial Black"/>
+                <a:sym typeface="Arial Black"/>
+              </a:rPr>
+              <a:t> - </a:t>
+            </a:r>
+            <a:r>
+              <a:rPr lang="es-ES" sz="2200" b="1">
+                <a:solidFill>
+                  <a:srgbClr val="FFFFFF"/>
+                </a:solidFill>
+                <a:latin typeface="Arial Black"/>
+                <a:ea typeface="Arial Black"/>
+                <a:cs typeface="Arial Black"/>
+                <a:sym typeface="Arial Black"/>
+              </a:rPr>
+              <a:t>AV. LA FLORIDA 9385, LA FLORIDA</a:t>
+            </a:r>
+            <a:endParaRPr sz="2200" b="1">
               <a:solidFill>
-                <a:schemeClr val="bg1"/>
+                <a:srgbClr val="FFFFFF"/>
               </a:solidFill>
               <a:latin typeface="Arial Black"/>
               <a:ea typeface="Arial Black"/>
@@ -3255,20 +3541,14 @@
       </p:sp>
       <p:sp>
         <p:nvSpPr>
-          <p:cNvPr id="30" name="Google Shape;30;g3ceeff82bb2_0_39">
-            <a:extLst>
-              <a:ext uri="{FF2B5EF4-FFF2-40B4-BE49-F238E27FC236}">
-                <a16:creationId xmlns:a16="http://schemas.microsoft.com/office/drawing/2014/main" id="{6A289230-FEB4-17C3-F031-23DD48C2F70C}"/>
-              </a:ext>
-            </a:extLst>
-          </p:cNvPr>
+          <p:cNvPr id="300" name="Google Shape;300;g395f9ca54f4_0_65"/>
           <p:cNvSpPr txBox="1"/>
           <p:nvPr/>
         </p:nvSpPr>
         <p:spPr>
           <a:xfrm>
-            <a:off x="343583" y="1971332"/>
-            <a:ext cx="3611132" cy="288803"/>
+            <a:off x="812585" y="1758950"/>
+            <a:ext cx="3022500" cy="288803"/>
           </a:xfrm>
           <a:prstGeom prst="rect">
             <a:avLst/>
@@ -3311,27 +3591,48 @@
                 <a:cs typeface="Arial"/>
                 <a:sym typeface="Arial"/>
               </a:rPr>
-              <a:t>FECHA:</a:t>
+              <a:t>FECHA: 11/03/2026</a:t>
             </a:r>
           </a:p>
         </p:txBody>
       </p:sp>
+      <p:pic>
+        <p:nvPicPr>
+          <p:cNvPr id="301" name="Google Shape;301;g395f9ca54f4_0_65" title="ce333640-24c4-4896-a46e-a5736a144946.jpg"/>
+          <p:cNvPicPr preferRelativeResize="0"/>
+          <p:nvPr/>
+        </p:nvPicPr>
+        <p:blipFill rotWithShape="1">
+          <a:blip r:embed="rId3">
+            <a:alphaModFix/>
+          </a:blip>
+          <a:srcRect l="1057" r="1057"/>
+          <a:stretch/>
+        </p:blipFill>
+        <p:spPr>
+          <a:xfrm>
+            <a:off x="634050" y="2177403"/>
+            <a:ext cx="3379376" cy="2589171"/>
+          </a:xfrm>
+          <a:prstGeom prst="rect">
+            <a:avLst/>
+          </a:prstGeom>
+          <a:noFill/>
+          <a:ln>
+            <a:noFill/>
+          </a:ln>
+        </p:spPr>
+      </p:pic>
       <p:sp>
         <p:nvSpPr>
-          <p:cNvPr id="32" name="Google Shape;32;g3ceeff82bb2_0_39">
-            <a:extLst>
-              <a:ext uri="{FF2B5EF4-FFF2-40B4-BE49-F238E27FC236}">
-                <a16:creationId xmlns:a16="http://schemas.microsoft.com/office/drawing/2014/main" id="{C57D19B4-BCF8-AB4E-24DE-C98916EDEF8C}"/>
-              </a:ext>
-            </a:extLst>
-          </p:cNvPr>
+          <p:cNvPr id="302" name="Google Shape;302;g395f9ca54f4_0_65"/>
           <p:cNvSpPr txBox="1"/>
           <p:nvPr/>
         </p:nvSpPr>
         <p:spPr>
           <a:xfrm>
-            <a:off x="4290435" y="1971604"/>
-            <a:ext cx="3611132" cy="288803"/>
+            <a:off x="4506135" y="1758950"/>
+            <a:ext cx="3022500" cy="288803"/>
           </a:xfrm>
           <a:prstGeom prst="rect">
             <a:avLst/>
@@ -3374,27 +3675,48 @@
                 <a:cs typeface="Arial"/>
                 <a:sym typeface="Arial"/>
               </a:rPr>
-              <a:t>FECHA:</a:t>
+              <a:t>FECHA: 12/03/2026</a:t>
             </a:r>
           </a:p>
         </p:txBody>
       </p:sp>
+      <p:pic>
+        <p:nvPicPr>
+          <p:cNvPr id="303" name="Google Shape;303;g395f9ca54f4_0_65" title="12ac924a-589c-4913-b415-93e9f815e129.jpg"/>
+          <p:cNvPicPr preferRelativeResize="0"/>
+          <p:nvPr/>
+        </p:nvPicPr>
+        <p:blipFill rotWithShape="1">
+          <a:blip r:embed="rId4">
+            <a:alphaModFix/>
+          </a:blip>
+          <a:srcRect l="1057" r="1057"/>
+          <a:stretch/>
+        </p:blipFill>
+        <p:spPr>
+          <a:xfrm>
+            <a:off x="4327600" y="2177403"/>
+            <a:ext cx="3379376" cy="2589171"/>
+          </a:xfrm>
+          <a:prstGeom prst="rect">
+            <a:avLst/>
+          </a:prstGeom>
+          <a:noFill/>
+          <a:ln>
+            <a:noFill/>
+          </a:ln>
+        </p:spPr>
+      </p:pic>
       <p:sp>
         <p:nvSpPr>
-          <p:cNvPr id="34" name="Google Shape;34;g3ceeff82bb2_0_39">
-            <a:extLst>
-              <a:ext uri="{FF2B5EF4-FFF2-40B4-BE49-F238E27FC236}">
-                <a16:creationId xmlns:a16="http://schemas.microsoft.com/office/drawing/2014/main" id="{1EDF8CAA-6A60-C19E-19EA-604854629E2D}"/>
-              </a:ext>
-            </a:extLst>
-          </p:cNvPr>
+          <p:cNvPr id="304" name="Google Shape;304;g395f9ca54f4_0_65"/>
           <p:cNvSpPr txBox="1"/>
           <p:nvPr/>
         </p:nvSpPr>
         <p:spPr>
           <a:xfrm>
-            <a:off x="8237284" y="1971604"/>
-            <a:ext cx="3611132" cy="288803"/>
+            <a:off x="8199684" y="1758950"/>
+            <a:ext cx="3022500" cy="288803"/>
           </a:xfrm>
           <a:prstGeom prst="rect">
             <a:avLst/>
@@ -3437,135 +3759,42 @@
                 <a:cs typeface="Arial"/>
                 <a:sym typeface="Arial"/>
               </a:rPr>
-              <a:t>FECHA:</a:t>
+              <a:t>FECHA: 12/03/2026</a:t>
             </a:r>
           </a:p>
         </p:txBody>
       </p:sp>
-      <p:grpSp>
-        <p:nvGrpSpPr>
-          <p:cNvPr id="2" name="Group 1">
-            <a:extLst>
-              <a:ext uri="{FF2B5EF4-FFF2-40B4-BE49-F238E27FC236}">
-                <a16:creationId xmlns:a16="http://schemas.microsoft.com/office/drawing/2014/main" id="{2050F029-8BA6-8A78-6964-904430E33469}"/>
-              </a:ext>
-            </a:extLst>
-          </p:cNvPr>
-          <p:cNvGrpSpPr/>
+      <p:pic>
+        <p:nvPicPr>
+          <p:cNvPr id="305" name="Google Shape;305;g395f9ca54f4_0_65" title="2156bd9d-182c-49f0-834c-eac5f7186354.jpg"/>
+          <p:cNvPicPr preferRelativeResize="0"/>
           <p:nvPr/>
-        </p:nvGrpSpPr>
-        <p:grpSpPr>
+        </p:nvPicPr>
+        <p:blipFill rotWithShape="1">
+          <a:blip r:embed="rId5">
+            <a:alphaModFix/>
+          </a:blip>
+          <a:srcRect l="1057" r="1057"/>
+          <a:stretch/>
+        </p:blipFill>
+        <p:spPr>
           <a:xfrm>
-            <a:off x="343583" y="2368788"/>
-            <a:ext cx="11504834" cy="2766737"/>
-            <a:chOff x="634050" y="2177403"/>
-            <a:chExt cx="10766475" cy="2589173"/>
+            <a:off x="8021149" y="2177403"/>
+            <a:ext cx="3379376" cy="2589171"/>
           </a:xfrm>
-        </p:grpSpPr>
-        <p:pic>
-          <p:nvPicPr>
-            <p:cNvPr id="31" name="Google Shape;31;g3ceeff82bb2_0_39" title="c8d449f8-5fb3-4bb5-95ec-050b9a34d934.jpg">
-              <a:extLst>
-                <a:ext uri="{FF2B5EF4-FFF2-40B4-BE49-F238E27FC236}">
-                  <a16:creationId xmlns:a16="http://schemas.microsoft.com/office/drawing/2014/main" id="{3C2FC40A-DBFA-BD4D-9856-0C7B04D524E3}"/>
-                </a:ext>
-              </a:extLst>
-            </p:cNvPr>
-            <p:cNvPicPr preferRelativeResize="0"/>
-            <p:nvPr/>
-          </p:nvPicPr>
-          <p:blipFill rotWithShape="1">
-            <a:blip r:embed="rId3">
-              <a:alphaModFix/>
-            </a:blip>
-            <a:srcRect l="1057" r="1057"/>
-            <a:stretch/>
-          </p:blipFill>
-          <p:spPr>
-            <a:xfrm>
-              <a:off x="634050" y="2177403"/>
-              <a:ext cx="3379376" cy="2589173"/>
-            </a:xfrm>
-            <a:prstGeom prst="rect">
-              <a:avLst/>
-            </a:prstGeom>
+          <a:prstGeom prst="rect">
+            <a:avLst/>
+          </a:prstGeom>
+          <a:noFill/>
+          <a:ln>
             <a:noFill/>
-            <a:ln>
-              <a:noFill/>
-            </a:ln>
-          </p:spPr>
-        </p:pic>
-        <p:pic>
-          <p:nvPicPr>
-            <p:cNvPr id="33" name="Google Shape;33;g3ceeff82bb2_0_39" title="41fe07a4-69a5-43f8-b998-ea75b2249615.jpg">
-              <a:extLst>
-                <a:ext uri="{FF2B5EF4-FFF2-40B4-BE49-F238E27FC236}">
-                  <a16:creationId xmlns:a16="http://schemas.microsoft.com/office/drawing/2014/main" id="{1B44DA41-6D8D-6EBC-61A4-31B4801029E1}"/>
-                </a:ext>
-              </a:extLst>
-            </p:cNvPr>
-            <p:cNvPicPr preferRelativeResize="0"/>
-            <p:nvPr/>
-          </p:nvPicPr>
-          <p:blipFill rotWithShape="1">
-            <a:blip r:embed="rId4">
-              <a:alphaModFix/>
-            </a:blip>
-            <a:srcRect l="1057" r="1057"/>
-            <a:stretch/>
-          </p:blipFill>
-          <p:spPr>
-            <a:xfrm>
-              <a:off x="4327600" y="2177403"/>
-              <a:ext cx="3379376" cy="2589170"/>
-            </a:xfrm>
-            <a:prstGeom prst="rect">
-              <a:avLst/>
-            </a:prstGeom>
-            <a:noFill/>
-            <a:ln>
-              <a:noFill/>
-            </a:ln>
-          </p:spPr>
-        </p:pic>
-        <p:pic>
-          <p:nvPicPr>
-            <p:cNvPr id="35" name="Google Shape;35;g3ceeff82bb2_0_39" title="66b07255-4409-4a2d-bcec-05262e91b0ae.jpg">
-              <a:extLst>
-                <a:ext uri="{FF2B5EF4-FFF2-40B4-BE49-F238E27FC236}">
-                  <a16:creationId xmlns:a16="http://schemas.microsoft.com/office/drawing/2014/main" id="{4CA3A236-45A7-D82A-16A4-0BDDCCCB1E06}"/>
-                </a:ext>
-              </a:extLst>
-            </p:cNvPr>
-            <p:cNvPicPr preferRelativeResize="0"/>
-            <p:nvPr/>
-          </p:nvPicPr>
-          <p:blipFill rotWithShape="1">
-            <a:blip r:embed="rId5">
-              <a:alphaModFix/>
-            </a:blip>
-            <a:srcRect l="1057" r="1057"/>
-            <a:stretch/>
-          </p:blipFill>
-          <p:spPr>
-            <a:xfrm>
-              <a:off x="8021149" y="2177403"/>
-              <a:ext cx="3379376" cy="2589173"/>
-            </a:xfrm>
-            <a:prstGeom prst="rect">
-              <a:avLst/>
-            </a:prstGeom>
-            <a:noFill/>
-            <a:ln>
-              <a:noFill/>
-            </a:ln>
-          </p:spPr>
-        </p:pic>
-      </p:grpSp>
+          </a:ln>
+        </p:spPr>
+      </p:pic>
     </p:spTree>
     <p:extLst>
       <p:ext uri="{BB962C8B-B14F-4D97-AF65-F5344CB8AC3E}">
-        <p14:creationId xmlns:p14="http://schemas.microsoft.com/office/powerpoint/2010/main" val="3499098738"/>
+        <p14:creationId xmlns:p14="http://schemas.microsoft.com/office/powerpoint/2010/main" val="3857638860"/>
       </p:ext>
     </p:extLst>
   </p:cSld>
@@ -3580,13 +3809,7 @@
   <p:cSld>
     <p:spTree>
       <p:nvGrpSpPr>
-        <p:cNvPr id="1" name="Shape 28">
-          <a:extLst>
-            <a:ext uri="{FF2B5EF4-FFF2-40B4-BE49-F238E27FC236}">
-              <a16:creationId xmlns:a16="http://schemas.microsoft.com/office/drawing/2014/main" id="{F03DC983-303A-7DAE-2764-0554BEB4829E}"/>
-            </a:ext>
-          </a:extLst>
-        </p:cNvPr>
+        <p:cNvPr id="1" name="Shape 309"/>
         <p:cNvGrpSpPr/>
         <p:nvPr/>
       </p:nvGrpSpPr>
@@ -3600,13 +3823,7 @@
       </p:grpSpPr>
       <p:sp>
         <p:nvSpPr>
-          <p:cNvPr id="29" name="Google Shape;29;g3ceeff82bb2_0_39">
-            <a:extLst>
-              <a:ext uri="{FF2B5EF4-FFF2-40B4-BE49-F238E27FC236}">
-                <a16:creationId xmlns:a16="http://schemas.microsoft.com/office/drawing/2014/main" id="{8350F6D5-D46E-F66C-3146-00634993BB51}"/>
-              </a:ext>
-            </a:extLst>
-          </p:cNvPr>
+          <p:cNvPr id="310" name="Google Shape;310;g3ceeff82bb2_0_1"/>
           <p:cNvSpPr txBox="1"/>
           <p:nvPr/>
         </p:nvSpPr>
@@ -3647,20 +3864,68 @@
               <a:buNone/>
             </a:pPr>
             <a:r>
-              <a:rPr lang="es-ES" sz="2200" b="1" dirty="0">
+              <a:rPr lang="es-ES" sz="2200" b="1">
                 <a:solidFill>
-                  <a:schemeClr val="bg1"/>
+                  <a:srgbClr val="FFFFFF"/>
                 </a:solidFill>
                 <a:latin typeface="Arial Black"/>
                 <a:ea typeface="Arial Black"/>
                 <a:cs typeface="Arial Black"/>
                 <a:sym typeface="Arial Black"/>
               </a:rPr>
-              <a:t>NOMBRE TIENDA</a:t>
+              <a:t>N765</a:t>
             </a:r>
-            <a:endParaRPr sz="2200" b="1" dirty="0">
+            <a:r>
+              <a:rPr lang="es-ES" sz="2200" b="1" i="0" u="none" strike="noStrike" cap="none">
+                <a:solidFill>
+                  <a:srgbClr val="FFFFFF"/>
+                </a:solidFill>
+                <a:latin typeface="Arial Black"/>
+                <a:ea typeface="Arial Black"/>
+                <a:cs typeface="Arial Black"/>
+                <a:sym typeface="Arial Black"/>
+              </a:rPr>
+              <a:t> S</a:t>
+            </a:r>
+            <a:r>
+              <a:rPr lang="es-ES" sz="2200" b="1">
+                <a:solidFill>
+                  <a:srgbClr val="FFFFFF"/>
+                </a:solidFill>
+                <a:latin typeface="Arial Black"/>
+                <a:ea typeface="Arial Black"/>
+                <a:cs typeface="Arial Black"/>
+                <a:sym typeface="Arial Black"/>
+              </a:rPr>
+              <a:t>ISA</a:t>
+            </a:r>
+            <a:r>
+              <a:rPr lang="es-ES" sz="2200" b="1" i="0" u="none" strike="noStrike" cap="none">
+                <a:solidFill>
+                  <a:srgbClr val="FFFFFF"/>
+                </a:solidFill>
+                <a:latin typeface="Arial Black"/>
+                <a:ea typeface="Arial Black"/>
+                <a:cs typeface="Arial Black"/>
+                <a:sym typeface="Arial Black"/>
+              </a:rPr>
+              <a:t> - </a:t>
+            </a:r>
+            <a:r>
+              <a:rPr lang="es-ES" sz="2200" b="1">
+                <a:solidFill>
+                  <a:srgbClr val="FFFFFF"/>
+                </a:solidFill>
+                <a:latin typeface="Arial Black"/>
+                <a:ea typeface="Arial Black"/>
+                <a:cs typeface="Arial Black"/>
+                <a:sym typeface="Arial Black"/>
+              </a:rPr>
+              <a:t>AV. JOSE MIGUEL CARRERA 6610, LA CISTERNA</a:t>
+            </a:r>
+            <a:endParaRPr sz="2200" b="1" i="0" u="none" strike="noStrike" cap="none">
               <a:solidFill>
-                <a:schemeClr val="bg1"/>
+                <a:srgbClr val="FFFFFF"/>
               </a:solidFill>
               <a:latin typeface="Arial Black"/>
               <a:ea typeface="Arial Black"/>
@@ -3672,20 +3937,14 @@
       </p:sp>
       <p:sp>
         <p:nvSpPr>
-          <p:cNvPr id="30" name="Google Shape;30;g3ceeff82bb2_0_39">
-            <a:extLst>
-              <a:ext uri="{FF2B5EF4-FFF2-40B4-BE49-F238E27FC236}">
-                <a16:creationId xmlns:a16="http://schemas.microsoft.com/office/drawing/2014/main" id="{5D18D63B-B6FC-E531-3F47-717773D4F8AD}"/>
-              </a:ext>
-            </a:extLst>
-          </p:cNvPr>
+          <p:cNvPr id="311" name="Google Shape;311;g3ceeff82bb2_0_1"/>
           <p:cNvSpPr txBox="1"/>
           <p:nvPr/>
         </p:nvSpPr>
         <p:spPr>
           <a:xfrm>
-            <a:off x="359412" y="2158656"/>
-            <a:ext cx="2681336" cy="288803"/>
+            <a:off x="4149210" y="1524000"/>
+            <a:ext cx="3893700" cy="318036"/>
           </a:xfrm>
           <a:prstGeom prst="rect">
             <a:avLst/>
@@ -3696,7 +3955,7 @@
           </a:ln>
         </p:spPr>
         <p:txBody>
-          <a:bodyPr spcFirstLastPara="1" wrap="square" lIns="36325" tIns="36325" rIns="36325" bIns="36325" anchor="t" anchorCtr="0">
+          <a:bodyPr spcFirstLastPara="1" wrap="square" lIns="50800" tIns="50800" rIns="50800" bIns="50800" anchor="t" anchorCtr="0">
             <a:spAutoFit/>
           </a:bodyPr>
           <a:lstStyle/>
@@ -3714,7 +3973,7 @@
               <a:buClr>
                 <a:srgbClr val="000000"/>
               </a:buClr>
-              <a:buSzPts val="1000"/>
+              <a:buSzPts val="1400"/>
               <a:buFont typeface="Arial"/>
               <a:buNone/>
             </a:pPr>
@@ -3728,533 +3987,14 @@
                 <a:cs typeface="Arial"/>
                 <a:sym typeface="Arial"/>
               </a:rPr>
-              <a:t>FECHA:</a:t>
-            </a:r>
-          </a:p>
-        </p:txBody>
-      </p:sp>
-      <p:grpSp>
-        <p:nvGrpSpPr>
-          <p:cNvPr id="4" name="Group 3">
-            <a:extLst>
-              <a:ext uri="{FF2B5EF4-FFF2-40B4-BE49-F238E27FC236}">
-                <a16:creationId xmlns:a16="http://schemas.microsoft.com/office/drawing/2014/main" id="{FD693E2C-7DC6-C192-7629-CC081D271632}"/>
-              </a:ext>
-            </a:extLst>
-          </p:cNvPr>
-          <p:cNvGrpSpPr/>
-          <p:nvPr/>
-        </p:nvGrpSpPr>
-        <p:grpSpPr>
-          <a:xfrm>
-            <a:off x="359412" y="2570806"/>
-            <a:ext cx="11473176" cy="2054358"/>
-            <a:chOff x="343583" y="2368787"/>
-            <a:chExt cx="11473176" cy="2054358"/>
-          </a:xfrm>
-        </p:grpSpPr>
-        <p:pic>
-          <p:nvPicPr>
-            <p:cNvPr id="31" name="Google Shape;31;g3ceeff82bb2_0_39" title="c8d449f8-5fb3-4bb5-95ec-050b9a34d934.jpg">
-              <a:extLst>
-                <a:ext uri="{FF2B5EF4-FFF2-40B4-BE49-F238E27FC236}">
-                  <a16:creationId xmlns:a16="http://schemas.microsoft.com/office/drawing/2014/main" id="{389936F0-5E9D-9690-88FE-5ECF6564226A}"/>
-                </a:ext>
-              </a:extLst>
-            </p:cNvPr>
-            <p:cNvPicPr preferRelativeResize="0"/>
-            <p:nvPr/>
-          </p:nvPicPr>
-          <p:blipFill rotWithShape="1">
-            <a:blip r:embed="rId3">
-              <a:alphaModFix/>
-            </a:blip>
-            <a:srcRect l="1057" r="1057"/>
-            <a:stretch/>
-          </p:blipFill>
-          <p:spPr>
-            <a:xfrm>
-              <a:off x="343583" y="2368789"/>
-              <a:ext cx="2681336" cy="2054356"/>
-            </a:xfrm>
-            <a:prstGeom prst="rect">
-              <a:avLst/>
-            </a:prstGeom>
-            <a:noFill/>
-            <a:ln>
-              <a:noFill/>
-            </a:ln>
-          </p:spPr>
-        </p:pic>
-        <p:pic>
-          <p:nvPicPr>
-            <p:cNvPr id="33" name="Google Shape;33;g3ceeff82bb2_0_39" title="41fe07a4-69a5-43f8-b998-ea75b2249615.jpg">
-              <a:extLst>
-                <a:ext uri="{FF2B5EF4-FFF2-40B4-BE49-F238E27FC236}">
-                  <a16:creationId xmlns:a16="http://schemas.microsoft.com/office/drawing/2014/main" id="{212FBBE8-3F78-D327-08A6-05DF4264DF92}"/>
-                </a:ext>
-              </a:extLst>
-            </p:cNvPr>
-            <p:cNvPicPr preferRelativeResize="0"/>
-            <p:nvPr/>
-          </p:nvPicPr>
-          <p:blipFill rotWithShape="1">
-            <a:blip r:embed="rId4">
-              <a:alphaModFix/>
-            </a:blip>
-            <a:srcRect l="1057" r="1057"/>
-            <a:stretch/>
-          </p:blipFill>
-          <p:spPr>
-            <a:xfrm>
-              <a:off x="3274197" y="2368789"/>
-              <a:ext cx="2681336" cy="2054354"/>
-            </a:xfrm>
-            <a:prstGeom prst="rect">
-              <a:avLst/>
-            </a:prstGeom>
-            <a:noFill/>
-            <a:ln>
-              <a:noFill/>
-            </a:ln>
-          </p:spPr>
-        </p:pic>
-        <p:pic>
-          <p:nvPicPr>
-            <p:cNvPr id="35" name="Google Shape;35;g3ceeff82bb2_0_39" title="66b07255-4409-4a2d-bcec-05262e91b0ae.jpg">
-              <a:extLst>
-                <a:ext uri="{FF2B5EF4-FFF2-40B4-BE49-F238E27FC236}">
-                  <a16:creationId xmlns:a16="http://schemas.microsoft.com/office/drawing/2014/main" id="{06DD81F6-6AFE-E977-279D-736397202C4E}"/>
-                </a:ext>
-              </a:extLst>
-            </p:cNvPr>
-            <p:cNvPicPr preferRelativeResize="0"/>
-            <p:nvPr/>
-          </p:nvPicPr>
-          <p:blipFill rotWithShape="1">
-            <a:blip r:embed="rId5">
-              <a:alphaModFix/>
-            </a:blip>
-            <a:srcRect l="1057" r="1057"/>
-            <a:stretch/>
-          </p:blipFill>
-          <p:spPr>
-            <a:xfrm>
-              <a:off x="6204810" y="2368789"/>
-              <a:ext cx="2681336" cy="2054356"/>
-            </a:xfrm>
-            <a:prstGeom prst="rect">
-              <a:avLst/>
-            </a:prstGeom>
-            <a:noFill/>
-            <a:ln>
-              <a:noFill/>
-            </a:ln>
-          </p:spPr>
-        </p:pic>
-        <p:pic>
-          <p:nvPicPr>
-            <p:cNvPr id="3" name="Google Shape;35;g3ceeff82bb2_0_39" title="66b07255-4409-4a2d-bcec-05262e91b0ae.jpg">
-              <a:extLst>
-                <a:ext uri="{FF2B5EF4-FFF2-40B4-BE49-F238E27FC236}">
-                  <a16:creationId xmlns:a16="http://schemas.microsoft.com/office/drawing/2014/main" id="{D59C8AAE-7CCF-ABC0-9CAC-8BEE3007C45C}"/>
-                </a:ext>
-              </a:extLst>
-            </p:cNvPr>
-            <p:cNvPicPr preferRelativeResize="0"/>
-            <p:nvPr/>
-          </p:nvPicPr>
-          <p:blipFill rotWithShape="1">
-            <a:blip r:embed="rId5">
-              <a:alphaModFix/>
-            </a:blip>
-            <a:srcRect l="1057" r="1057"/>
-            <a:stretch/>
-          </p:blipFill>
-          <p:spPr>
-            <a:xfrm>
-              <a:off x="9135423" y="2368787"/>
-              <a:ext cx="2681336" cy="2054356"/>
-            </a:xfrm>
-            <a:prstGeom prst="rect">
-              <a:avLst/>
-            </a:prstGeom>
-            <a:noFill/>
-            <a:ln>
-              <a:noFill/>
-            </a:ln>
-          </p:spPr>
-        </p:pic>
-      </p:grpSp>
-      <p:sp>
-        <p:nvSpPr>
-          <p:cNvPr id="5" name="Google Shape;30;g3ceeff82bb2_0_39">
-            <a:extLst>
-              <a:ext uri="{FF2B5EF4-FFF2-40B4-BE49-F238E27FC236}">
-                <a16:creationId xmlns:a16="http://schemas.microsoft.com/office/drawing/2014/main" id="{6ADEA137-71FD-16B0-E6D7-80A64636D90C}"/>
-              </a:ext>
-            </a:extLst>
-          </p:cNvPr>
-          <p:cNvSpPr txBox="1"/>
-          <p:nvPr/>
-        </p:nvSpPr>
-        <p:spPr>
-          <a:xfrm>
-            <a:off x="3290026" y="2158655"/>
-            <a:ext cx="2681336" cy="288803"/>
-          </a:xfrm>
-          <a:prstGeom prst="rect">
-            <a:avLst/>
-          </a:prstGeom>
-          <a:noFill/>
-          <a:ln>
-            <a:noFill/>
-          </a:ln>
-        </p:spPr>
-        <p:txBody>
-          <a:bodyPr spcFirstLastPara="1" wrap="square" lIns="36325" tIns="36325" rIns="36325" bIns="36325" anchor="t" anchorCtr="0">
-            <a:spAutoFit/>
-          </a:bodyPr>
-          <a:lstStyle/>
-          <a:p>
-            <a:pPr marL="0" marR="0" lvl="0" indent="0" algn="ctr" rtl="0">
-              <a:lnSpc>
-                <a:spcPct val="100000"/>
-              </a:lnSpc>
-              <a:spcBef>
-                <a:spcPts val="0"/>
-              </a:spcBef>
-              <a:spcAft>
-                <a:spcPts val="0"/>
-              </a:spcAft>
-              <a:buClr>
-                <a:srgbClr val="000000"/>
-              </a:buClr>
-              <a:buSzPts val="1000"/>
-              <a:buFont typeface="Arial"/>
-              <a:buNone/>
-            </a:pPr>
-            <a:r>
-              <a:rPr lang="es-ES" b="1" i="0" u="none" strike="noStrike" cap="none" dirty="0">
-                <a:solidFill>
-                  <a:srgbClr val="FFFFFF"/>
-                </a:solidFill>
-                <a:latin typeface="Arial"/>
-                <a:ea typeface="Arial"/>
-                <a:cs typeface="Arial"/>
-                <a:sym typeface="Arial"/>
-              </a:rPr>
-              <a:t>FECHA:</a:t>
-            </a:r>
-          </a:p>
-        </p:txBody>
-      </p:sp>
-      <p:sp>
-        <p:nvSpPr>
-          <p:cNvPr id="6" name="Google Shape;30;g3ceeff82bb2_0_39">
-            <a:extLst>
-              <a:ext uri="{FF2B5EF4-FFF2-40B4-BE49-F238E27FC236}">
-                <a16:creationId xmlns:a16="http://schemas.microsoft.com/office/drawing/2014/main" id="{7CF5D54C-4C90-9CC1-55D5-0441293D3C8E}"/>
-              </a:ext>
-            </a:extLst>
-          </p:cNvPr>
-          <p:cNvSpPr txBox="1"/>
-          <p:nvPr/>
-        </p:nvSpPr>
-        <p:spPr>
-          <a:xfrm>
-            <a:off x="6209841" y="2158654"/>
-            <a:ext cx="2681336" cy="288803"/>
-          </a:xfrm>
-          <a:prstGeom prst="rect">
-            <a:avLst/>
-          </a:prstGeom>
-          <a:noFill/>
-          <a:ln>
-            <a:noFill/>
-          </a:ln>
-        </p:spPr>
-        <p:txBody>
-          <a:bodyPr spcFirstLastPara="1" wrap="square" lIns="36325" tIns="36325" rIns="36325" bIns="36325" anchor="t" anchorCtr="0">
-            <a:spAutoFit/>
-          </a:bodyPr>
-          <a:lstStyle/>
-          <a:p>
-            <a:pPr marL="0" marR="0" lvl="0" indent="0" algn="ctr" rtl="0">
-              <a:lnSpc>
-                <a:spcPct val="100000"/>
-              </a:lnSpc>
-              <a:spcBef>
-                <a:spcPts val="0"/>
-              </a:spcBef>
-              <a:spcAft>
-                <a:spcPts val="0"/>
-              </a:spcAft>
-              <a:buClr>
-                <a:srgbClr val="000000"/>
-              </a:buClr>
-              <a:buSzPts val="1000"/>
-              <a:buFont typeface="Arial"/>
-              <a:buNone/>
-            </a:pPr>
-            <a:r>
-              <a:rPr lang="es-ES" b="1" i="0" u="none" strike="noStrike" cap="none" dirty="0">
-                <a:solidFill>
-                  <a:srgbClr val="FFFFFF"/>
-                </a:solidFill>
-                <a:latin typeface="Arial"/>
-                <a:ea typeface="Arial"/>
-                <a:cs typeface="Arial"/>
-                <a:sym typeface="Arial"/>
-              </a:rPr>
-              <a:t>FECHA:</a:t>
-            </a:r>
-          </a:p>
-        </p:txBody>
-      </p:sp>
-      <p:sp>
-        <p:nvSpPr>
-          <p:cNvPr id="7" name="Google Shape;30;g3ceeff82bb2_0_39">
-            <a:extLst>
-              <a:ext uri="{FF2B5EF4-FFF2-40B4-BE49-F238E27FC236}">
-                <a16:creationId xmlns:a16="http://schemas.microsoft.com/office/drawing/2014/main" id="{3BBB08B7-13C5-5D45-6D55-FF4E00AD61D9}"/>
-              </a:ext>
-            </a:extLst>
-          </p:cNvPr>
-          <p:cNvSpPr txBox="1"/>
-          <p:nvPr/>
-        </p:nvSpPr>
-        <p:spPr>
-          <a:xfrm>
-            <a:off x="9129986" y="2158654"/>
-            <a:ext cx="2681336" cy="288803"/>
-          </a:xfrm>
-          <a:prstGeom prst="rect">
-            <a:avLst/>
-          </a:prstGeom>
-          <a:noFill/>
-          <a:ln>
-            <a:noFill/>
-          </a:ln>
-        </p:spPr>
-        <p:txBody>
-          <a:bodyPr spcFirstLastPara="1" wrap="square" lIns="36325" tIns="36325" rIns="36325" bIns="36325" anchor="t" anchorCtr="0">
-            <a:spAutoFit/>
-          </a:bodyPr>
-          <a:lstStyle/>
-          <a:p>
-            <a:pPr marL="0" marR="0" lvl="0" indent="0" algn="ctr" rtl="0">
-              <a:lnSpc>
-                <a:spcPct val="100000"/>
-              </a:lnSpc>
-              <a:spcBef>
-                <a:spcPts val="0"/>
-              </a:spcBef>
-              <a:spcAft>
-                <a:spcPts val="0"/>
-              </a:spcAft>
-              <a:buClr>
-                <a:srgbClr val="000000"/>
-              </a:buClr>
-              <a:buSzPts val="1000"/>
-              <a:buFont typeface="Arial"/>
-              <a:buNone/>
-            </a:pPr>
-            <a:r>
-              <a:rPr lang="es-ES" b="1" i="0" u="none" strike="noStrike" cap="none" dirty="0">
-                <a:solidFill>
-                  <a:srgbClr val="FFFFFF"/>
-                </a:solidFill>
-                <a:latin typeface="Arial"/>
-                <a:ea typeface="Arial"/>
-                <a:cs typeface="Arial"/>
-                <a:sym typeface="Arial"/>
-              </a:rPr>
-              <a:t>FECHA:</a:t>
-            </a:r>
-          </a:p>
-        </p:txBody>
-      </p:sp>
-    </p:spTree>
-    <p:extLst>
-      <p:ext uri="{BB962C8B-B14F-4D97-AF65-F5344CB8AC3E}">
-        <p14:creationId xmlns:p14="http://schemas.microsoft.com/office/powerpoint/2010/main" val="1921996156"/>
-      </p:ext>
-    </p:extLst>
-  </p:cSld>
-  <p:clrMapOvr>
-    <a:masterClrMapping/>
-  </p:clrMapOvr>
-</p:sld>
-</file>
-
-<file path=ppt/slides/slide7.xml><?xml version="1.0" encoding="utf-8"?>
-<p:sld xmlns:a="http://schemas.openxmlformats.org/drawingml/2006/main" xmlns:r="http://schemas.openxmlformats.org/officeDocument/2006/relationships" xmlns:p="http://schemas.openxmlformats.org/presentationml/2006/main">
-  <p:cSld>
-    <p:spTree>
-      <p:nvGrpSpPr>
-        <p:cNvPr id="1" name="Shape 28">
-          <a:extLst>
-            <a:ext uri="{FF2B5EF4-FFF2-40B4-BE49-F238E27FC236}">
-              <a16:creationId xmlns:a16="http://schemas.microsoft.com/office/drawing/2014/main" id="{81B44511-EA63-539C-C9AB-F2DDE0809B0D}"/>
-            </a:ext>
-          </a:extLst>
-        </p:cNvPr>
-        <p:cNvGrpSpPr/>
-        <p:nvPr/>
-      </p:nvGrpSpPr>
-      <p:grpSpPr>
-        <a:xfrm>
-          <a:off x="0" y="0"/>
-          <a:ext cx="0" cy="0"/>
-          <a:chOff x="0" y="0"/>
-          <a:chExt cx="0" cy="0"/>
-        </a:xfrm>
-      </p:grpSpPr>
-      <p:sp>
-        <p:nvSpPr>
-          <p:cNvPr id="29" name="Google Shape;29;g3ceeff82bb2_0_39">
-            <a:extLst>
-              <a:ext uri="{FF2B5EF4-FFF2-40B4-BE49-F238E27FC236}">
-                <a16:creationId xmlns:a16="http://schemas.microsoft.com/office/drawing/2014/main" id="{B16BD5FB-739A-D81C-2B2F-51CD4BC7F652}"/>
-              </a:ext>
-            </a:extLst>
-          </p:cNvPr>
-          <p:cNvSpPr txBox="1"/>
-          <p:nvPr/>
-        </p:nvSpPr>
-        <p:spPr>
-          <a:xfrm>
-            <a:off x="499380" y="263800"/>
-            <a:ext cx="10972800" cy="430800"/>
-          </a:xfrm>
-          <a:prstGeom prst="rect">
-            <a:avLst/>
-          </a:prstGeom>
-          <a:noFill/>
-          <a:ln>
-            <a:noFill/>
-          </a:ln>
-        </p:spPr>
-        <p:txBody>
-          <a:bodyPr spcFirstLastPara="1" wrap="square" lIns="91425" tIns="45700" rIns="91425" bIns="45700" anchor="t" anchorCtr="0">
-            <a:spAutoFit/>
-          </a:bodyPr>
-          <a:lstStyle/>
-          <a:p>
-            <a:pPr marL="0" marR="0" lvl="0" indent="0" algn="l" rtl="0">
-              <a:lnSpc>
-                <a:spcPct val="100000"/>
-              </a:lnSpc>
-              <a:spcBef>
-                <a:spcPts val="0"/>
-              </a:spcBef>
-              <a:spcAft>
-                <a:spcPts val="0"/>
-              </a:spcAft>
-              <a:buClr>
-                <a:srgbClr val="000000"/>
-              </a:buClr>
-              <a:buSzPts val="2400"/>
-              <a:buFont typeface="Arial"/>
-              <a:buNone/>
-            </a:pPr>
-            <a:r>
-              <a:rPr lang="es-ES" sz="2200" b="1" dirty="0">
-                <a:solidFill>
-                  <a:schemeClr val="bg1"/>
-                </a:solidFill>
-                <a:latin typeface="Arial Black"/>
-                <a:ea typeface="Arial Black"/>
-                <a:cs typeface="Arial Black"/>
-                <a:sym typeface="Arial Black"/>
-              </a:rPr>
-              <a:t>NOMBRE TIENDA</a:t>
-            </a:r>
-            <a:endParaRPr sz="2200" b="1" dirty="0">
-              <a:solidFill>
-                <a:schemeClr val="bg1"/>
-              </a:solidFill>
-              <a:latin typeface="Arial Black"/>
-              <a:ea typeface="Arial Black"/>
-              <a:cs typeface="Arial Black"/>
-              <a:sym typeface="Arial Black"/>
-            </a:endParaRPr>
-          </a:p>
-        </p:txBody>
-      </p:sp>
-      <p:sp>
-        <p:nvSpPr>
-          <p:cNvPr id="30" name="Google Shape;30;g3ceeff82bb2_0_39">
-            <a:extLst>
-              <a:ext uri="{FF2B5EF4-FFF2-40B4-BE49-F238E27FC236}">
-                <a16:creationId xmlns:a16="http://schemas.microsoft.com/office/drawing/2014/main" id="{7A8115F2-BEAD-2565-E273-AA37B13296CC}"/>
-              </a:ext>
-            </a:extLst>
-          </p:cNvPr>
-          <p:cNvSpPr txBox="1"/>
-          <p:nvPr/>
-        </p:nvSpPr>
-        <p:spPr>
-          <a:xfrm>
-            <a:off x="1624686" y="1084491"/>
-            <a:ext cx="2681336" cy="288803"/>
-          </a:xfrm>
-          <a:prstGeom prst="rect">
-            <a:avLst/>
-          </a:prstGeom>
-          <a:noFill/>
-          <a:ln>
-            <a:noFill/>
-          </a:ln>
-        </p:spPr>
-        <p:txBody>
-          <a:bodyPr spcFirstLastPara="1" wrap="square" lIns="36325" tIns="36325" rIns="36325" bIns="36325" anchor="t" anchorCtr="0">
-            <a:spAutoFit/>
-          </a:bodyPr>
-          <a:lstStyle/>
-          <a:p>
-            <a:pPr marL="0" marR="0" lvl="0" indent="0" algn="ctr" rtl="0">
-              <a:lnSpc>
-                <a:spcPct val="100000"/>
-              </a:lnSpc>
-              <a:spcBef>
-                <a:spcPts val="0"/>
-              </a:spcBef>
-              <a:spcAft>
-                <a:spcPts val="0"/>
-              </a:spcAft>
-              <a:buClr>
-                <a:srgbClr val="000000"/>
-              </a:buClr>
-              <a:buSzPts val="1000"/>
-              <a:buFont typeface="Arial"/>
-              <a:buNone/>
-            </a:pPr>
-            <a:r>
-              <a:rPr lang="es-ES" b="1" i="0" u="none" strike="noStrike" cap="none" dirty="0">
-                <a:solidFill>
-                  <a:srgbClr val="FFFFFF"/>
-                </a:solidFill>
-                <a:latin typeface="Arial"/>
-                <a:ea typeface="Arial"/>
-                <a:cs typeface="Arial"/>
-                <a:sym typeface="Arial"/>
-              </a:rPr>
-              <a:t>FECHA:</a:t>
+              <a:t>FECHA: 10/03/2026</a:t>
             </a:r>
           </a:p>
         </p:txBody>
       </p:sp>
       <p:pic>
         <p:nvPicPr>
-          <p:cNvPr id="31" name="Google Shape;31;g3ceeff82bb2_0_39" title="c8d449f8-5fb3-4bb5-95ec-050b9a34d934.jpg">
-            <a:extLst>
-              <a:ext uri="{FF2B5EF4-FFF2-40B4-BE49-F238E27FC236}">
-                <a16:creationId xmlns:a16="http://schemas.microsoft.com/office/drawing/2014/main" id="{AC4BE59C-3A98-72AE-8B34-467776345EC1}"/>
-              </a:ext>
-            </a:extLst>
-          </p:cNvPr>
+          <p:cNvPr id="312" name="Google Shape;312;g3ceeff82bb2_0_1" title="89b6b83f-fbb4-4828-9c54-24dd3cb59ae3.jpg"/>
           <p:cNvPicPr preferRelativeResize="0"/>
           <p:nvPr/>
         </p:nvPicPr>
@@ -4262,13 +4002,13 @@
           <a:blip r:embed="rId3">
             <a:alphaModFix/>
           </a:blip>
-          <a:srcRect l="1057" r="1057"/>
+          <a:srcRect l="12997" r="12989"/>
           <a:stretch/>
         </p:blipFill>
         <p:spPr>
           <a:xfrm>
-            <a:off x="1624686" y="1496643"/>
-            <a:ext cx="2681336" cy="2054356"/>
+            <a:off x="3602400" y="1887075"/>
+            <a:ext cx="5174900" cy="3933000"/>
           </a:xfrm>
           <a:prstGeom prst="rect">
             <a:avLst/>
@@ -4279,1078 +4019,10 @@
           </a:ln>
         </p:spPr>
       </p:pic>
-      <p:pic>
-        <p:nvPicPr>
-          <p:cNvPr id="33" name="Google Shape;33;g3ceeff82bb2_0_39" title="41fe07a4-69a5-43f8-b998-ea75b2249615.jpg">
-            <a:extLst>
-              <a:ext uri="{FF2B5EF4-FFF2-40B4-BE49-F238E27FC236}">
-                <a16:creationId xmlns:a16="http://schemas.microsoft.com/office/drawing/2014/main" id="{D5226E1B-A15D-5C85-2A11-93ED6A3336DB}"/>
-              </a:ext>
-            </a:extLst>
-          </p:cNvPr>
-          <p:cNvPicPr preferRelativeResize="0"/>
-          <p:nvPr/>
-        </p:nvPicPr>
-        <p:blipFill rotWithShape="1">
-          <a:blip r:embed="rId4">
-            <a:alphaModFix/>
-          </a:blip>
-          <a:srcRect l="1057" r="1057"/>
-          <a:stretch/>
-        </p:blipFill>
-        <p:spPr>
-          <a:xfrm>
-            <a:off x="4555300" y="1496643"/>
-            <a:ext cx="2681336" cy="2054354"/>
-          </a:xfrm>
-          <a:prstGeom prst="rect">
-            <a:avLst/>
-          </a:prstGeom>
-          <a:noFill/>
-          <a:ln>
-            <a:noFill/>
-          </a:ln>
-        </p:spPr>
-      </p:pic>
-      <p:pic>
-        <p:nvPicPr>
-          <p:cNvPr id="35" name="Google Shape;35;g3ceeff82bb2_0_39" title="66b07255-4409-4a2d-bcec-05262e91b0ae.jpg">
-            <a:extLst>
-              <a:ext uri="{FF2B5EF4-FFF2-40B4-BE49-F238E27FC236}">
-                <a16:creationId xmlns:a16="http://schemas.microsoft.com/office/drawing/2014/main" id="{B2BA2009-EF44-8D44-47AF-0EE2737E8DAD}"/>
-              </a:ext>
-            </a:extLst>
-          </p:cNvPr>
-          <p:cNvPicPr preferRelativeResize="0"/>
-          <p:nvPr/>
-        </p:nvPicPr>
-        <p:blipFill rotWithShape="1">
-          <a:blip r:embed="rId5">
-            <a:alphaModFix/>
-          </a:blip>
-          <a:srcRect l="1057" r="1057"/>
-          <a:stretch/>
-        </p:blipFill>
-        <p:spPr>
-          <a:xfrm>
-            <a:off x="7485913" y="1496643"/>
-            <a:ext cx="2681336" cy="2054356"/>
-          </a:xfrm>
-          <a:prstGeom prst="rect">
-            <a:avLst/>
-          </a:prstGeom>
-          <a:noFill/>
-          <a:ln>
-            <a:noFill/>
-          </a:ln>
-        </p:spPr>
-      </p:pic>
-      <p:pic>
-        <p:nvPicPr>
-          <p:cNvPr id="3" name="Google Shape;35;g3ceeff82bb2_0_39" title="66b07255-4409-4a2d-bcec-05262e91b0ae.jpg">
-            <a:extLst>
-              <a:ext uri="{FF2B5EF4-FFF2-40B4-BE49-F238E27FC236}">
-                <a16:creationId xmlns:a16="http://schemas.microsoft.com/office/drawing/2014/main" id="{1F22EF3E-8C02-F624-1D60-EF1D06A73C92}"/>
-              </a:ext>
-            </a:extLst>
-          </p:cNvPr>
-          <p:cNvPicPr preferRelativeResize="0"/>
-          <p:nvPr/>
-        </p:nvPicPr>
-        <p:blipFill rotWithShape="1">
-          <a:blip r:embed="rId5">
-            <a:alphaModFix/>
-          </a:blip>
-          <a:srcRect l="1057" r="1057"/>
-          <a:stretch/>
-        </p:blipFill>
-        <p:spPr>
-          <a:xfrm>
-            <a:off x="3080061" y="4346442"/>
-            <a:ext cx="2681336" cy="2054356"/>
-          </a:xfrm>
-          <a:prstGeom prst="rect">
-            <a:avLst/>
-          </a:prstGeom>
-          <a:noFill/>
-          <a:ln>
-            <a:noFill/>
-          </a:ln>
-        </p:spPr>
-      </p:pic>
-      <p:sp>
-        <p:nvSpPr>
-          <p:cNvPr id="5" name="Google Shape;30;g3ceeff82bb2_0_39">
-            <a:extLst>
-              <a:ext uri="{FF2B5EF4-FFF2-40B4-BE49-F238E27FC236}">
-                <a16:creationId xmlns:a16="http://schemas.microsoft.com/office/drawing/2014/main" id="{D9B1FCB1-5238-F500-36AE-C82E6CF7D5A8}"/>
-              </a:ext>
-            </a:extLst>
-          </p:cNvPr>
-          <p:cNvSpPr txBox="1"/>
-          <p:nvPr/>
-        </p:nvSpPr>
-        <p:spPr>
-          <a:xfrm>
-            <a:off x="4555300" y="1084490"/>
-            <a:ext cx="2681336" cy="288803"/>
-          </a:xfrm>
-          <a:prstGeom prst="rect">
-            <a:avLst/>
-          </a:prstGeom>
-          <a:noFill/>
-          <a:ln>
-            <a:noFill/>
-          </a:ln>
-        </p:spPr>
-        <p:txBody>
-          <a:bodyPr spcFirstLastPara="1" wrap="square" lIns="36325" tIns="36325" rIns="36325" bIns="36325" anchor="t" anchorCtr="0">
-            <a:spAutoFit/>
-          </a:bodyPr>
-          <a:lstStyle/>
-          <a:p>
-            <a:pPr marL="0" marR="0" lvl="0" indent="0" algn="ctr" rtl="0">
-              <a:lnSpc>
-                <a:spcPct val="100000"/>
-              </a:lnSpc>
-              <a:spcBef>
-                <a:spcPts val="0"/>
-              </a:spcBef>
-              <a:spcAft>
-                <a:spcPts val="0"/>
-              </a:spcAft>
-              <a:buClr>
-                <a:srgbClr val="000000"/>
-              </a:buClr>
-              <a:buSzPts val="1000"/>
-              <a:buFont typeface="Arial"/>
-              <a:buNone/>
-            </a:pPr>
-            <a:r>
-              <a:rPr lang="es-ES" b="1" i="0" u="none" strike="noStrike" cap="none" dirty="0">
-                <a:solidFill>
-                  <a:srgbClr val="FFFFFF"/>
-                </a:solidFill>
-                <a:latin typeface="Arial"/>
-                <a:ea typeface="Arial"/>
-                <a:cs typeface="Arial"/>
-                <a:sym typeface="Arial"/>
-              </a:rPr>
-              <a:t>FECHA:</a:t>
-            </a:r>
-          </a:p>
-        </p:txBody>
-      </p:sp>
-      <p:sp>
-        <p:nvSpPr>
-          <p:cNvPr id="6" name="Google Shape;30;g3ceeff82bb2_0_39">
-            <a:extLst>
-              <a:ext uri="{FF2B5EF4-FFF2-40B4-BE49-F238E27FC236}">
-                <a16:creationId xmlns:a16="http://schemas.microsoft.com/office/drawing/2014/main" id="{25E245DA-B75B-3315-2F11-251428B83082}"/>
-              </a:ext>
-            </a:extLst>
-          </p:cNvPr>
-          <p:cNvSpPr txBox="1"/>
-          <p:nvPr/>
-        </p:nvSpPr>
-        <p:spPr>
-          <a:xfrm>
-            <a:off x="7475115" y="1084489"/>
-            <a:ext cx="2681336" cy="288803"/>
-          </a:xfrm>
-          <a:prstGeom prst="rect">
-            <a:avLst/>
-          </a:prstGeom>
-          <a:noFill/>
-          <a:ln>
-            <a:noFill/>
-          </a:ln>
-        </p:spPr>
-        <p:txBody>
-          <a:bodyPr spcFirstLastPara="1" wrap="square" lIns="36325" tIns="36325" rIns="36325" bIns="36325" anchor="t" anchorCtr="0">
-            <a:spAutoFit/>
-          </a:bodyPr>
-          <a:lstStyle/>
-          <a:p>
-            <a:pPr marL="0" marR="0" lvl="0" indent="0" algn="ctr" rtl="0">
-              <a:lnSpc>
-                <a:spcPct val="100000"/>
-              </a:lnSpc>
-              <a:spcBef>
-                <a:spcPts val="0"/>
-              </a:spcBef>
-              <a:spcAft>
-                <a:spcPts val="0"/>
-              </a:spcAft>
-              <a:buClr>
-                <a:srgbClr val="000000"/>
-              </a:buClr>
-              <a:buSzPts val="1000"/>
-              <a:buFont typeface="Arial"/>
-              <a:buNone/>
-            </a:pPr>
-            <a:r>
-              <a:rPr lang="es-ES" b="1" i="0" u="none" strike="noStrike" cap="none" dirty="0">
-                <a:solidFill>
-                  <a:srgbClr val="FFFFFF"/>
-                </a:solidFill>
-                <a:latin typeface="Arial"/>
-                <a:ea typeface="Arial"/>
-                <a:cs typeface="Arial"/>
-                <a:sym typeface="Arial"/>
-              </a:rPr>
-              <a:t>FECHA:</a:t>
-            </a:r>
-          </a:p>
-        </p:txBody>
-      </p:sp>
-      <p:sp>
-        <p:nvSpPr>
-          <p:cNvPr id="7" name="Google Shape;30;g3ceeff82bb2_0_39">
-            <a:extLst>
-              <a:ext uri="{FF2B5EF4-FFF2-40B4-BE49-F238E27FC236}">
-                <a16:creationId xmlns:a16="http://schemas.microsoft.com/office/drawing/2014/main" id="{0E3087A1-016C-D98F-FF95-F58B1EB3094A}"/>
-              </a:ext>
-            </a:extLst>
-          </p:cNvPr>
-          <p:cNvSpPr txBox="1"/>
-          <p:nvPr/>
-        </p:nvSpPr>
-        <p:spPr>
-          <a:xfrm>
-            <a:off x="3058795" y="3934290"/>
-            <a:ext cx="2681336" cy="288803"/>
-          </a:xfrm>
-          <a:prstGeom prst="rect">
-            <a:avLst/>
-          </a:prstGeom>
-          <a:noFill/>
-          <a:ln>
-            <a:noFill/>
-          </a:ln>
-        </p:spPr>
-        <p:txBody>
-          <a:bodyPr spcFirstLastPara="1" wrap="square" lIns="36325" tIns="36325" rIns="36325" bIns="36325" anchor="t" anchorCtr="0">
-            <a:spAutoFit/>
-          </a:bodyPr>
-          <a:lstStyle/>
-          <a:p>
-            <a:pPr marL="0" marR="0" lvl="0" indent="0" algn="ctr" rtl="0">
-              <a:lnSpc>
-                <a:spcPct val="100000"/>
-              </a:lnSpc>
-              <a:spcBef>
-                <a:spcPts val="0"/>
-              </a:spcBef>
-              <a:spcAft>
-                <a:spcPts val="0"/>
-              </a:spcAft>
-              <a:buClr>
-                <a:srgbClr val="000000"/>
-              </a:buClr>
-              <a:buSzPts val="1000"/>
-              <a:buFont typeface="Arial"/>
-              <a:buNone/>
-            </a:pPr>
-            <a:r>
-              <a:rPr lang="es-ES" b="1" i="0" u="none" strike="noStrike" cap="none" dirty="0">
-                <a:solidFill>
-                  <a:srgbClr val="FFFFFF"/>
-                </a:solidFill>
-                <a:latin typeface="Arial"/>
-                <a:ea typeface="Arial"/>
-                <a:cs typeface="Arial"/>
-                <a:sym typeface="Arial"/>
-              </a:rPr>
-              <a:t>FECHA:</a:t>
-            </a:r>
-          </a:p>
-        </p:txBody>
-      </p:sp>
-      <p:pic>
-        <p:nvPicPr>
-          <p:cNvPr id="2" name="Google Shape;35;g3ceeff82bb2_0_39" title="66b07255-4409-4a2d-bcec-05262e91b0ae.jpg">
-            <a:extLst>
-              <a:ext uri="{FF2B5EF4-FFF2-40B4-BE49-F238E27FC236}">
-                <a16:creationId xmlns:a16="http://schemas.microsoft.com/office/drawing/2014/main" id="{A9E89C26-7176-79BE-BEBE-095D3F37ABB1}"/>
-              </a:ext>
-            </a:extLst>
-          </p:cNvPr>
-          <p:cNvPicPr preferRelativeResize="0"/>
-          <p:nvPr/>
-        </p:nvPicPr>
-        <p:blipFill rotWithShape="1">
-          <a:blip r:embed="rId5">
-            <a:alphaModFix/>
-          </a:blip>
-          <a:srcRect l="1057" r="1057"/>
-          <a:stretch/>
-        </p:blipFill>
-        <p:spPr>
-          <a:xfrm>
-            <a:off x="6018192" y="4346442"/>
-            <a:ext cx="2681336" cy="2054356"/>
-          </a:xfrm>
-          <a:prstGeom prst="rect">
-            <a:avLst/>
-          </a:prstGeom>
-          <a:noFill/>
-          <a:ln>
-            <a:noFill/>
-          </a:ln>
-        </p:spPr>
-      </p:pic>
-      <p:sp>
-        <p:nvSpPr>
-          <p:cNvPr id="8" name="Google Shape;30;g3ceeff82bb2_0_39">
-            <a:extLst>
-              <a:ext uri="{FF2B5EF4-FFF2-40B4-BE49-F238E27FC236}">
-                <a16:creationId xmlns:a16="http://schemas.microsoft.com/office/drawing/2014/main" id="{E9C4CF50-633C-E1E7-CE74-D984847B9EAF}"/>
-              </a:ext>
-            </a:extLst>
-          </p:cNvPr>
-          <p:cNvSpPr txBox="1"/>
-          <p:nvPr/>
-        </p:nvSpPr>
-        <p:spPr>
-          <a:xfrm>
-            <a:off x="5996926" y="3934290"/>
-            <a:ext cx="2681336" cy="288803"/>
-          </a:xfrm>
-          <a:prstGeom prst="rect">
-            <a:avLst/>
-          </a:prstGeom>
-          <a:noFill/>
-          <a:ln>
-            <a:noFill/>
-          </a:ln>
-        </p:spPr>
-        <p:txBody>
-          <a:bodyPr spcFirstLastPara="1" wrap="square" lIns="36325" tIns="36325" rIns="36325" bIns="36325" anchor="t" anchorCtr="0">
-            <a:spAutoFit/>
-          </a:bodyPr>
-          <a:lstStyle/>
-          <a:p>
-            <a:pPr marL="0" marR="0" lvl="0" indent="0" algn="ctr" rtl="0">
-              <a:lnSpc>
-                <a:spcPct val="100000"/>
-              </a:lnSpc>
-              <a:spcBef>
-                <a:spcPts val="0"/>
-              </a:spcBef>
-              <a:spcAft>
-                <a:spcPts val="0"/>
-              </a:spcAft>
-              <a:buClr>
-                <a:srgbClr val="000000"/>
-              </a:buClr>
-              <a:buSzPts val="1000"/>
-              <a:buFont typeface="Arial"/>
-              <a:buNone/>
-            </a:pPr>
-            <a:r>
-              <a:rPr lang="es-ES" b="1" i="0" u="none" strike="noStrike" cap="none" dirty="0">
-                <a:solidFill>
-                  <a:srgbClr val="FFFFFF"/>
-                </a:solidFill>
-                <a:latin typeface="Arial"/>
-                <a:ea typeface="Arial"/>
-                <a:cs typeface="Arial"/>
-                <a:sym typeface="Arial"/>
-              </a:rPr>
-              <a:t>FECHA:</a:t>
-            </a:r>
-          </a:p>
-        </p:txBody>
-      </p:sp>
     </p:spTree>
     <p:extLst>
       <p:ext uri="{BB962C8B-B14F-4D97-AF65-F5344CB8AC3E}">
-        <p14:creationId xmlns:p14="http://schemas.microsoft.com/office/powerpoint/2010/main" val="2548902095"/>
-      </p:ext>
-    </p:extLst>
-  </p:cSld>
-  <p:clrMapOvr>
-    <a:masterClrMapping/>
-  </p:clrMapOvr>
-</p:sld>
-</file>
-
-<file path=ppt/slides/slide8.xml><?xml version="1.0" encoding="utf-8"?>
-<p:sld xmlns:a="http://schemas.openxmlformats.org/drawingml/2006/main" xmlns:r="http://schemas.openxmlformats.org/officeDocument/2006/relationships" xmlns:p="http://schemas.openxmlformats.org/presentationml/2006/main">
-  <p:cSld>
-    <p:spTree>
-      <p:nvGrpSpPr>
-        <p:cNvPr id="1" name="Shape 28">
-          <a:extLst>
-            <a:ext uri="{FF2B5EF4-FFF2-40B4-BE49-F238E27FC236}">
-              <a16:creationId xmlns:a16="http://schemas.microsoft.com/office/drawing/2014/main" id="{1FF8E3B3-D1F2-3D09-B5B2-7EE99CA88370}"/>
-            </a:ext>
-          </a:extLst>
-        </p:cNvPr>
-        <p:cNvGrpSpPr/>
-        <p:nvPr/>
-      </p:nvGrpSpPr>
-      <p:grpSpPr>
-        <a:xfrm>
-          <a:off x="0" y="0"/>
-          <a:ext cx="0" cy="0"/>
-          <a:chOff x="0" y="0"/>
-          <a:chExt cx="0" cy="0"/>
-        </a:xfrm>
-      </p:grpSpPr>
-      <p:sp>
-        <p:nvSpPr>
-          <p:cNvPr id="29" name="Google Shape;29;g3ceeff82bb2_0_39">
-            <a:extLst>
-              <a:ext uri="{FF2B5EF4-FFF2-40B4-BE49-F238E27FC236}">
-                <a16:creationId xmlns:a16="http://schemas.microsoft.com/office/drawing/2014/main" id="{773AA8E5-0287-8F87-078E-9A27C6FC303A}"/>
-              </a:ext>
-            </a:extLst>
-          </p:cNvPr>
-          <p:cNvSpPr txBox="1"/>
-          <p:nvPr/>
-        </p:nvSpPr>
-        <p:spPr>
-          <a:xfrm>
-            <a:off x="499380" y="263800"/>
-            <a:ext cx="10972800" cy="430800"/>
-          </a:xfrm>
-          <a:prstGeom prst="rect">
-            <a:avLst/>
-          </a:prstGeom>
-          <a:noFill/>
-          <a:ln>
-            <a:noFill/>
-          </a:ln>
-        </p:spPr>
-        <p:txBody>
-          <a:bodyPr spcFirstLastPara="1" wrap="square" lIns="91425" tIns="45700" rIns="91425" bIns="45700" anchor="t" anchorCtr="0">
-            <a:spAutoFit/>
-          </a:bodyPr>
-          <a:lstStyle/>
-          <a:p>
-            <a:pPr marL="0" marR="0" lvl="0" indent="0" algn="l" rtl="0">
-              <a:lnSpc>
-                <a:spcPct val="100000"/>
-              </a:lnSpc>
-              <a:spcBef>
-                <a:spcPts val="0"/>
-              </a:spcBef>
-              <a:spcAft>
-                <a:spcPts val="0"/>
-              </a:spcAft>
-              <a:buClr>
-                <a:srgbClr val="000000"/>
-              </a:buClr>
-              <a:buSzPts val="2400"/>
-              <a:buFont typeface="Arial"/>
-              <a:buNone/>
-            </a:pPr>
-            <a:r>
-              <a:rPr lang="es-ES" sz="2200" b="1" dirty="0">
-                <a:solidFill>
-                  <a:schemeClr val="bg1"/>
-                </a:solidFill>
-                <a:latin typeface="Arial Black"/>
-                <a:ea typeface="Arial Black"/>
-                <a:cs typeface="Arial Black"/>
-                <a:sym typeface="Arial Black"/>
-              </a:rPr>
-              <a:t>NOMBRE TIENDA</a:t>
-            </a:r>
-            <a:endParaRPr sz="2200" b="1" dirty="0">
-              <a:solidFill>
-                <a:schemeClr val="bg1"/>
-              </a:solidFill>
-              <a:latin typeface="Arial Black"/>
-              <a:ea typeface="Arial Black"/>
-              <a:cs typeface="Arial Black"/>
-              <a:sym typeface="Arial Black"/>
-            </a:endParaRPr>
-          </a:p>
-        </p:txBody>
-      </p:sp>
-      <p:sp>
-        <p:nvSpPr>
-          <p:cNvPr id="30" name="Google Shape;30;g3ceeff82bb2_0_39">
-            <a:extLst>
-              <a:ext uri="{FF2B5EF4-FFF2-40B4-BE49-F238E27FC236}">
-                <a16:creationId xmlns:a16="http://schemas.microsoft.com/office/drawing/2014/main" id="{01B686E0-B98B-4441-C11B-39245DC7E14A}"/>
-              </a:ext>
-            </a:extLst>
-          </p:cNvPr>
-          <p:cNvSpPr txBox="1"/>
-          <p:nvPr/>
-        </p:nvSpPr>
-        <p:spPr>
-          <a:xfrm>
-            <a:off x="1624686" y="1084491"/>
-            <a:ext cx="2681336" cy="288803"/>
-          </a:xfrm>
-          <a:prstGeom prst="rect">
-            <a:avLst/>
-          </a:prstGeom>
-          <a:noFill/>
-          <a:ln>
-            <a:noFill/>
-          </a:ln>
-        </p:spPr>
-        <p:txBody>
-          <a:bodyPr spcFirstLastPara="1" wrap="square" lIns="36325" tIns="36325" rIns="36325" bIns="36325" anchor="t" anchorCtr="0">
-            <a:spAutoFit/>
-          </a:bodyPr>
-          <a:lstStyle/>
-          <a:p>
-            <a:pPr marL="0" marR="0" lvl="0" indent="0" algn="ctr" rtl="0">
-              <a:lnSpc>
-                <a:spcPct val="100000"/>
-              </a:lnSpc>
-              <a:spcBef>
-                <a:spcPts val="0"/>
-              </a:spcBef>
-              <a:spcAft>
-                <a:spcPts val="0"/>
-              </a:spcAft>
-              <a:buClr>
-                <a:srgbClr val="000000"/>
-              </a:buClr>
-              <a:buSzPts val="1000"/>
-              <a:buFont typeface="Arial"/>
-              <a:buNone/>
-            </a:pPr>
-            <a:r>
-              <a:rPr lang="es-ES" b="1" i="0" u="none" strike="noStrike" cap="none" dirty="0">
-                <a:solidFill>
-                  <a:srgbClr val="FFFFFF"/>
-                </a:solidFill>
-                <a:latin typeface="Arial"/>
-                <a:ea typeface="Arial"/>
-                <a:cs typeface="Arial"/>
-                <a:sym typeface="Arial"/>
-              </a:rPr>
-              <a:t>FECHA:</a:t>
-            </a:r>
-          </a:p>
-        </p:txBody>
-      </p:sp>
-      <p:pic>
-        <p:nvPicPr>
-          <p:cNvPr id="31" name="Google Shape;31;g3ceeff82bb2_0_39" title="c8d449f8-5fb3-4bb5-95ec-050b9a34d934.jpg">
-            <a:extLst>
-              <a:ext uri="{FF2B5EF4-FFF2-40B4-BE49-F238E27FC236}">
-                <a16:creationId xmlns:a16="http://schemas.microsoft.com/office/drawing/2014/main" id="{E78A91A6-2B7E-0D91-2E6F-9488B26AF54E}"/>
-              </a:ext>
-            </a:extLst>
-          </p:cNvPr>
-          <p:cNvPicPr preferRelativeResize="0"/>
-          <p:nvPr/>
-        </p:nvPicPr>
-        <p:blipFill rotWithShape="1">
-          <a:blip r:embed="rId3">
-            <a:alphaModFix/>
-          </a:blip>
-          <a:srcRect l="1057" r="1057"/>
-          <a:stretch/>
-        </p:blipFill>
-        <p:spPr>
-          <a:xfrm>
-            <a:off x="1624686" y="1496643"/>
-            <a:ext cx="2681336" cy="2054356"/>
-          </a:xfrm>
-          <a:prstGeom prst="rect">
-            <a:avLst/>
-          </a:prstGeom>
-          <a:noFill/>
-          <a:ln>
-            <a:noFill/>
-          </a:ln>
-        </p:spPr>
-      </p:pic>
-      <p:pic>
-        <p:nvPicPr>
-          <p:cNvPr id="33" name="Google Shape;33;g3ceeff82bb2_0_39" title="41fe07a4-69a5-43f8-b998-ea75b2249615.jpg">
-            <a:extLst>
-              <a:ext uri="{FF2B5EF4-FFF2-40B4-BE49-F238E27FC236}">
-                <a16:creationId xmlns:a16="http://schemas.microsoft.com/office/drawing/2014/main" id="{C4F2EC3A-074A-0D12-136C-AD78D0C5C332}"/>
-              </a:ext>
-            </a:extLst>
-          </p:cNvPr>
-          <p:cNvPicPr preferRelativeResize="0"/>
-          <p:nvPr/>
-        </p:nvPicPr>
-        <p:blipFill rotWithShape="1">
-          <a:blip r:embed="rId4">
-            <a:alphaModFix/>
-          </a:blip>
-          <a:srcRect l="1057" r="1057"/>
-          <a:stretch/>
-        </p:blipFill>
-        <p:spPr>
-          <a:xfrm>
-            <a:off x="4555300" y="1496643"/>
-            <a:ext cx="2681336" cy="2054354"/>
-          </a:xfrm>
-          <a:prstGeom prst="rect">
-            <a:avLst/>
-          </a:prstGeom>
-          <a:noFill/>
-          <a:ln>
-            <a:noFill/>
-          </a:ln>
-        </p:spPr>
-      </p:pic>
-      <p:pic>
-        <p:nvPicPr>
-          <p:cNvPr id="35" name="Google Shape;35;g3ceeff82bb2_0_39" title="66b07255-4409-4a2d-bcec-05262e91b0ae.jpg">
-            <a:extLst>
-              <a:ext uri="{FF2B5EF4-FFF2-40B4-BE49-F238E27FC236}">
-                <a16:creationId xmlns:a16="http://schemas.microsoft.com/office/drawing/2014/main" id="{373926E3-D425-09FC-9D5F-1D8A53810BE7}"/>
-              </a:ext>
-            </a:extLst>
-          </p:cNvPr>
-          <p:cNvPicPr preferRelativeResize="0"/>
-          <p:nvPr/>
-        </p:nvPicPr>
-        <p:blipFill rotWithShape="1">
-          <a:blip r:embed="rId5">
-            <a:alphaModFix/>
-          </a:blip>
-          <a:srcRect l="1057" r="1057"/>
-          <a:stretch/>
-        </p:blipFill>
-        <p:spPr>
-          <a:xfrm>
-            <a:off x="7485913" y="1496643"/>
-            <a:ext cx="2681336" cy="2054356"/>
-          </a:xfrm>
-          <a:prstGeom prst="rect">
-            <a:avLst/>
-          </a:prstGeom>
-          <a:noFill/>
-          <a:ln>
-            <a:noFill/>
-          </a:ln>
-        </p:spPr>
-      </p:pic>
-      <p:sp>
-        <p:nvSpPr>
-          <p:cNvPr id="5" name="Google Shape;30;g3ceeff82bb2_0_39">
-            <a:extLst>
-              <a:ext uri="{FF2B5EF4-FFF2-40B4-BE49-F238E27FC236}">
-                <a16:creationId xmlns:a16="http://schemas.microsoft.com/office/drawing/2014/main" id="{637CA0C7-7351-D78E-9618-0A35F2451254}"/>
-              </a:ext>
-            </a:extLst>
-          </p:cNvPr>
-          <p:cNvSpPr txBox="1"/>
-          <p:nvPr/>
-        </p:nvSpPr>
-        <p:spPr>
-          <a:xfrm>
-            <a:off x="4555300" y="1084490"/>
-            <a:ext cx="2681336" cy="288803"/>
-          </a:xfrm>
-          <a:prstGeom prst="rect">
-            <a:avLst/>
-          </a:prstGeom>
-          <a:noFill/>
-          <a:ln>
-            <a:noFill/>
-          </a:ln>
-        </p:spPr>
-        <p:txBody>
-          <a:bodyPr spcFirstLastPara="1" wrap="square" lIns="36325" tIns="36325" rIns="36325" bIns="36325" anchor="t" anchorCtr="0">
-            <a:spAutoFit/>
-          </a:bodyPr>
-          <a:lstStyle/>
-          <a:p>
-            <a:pPr marL="0" marR="0" lvl="0" indent="0" algn="ctr" rtl="0">
-              <a:lnSpc>
-                <a:spcPct val="100000"/>
-              </a:lnSpc>
-              <a:spcBef>
-                <a:spcPts val="0"/>
-              </a:spcBef>
-              <a:spcAft>
-                <a:spcPts val="0"/>
-              </a:spcAft>
-              <a:buClr>
-                <a:srgbClr val="000000"/>
-              </a:buClr>
-              <a:buSzPts val="1000"/>
-              <a:buFont typeface="Arial"/>
-              <a:buNone/>
-            </a:pPr>
-            <a:r>
-              <a:rPr lang="es-ES" b="1" i="0" u="none" strike="noStrike" cap="none" dirty="0">
-                <a:solidFill>
-                  <a:srgbClr val="FFFFFF"/>
-                </a:solidFill>
-                <a:latin typeface="Arial"/>
-                <a:ea typeface="Arial"/>
-                <a:cs typeface="Arial"/>
-                <a:sym typeface="Arial"/>
-              </a:rPr>
-              <a:t>FECHA:</a:t>
-            </a:r>
-          </a:p>
-        </p:txBody>
-      </p:sp>
-      <p:sp>
-        <p:nvSpPr>
-          <p:cNvPr id="6" name="Google Shape;30;g3ceeff82bb2_0_39">
-            <a:extLst>
-              <a:ext uri="{FF2B5EF4-FFF2-40B4-BE49-F238E27FC236}">
-                <a16:creationId xmlns:a16="http://schemas.microsoft.com/office/drawing/2014/main" id="{AE002662-0C42-16D4-6A27-A73C361C91F6}"/>
-              </a:ext>
-            </a:extLst>
-          </p:cNvPr>
-          <p:cNvSpPr txBox="1"/>
-          <p:nvPr/>
-        </p:nvSpPr>
-        <p:spPr>
-          <a:xfrm>
-            <a:off x="7475115" y="1084489"/>
-            <a:ext cx="2681336" cy="288803"/>
-          </a:xfrm>
-          <a:prstGeom prst="rect">
-            <a:avLst/>
-          </a:prstGeom>
-          <a:noFill/>
-          <a:ln>
-            <a:noFill/>
-          </a:ln>
-        </p:spPr>
-        <p:txBody>
-          <a:bodyPr spcFirstLastPara="1" wrap="square" lIns="36325" tIns="36325" rIns="36325" bIns="36325" anchor="t" anchorCtr="0">
-            <a:spAutoFit/>
-          </a:bodyPr>
-          <a:lstStyle/>
-          <a:p>
-            <a:pPr marL="0" marR="0" lvl="0" indent="0" algn="ctr" rtl="0">
-              <a:lnSpc>
-                <a:spcPct val="100000"/>
-              </a:lnSpc>
-              <a:spcBef>
-                <a:spcPts val="0"/>
-              </a:spcBef>
-              <a:spcAft>
-                <a:spcPts val="0"/>
-              </a:spcAft>
-              <a:buClr>
-                <a:srgbClr val="000000"/>
-              </a:buClr>
-              <a:buSzPts val="1000"/>
-              <a:buFont typeface="Arial"/>
-              <a:buNone/>
-            </a:pPr>
-            <a:r>
-              <a:rPr lang="es-ES" b="1" i="0" u="none" strike="noStrike" cap="none" dirty="0">
-                <a:solidFill>
-                  <a:srgbClr val="FFFFFF"/>
-                </a:solidFill>
-                <a:latin typeface="Arial"/>
-                <a:ea typeface="Arial"/>
-                <a:cs typeface="Arial"/>
-                <a:sym typeface="Arial"/>
-              </a:rPr>
-              <a:t>FECHA:</a:t>
-            </a:r>
-          </a:p>
-        </p:txBody>
-      </p:sp>
-      <p:sp>
-        <p:nvSpPr>
-          <p:cNvPr id="4" name="Google Shape;30;g3ceeff82bb2_0_39">
-            <a:extLst>
-              <a:ext uri="{FF2B5EF4-FFF2-40B4-BE49-F238E27FC236}">
-                <a16:creationId xmlns:a16="http://schemas.microsoft.com/office/drawing/2014/main" id="{945E2092-7796-2F80-E3FC-962ADC59E9A0}"/>
-              </a:ext>
-            </a:extLst>
-          </p:cNvPr>
-          <p:cNvSpPr txBox="1"/>
-          <p:nvPr/>
-        </p:nvSpPr>
-        <p:spPr>
-          <a:xfrm>
-            <a:off x="1613888" y="3831235"/>
-            <a:ext cx="2681336" cy="288803"/>
-          </a:xfrm>
-          <a:prstGeom prst="rect">
-            <a:avLst/>
-          </a:prstGeom>
-          <a:noFill/>
-          <a:ln>
-            <a:noFill/>
-          </a:ln>
-        </p:spPr>
-        <p:txBody>
-          <a:bodyPr spcFirstLastPara="1" wrap="square" lIns="36325" tIns="36325" rIns="36325" bIns="36325" anchor="t" anchorCtr="0">
-            <a:spAutoFit/>
-          </a:bodyPr>
-          <a:lstStyle/>
-          <a:p>
-            <a:pPr marL="0" marR="0" lvl="0" indent="0" algn="ctr" rtl="0">
-              <a:lnSpc>
-                <a:spcPct val="100000"/>
-              </a:lnSpc>
-              <a:spcBef>
-                <a:spcPts val="0"/>
-              </a:spcBef>
-              <a:spcAft>
-                <a:spcPts val="0"/>
-              </a:spcAft>
-              <a:buClr>
-                <a:srgbClr val="000000"/>
-              </a:buClr>
-              <a:buSzPts val="1000"/>
-              <a:buFont typeface="Arial"/>
-              <a:buNone/>
-            </a:pPr>
-            <a:r>
-              <a:rPr lang="es-ES" b="1" i="0" u="none" strike="noStrike" cap="none" dirty="0">
-                <a:solidFill>
-                  <a:srgbClr val="FFFFFF"/>
-                </a:solidFill>
-                <a:latin typeface="Arial"/>
-                <a:ea typeface="Arial"/>
-                <a:cs typeface="Arial"/>
-                <a:sym typeface="Arial"/>
-              </a:rPr>
-              <a:t>FECHA:</a:t>
-            </a:r>
-          </a:p>
-        </p:txBody>
-      </p:sp>
-      <p:pic>
-        <p:nvPicPr>
-          <p:cNvPr id="9" name="Google Shape;31;g3ceeff82bb2_0_39" title="c8d449f8-5fb3-4bb5-95ec-050b9a34d934.jpg">
-            <a:extLst>
-              <a:ext uri="{FF2B5EF4-FFF2-40B4-BE49-F238E27FC236}">
-                <a16:creationId xmlns:a16="http://schemas.microsoft.com/office/drawing/2014/main" id="{9C453C0D-8C93-230B-4AED-F339645B88C4}"/>
-              </a:ext>
-            </a:extLst>
-          </p:cNvPr>
-          <p:cNvPicPr preferRelativeResize="0"/>
-          <p:nvPr/>
-        </p:nvPicPr>
-        <p:blipFill rotWithShape="1">
-          <a:blip r:embed="rId3">
-            <a:alphaModFix/>
-          </a:blip>
-          <a:srcRect l="1057" r="1057"/>
-          <a:stretch/>
-        </p:blipFill>
-        <p:spPr>
-          <a:xfrm>
-            <a:off x="1613888" y="4243387"/>
-            <a:ext cx="2681336" cy="2054356"/>
-          </a:xfrm>
-          <a:prstGeom prst="rect">
-            <a:avLst/>
-          </a:prstGeom>
-          <a:noFill/>
-          <a:ln>
-            <a:noFill/>
-          </a:ln>
-        </p:spPr>
-      </p:pic>
-      <p:pic>
-        <p:nvPicPr>
-          <p:cNvPr id="10" name="Google Shape;33;g3ceeff82bb2_0_39" title="41fe07a4-69a5-43f8-b998-ea75b2249615.jpg">
-            <a:extLst>
-              <a:ext uri="{FF2B5EF4-FFF2-40B4-BE49-F238E27FC236}">
-                <a16:creationId xmlns:a16="http://schemas.microsoft.com/office/drawing/2014/main" id="{563E2538-3CC3-E552-B382-7EBBF7429ACA}"/>
-              </a:ext>
-            </a:extLst>
-          </p:cNvPr>
-          <p:cNvPicPr preferRelativeResize="0"/>
-          <p:nvPr/>
-        </p:nvPicPr>
-        <p:blipFill rotWithShape="1">
-          <a:blip r:embed="rId4">
-            <a:alphaModFix/>
-          </a:blip>
-          <a:srcRect l="1057" r="1057"/>
-          <a:stretch/>
-        </p:blipFill>
-        <p:spPr>
-          <a:xfrm>
-            <a:off x="4544502" y="4243387"/>
-            <a:ext cx="2681336" cy="2054354"/>
-          </a:xfrm>
-          <a:prstGeom prst="rect">
-            <a:avLst/>
-          </a:prstGeom>
-          <a:noFill/>
-          <a:ln>
-            <a:noFill/>
-          </a:ln>
-        </p:spPr>
-      </p:pic>
-      <p:pic>
-        <p:nvPicPr>
-          <p:cNvPr id="11" name="Google Shape;35;g3ceeff82bb2_0_39" title="66b07255-4409-4a2d-bcec-05262e91b0ae.jpg">
-            <a:extLst>
-              <a:ext uri="{FF2B5EF4-FFF2-40B4-BE49-F238E27FC236}">
-                <a16:creationId xmlns:a16="http://schemas.microsoft.com/office/drawing/2014/main" id="{7B624DFA-F74E-CA6D-0390-979BF1C5C133}"/>
-              </a:ext>
-            </a:extLst>
-          </p:cNvPr>
-          <p:cNvPicPr preferRelativeResize="0"/>
-          <p:nvPr/>
-        </p:nvPicPr>
-        <p:blipFill rotWithShape="1">
-          <a:blip r:embed="rId5">
-            <a:alphaModFix/>
-          </a:blip>
-          <a:srcRect l="1057" r="1057"/>
-          <a:stretch/>
-        </p:blipFill>
-        <p:spPr>
-          <a:xfrm>
-            <a:off x="7475115" y="4243387"/>
-            <a:ext cx="2681336" cy="2054356"/>
-          </a:xfrm>
-          <a:prstGeom prst="rect">
-            <a:avLst/>
-          </a:prstGeom>
-          <a:noFill/>
-          <a:ln>
-            <a:noFill/>
-          </a:ln>
-        </p:spPr>
-      </p:pic>
-      <p:sp>
-        <p:nvSpPr>
-          <p:cNvPr id="12" name="Google Shape;30;g3ceeff82bb2_0_39">
-            <a:extLst>
-              <a:ext uri="{FF2B5EF4-FFF2-40B4-BE49-F238E27FC236}">
-                <a16:creationId xmlns:a16="http://schemas.microsoft.com/office/drawing/2014/main" id="{4A77C14F-A97B-CF62-E131-B76043AF8FAA}"/>
-              </a:ext>
-            </a:extLst>
-          </p:cNvPr>
-          <p:cNvSpPr txBox="1"/>
-          <p:nvPr/>
-        </p:nvSpPr>
-        <p:spPr>
-          <a:xfrm>
-            <a:off x="4544502" y="3831234"/>
-            <a:ext cx="2681336" cy="288803"/>
-          </a:xfrm>
-          <a:prstGeom prst="rect">
-            <a:avLst/>
-          </a:prstGeom>
-          <a:noFill/>
-          <a:ln>
-            <a:noFill/>
-          </a:ln>
-        </p:spPr>
-        <p:txBody>
-          <a:bodyPr spcFirstLastPara="1" wrap="square" lIns="36325" tIns="36325" rIns="36325" bIns="36325" anchor="t" anchorCtr="0">
-            <a:spAutoFit/>
-          </a:bodyPr>
-          <a:lstStyle/>
-          <a:p>
-            <a:pPr marL="0" marR="0" lvl="0" indent="0" algn="ctr" rtl="0">
-              <a:lnSpc>
-                <a:spcPct val="100000"/>
-              </a:lnSpc>
-              <a:spcBef>
-                <a:spcPts val="0"/>
-              </a:spcBef>
-              <a:spcAft>
-                <a:spcPts val="0"/>
-              </a:spcAft>
-              <a:buClr>
-                <a:srgbClr val="000000"/>
-              </a:buClr>
-              <a:buSzPts val="1000"/>
-              <a:buFont typeface="Arial"/>
-              <a:buNone/>
-            </a:pPr>
-            <a:r>
-              <a:rPr lang="es-ES" b="1" i="0" u="none" strike="noStrike" cap="none" dirty="0">
-                <a:solidFill>
-                  <a:srgbClr val="FFFFFF"/>
-                </a:solidFill>
-                <a:latin typeface="Arial"/>
-                <a:ea typeface="Arial"/>
-                <a:cs typeface="Arial"/>
-                <a:sym typeface="Arial"/>
-              </a:rPr>
-              <a:t>FECHA:</a:t>
-            </a:r>
-          </a:p>
-        </p:txBody>
-      </p:sp>
-      <p:sp>
-        <p:nvSpPr>
-          <p:cNvPr id="13" name="Google Shape;30;g3ceeff82bb2_0_39">
-            <a:extLst>
-              <a:ext uri="{FF2B5EF4-FFF2-40B4-BE49-F238E27FC236}">
-                <a16:creationId xmlns:a16="http://schemas.microsoft.com/office/drawing/2014/main" id="{F073BB2A-D902-DE61-D915-165EA04D3793}"/>
-              </a:ext>
-            </a:extLst>
-          </p:cNvPr>
-          <p:cNvSpPr txBox="1"/>
-          <p:nvPr/>
-        </p:nvSpPr>
-        <p:spPr>
-          <a:xfrm>
-            <a:off x="7464317" y="3831233"/>
-            <a:ext cx="2681336" cy="288803"/>
-          </a:xfrm>
-          <a:prstGeom prst="rect">
-            <a:avLst/>
-          </a:prstGeom>
-          <a:noFill/>
-          <a:ln>
-            <a:noFill/>
-          </a:ln>
-        </p:spPr>
-        <p:txBody>
-          <a:bodyPr spcFirstLastPara="1" wrap="square" lIns="36325" tIns="36325" rIns="36325" bIns="36325" anchor="t" anchorCtr="0">
-            <a:spAutoFit/>
-          </a:bodyPr>
-          <a:lstStyle/>
-          <a:p>
-            <a:pPr marL="0" marR="0" lvl="0" indent="0" algn="ctr" rtl="0">
-              <a:lnSpc>
-                <a:spcPct val="100000"/>
-              </a:lnSpc>
-              <a:spcBef>
-                <a:spcPts val="0"/>
-              </a:spcBef>
-              <a:spcAft>
-                <a:spcPts val="0"/>
-              </a:spcAft>
-              <a:buClr>
-                <a:srgbClr val="000000"/>
-              </a:buClr>
-              <a:buSzPts val="1000"/>
-              <a:buFont typeface="Arial"/>
-              <a:buNone/>
-            </a:pPr>
-            <a:r>
-              <a:rPr lang="es-ES" b="1" i="0" u="none" strike="noStrike" cap="none" dirty="0">
-                <a:solidFill>
-                  <a:srgbClr val="FFFFFF"/>
-                </a:solidFill>
-                <a:latin typeface="Arial"/>
-                <a:ea typeface="Arial"/>
-                <a:cs typeface="Arial"/>
-                <a:sym typeface="Arial"/>
-              </a:rPr>
-              <a:t>FECHA:</a:t>
-            </a:r>
-          </a:p>
-        </p:txBody>
-      </p:sp>
-    </p:spTree>
-    <p:extLst>
-      <p:ext uri="{BB962C8B-B14F-4D97-AF65-F5344CB8AC3E}">
-        <p14:creationId xmlns:p14="http://schemas.microsoft.com/office/powerpoint/2010/main" val="1936137184"/>
+        <p14:creationId xmlns:p14="http://schemas.microsoft.com/office/powerpoint/2010/main" val="214102958"/>
       </p:ext>
     </p:extLst>
   </p:cSld>

</xml_diff>